<commit_message>
Point DRL PCB 1/3 LED light arrows along each LED's direction
Co-Authored-By: Claude Opus 5.5 <noreply@anthropic.com>
Claude-Session: https://claude.ai/code/session_01UaF17Au6hV57ugnQjCn17h
</commit_message>
<xml_diff>
--- a/PCB_LIGHTING_updated.pptx
+++ b/PCB_LIGHTING_updated.pptx
@@ -4839,9 +4839,9 @@
           <p:nvPr/>
         </p:nvCxnSpPr>
         <p:spPr>
-          <a:xfrm flipH="1" flipV="1">
-            <a:off x="4646855" y="1624763"/>
-            <a:ext cx="103453" cy="103453"/>
+          <a:xfrm flipV="1">
+            <a:off x="4750308" y="1624763"/>
+            <a:ext cx="103452" cy="103453"/>
           </a:xfrm>
           <a:prstGeom prst="line">
             <a:avLst/>
@@ -4861,9 +4861,9 @@
           <p:nvPr/>
         </p:nvCxnSpPr>
         <p:spPr>
-          <a:xfrm flipH="1" flipV="1">
-            <a:off x="4747439" y="1624763"/>
-            <a:ext cx="103453" cy="103453"/>
+          <a:xfrm flipV="1">
+            <a:off x="4850892" y="1624763"/>
+            <a:ext cx="103452" cy="103453"/>
           </a:xfrm>
           <a:prstGeom prst="line">
             <a:avLst/>
@@ -5001,9 +5001,9 @@
           <p:nvPr/>
         </p:nvCxnSpPr>
         <p:spPr>
-          <a:xfrm flipH="1" flipV="1">
-            <a:off x="5012615" y="1624763"/>
-            <a:ext cx="103453" cy="103453"/>
+          <a:xfrm flipV="1">
+            <a:off x="5116068" y="1624763"/>
+            <a:ext cx="103452" cy="103453"/>
           </a:xfrm>
           <a:prstGeom prst="line">
             <a:avLst/>
@@ -5023,9 +5023,9 @@
           <p:nvPr/>
         </p:nvCxnSpPr>
         <p:spPr>
-          <a:xfrm flipH="1" flipV="1">
-            <a:off x="5113199" y="1624763"/>
-            <a:ext cx="103453" cy="103453"/>
+          <a:xfrm flipV="1">
+            <a:off x="5216652" y="1624763"/>
+            <a:ext cx="103452" cy="103453"/>
           </a:xfrm>
           <a:prstGeom prst="line">
             <a:avLst/>
@@ -5163,9 +5163,9 @@
           <p:nvPr/>
         </p:nvCxnSpPr>
         <p:spPr>
-          <a:xfrm flipH="1" flipV="1">
-            <a:off x="5378375" y="1624763"/>
-            <a:ext cx="103453" cy="103453"/>
+          <a:xfrm flipV="1">
+            <a:off x="5481828" y="1624763"/>
+            <a:ext cx="103452" cy="103453"/>
           </a:xfrm>
           <a:prstGeom prst="line">
             <a:avLst/>
@@ -5185,9 +5185,9 @@
           <p:nvPr/>
         </p:nvCxnSpPr>
         <p:spPr>
-          <a:xfrm flipH="1" flipV="1">
-            <a:off x="5478959" y="1624763"/>
-            <a:ext cx="103453" cy="103453"/>
+          <a:xfrm flipV="1">
+            <a:off x="5582412" y="1624763"/>
+            <a:ext cx="103452" cy="103453"/>
           </a:xfrm>
           <a:prstGeom prst="line">
             <a:avLst/>
@@ -5325,9 +5325,9 @@
           <p:nvPr/>
         </p:nvCxnSpPr>
         <p:spPr>
-          <a:xfrm flipH="1" flipV="1">
-            <a:off x="5744135" y="1624763"/>
-            <a:ext cx="103453" cy="103453"/>
+          <a:xfrm flipV="1">
+            <a:off x="5847588" y="1624763"/>
+            <a:ext cx="103452" cy="103453"/>
           </a:xfrm>
           <a:prstGeom prst="line">
             <a:avLst/>
@@ -5347,9 +5347,9 @@
           <p:nvPr/>
         </p:nvCxnSpPr>
         <p:spPr>
-          <a:xfrm flipH="1" flipV="1">
-            <a:off x="5844719" y="1624763"/>
-            <a:ext cx="103453" cy="103453"/>
+          <a:xfrm flipV="1">
+            <a:off x="5948172" y="1624763"/>
+            <a:ext cx="103452" cy="103453"/>
           </a:xfrm>
           <a:prstGeom prst="line">
             <a:avLst/>
@@ -5487,9 +5487,9 @@
           <p:nvPr/>
         </p:nvCxnSpPr>
         <p:spPr>
-          <a:xfrm flipH="1" flipV="1">
-            <a:off x="6109895" y="1624763"/>
-            <a:ext cx="103453" cy="103453"/>
+          <a:xfrm flipV="1">
+            <a:off x="6213348" y="1624763"/>
+            <a:ext cx="103452" cy="103453"/>
           </a:xfrm>
           <a:prstGeom prst="line">
             <a:avLst/>
@@ -5509,9 +5509,9 @@
           <p:nvPr/>
         </p:nvCxnSpPr>
         <p:spPr>
-          <a:xfrm flipH="1" flipV="1">
-            <a:off x="6210479" y="1624763"/>
-            <a:ext cx="103452" cy="103453"/>
+          <a:xfrm flipV="1">
+            <a:off x="6313931" y="1624763"/>
+            <a:ext cx="103453" cy="103453"/>
           </a:xfrm>
           <a:prstGeom prst="line">
             <a:avLst/>
@@ -5649,9 +5649,9 @@
           <p:nvPr/>
         </p:nvCxnSpPr>
         <p:spPr>
-          <a:xfrm flipH="1" flipV="1">
-            <a:off x="6475655" y="1624763"/>
-            <a:ext cx="103453" cy="103453"/>
+          <a:xfrm flipV="1">
+            <a:off x="6579108" y="1624763"/>
+            <a:ext cx="103452" cy="103453"/>
           </a:xfrm>
           <a:prstGeom prst="line">
             <a:avLst/>
@@ -5671,9 +5671,9 @@
           <p:nvPr/>
         </p:nvCxnSpPr>
         <p:spPr>
-          <a:xfrm flipH="1" flipV="1">
-            <a:off x="6576239" y="1624763"/>
-            <a:ext cx="103453" cy="103453"/>
+          <a:xfrm flipV="1">
+            <a:off x="6679692" y="1624763"/>
+            <a:ext cx="103452" cy="103453"/>
           </a:xfrm>
           <a:prstGeom prst="line">
             <a:avLst/>
@@ -5811,9 +5811,9 @@
           <p:nvPr/>
         </p:nvCxnSpPr>
         <p:spPr>
-          <a:xfrm flipH="1" flipV="1">
-            <a:off x="6841415" y="1624763"/>
-            <a:ext cx="103453" cy="103453"/>
+          <a:xfrm flipV="1">
+            <a:off x="6944868" y="1624763"/>
+            <a:ext cx="103452" cy="103453"/>
           </a:xfrm>
           <a:prstGeom prst="line">
             <a:avLst/>
@@ -5833,9 +5833,9 @@
           <p:nvPr/>
         </p:nvCxnSpPr>
         <p:spPr>
-          <a:xfrm flipH="1" flipV="1">
-            <a:off x="6941999" y="1624763"/>
-            <a:ext cx="103453" cy="103453"/>
+          <a:xfrm flipV="1">
+            <a:off x="7045452" y="1624763"/>
+            <a:ext cx="103452" cy="103453"/>
           </a:xfrm>
           <a:prstGeom prst="line">
             <a:avLst/>
@@ -5973,9 +5973,9 @@
           <p:nvPr/>
         </p:nvCxnSpPr>
         <p:spPr>
-          <a:xfrm flipH="1" flipV="1">
-            <a:off x="7207175" y="1624763"/>
-            <a:ext cx="103453" cy="103453"/>
+          <a:xfrm flipV="1">
+            <a:off x="7310628" y="1624763"/>
+            <a:ext cx="103452" cy="103453"/>
           </a:xfrm>
           <a:prstGeom prst="line">
             <a:avLst/>
@@ -5995,9 +5995,9 @@
           <p:nvPr/>
         </p:nvCxnSpPr>
         <p:spPr>
-          <a:xfrm flipH="1" flipV="1">
-            <a:off x="7307759" y="1624763"/>
-            <a:ext cx="103453" cy="103453"/>
+          <a:xfrm flipV="1">
+            <a:off x="7411212" y="1624763"/>
+            <a:ext cx="103452" cy="103453"/>
           </a:xfrm>
           <a:prstGeom prst="line">
             <a:avLst/>
@@ -7431,9 +7431,9 @@
           <p:nvPr/>
         </p:nvCxnSpPr>
         <p:spPr>
-          <a:xfrm>
-            <a:off x="7411212" y="5769864"/>
-            <a:ext cx="103452" cy="103452"/>
+          <a:xfrm flipH="1">
+            <a:off x="7307759" y="5769864"/>
+            <a:ext cx="103453" cy="103452"/>
           </a:xfrm>
           <a:prstGeom prst="line">
             <a:avLst/>
@@ -7453,9 +7453,9 @@
           <p:nvPr/>
         </p:nvCxnSpPr>
         <p:spPr>
-          <a:xfrm>
-            <a:off x="7310628" y="5769864"/>
-            <a:ext cx="103452" cy="103452"/>
+          <a:xfrm flipH="1">
+            <a:off x="7207175" y="5769864"/>
+            <a:ext cx="103453" cy="103452"/>
           </a:xfrm>
           <a:prstGeom prst="line">
             <a:avLst/>
@@ -7593,9 +7593,9 @@
           <p:nvPr/>
         </p:nvCxnSpPr>
         <p:spPr>
-          <a:xfrm>
-            <a:off x="7045452" y="5769864"/>
-            <a:ext cx="103452" cy="103452"/>
+          <a:xfrm flipH="1">
+            <a:off x="6941999" y="5769864"/>
+            <a:ext cx="103453" cy="103452"/>
           </a:xfrm>
           <a:prstGeom prst="line">
             <a:avLst/>
@@ -7615,9 +7615,9 @@
           <p:nvPr/>
         </p:nvCxnSpPr>
         <p:spPr>
-          <a:xfrm>
-            <a:off x="6944868" y="5769864"/>
-            <a:ext cx="103452" cy="103452"/>
+          <a:xfrm flipH="1">
+            <a:off x="6841415" y="5769864"/>
+            <a:ext cx="103453" cy="103452"/>
           </a:xfrm>
           <a:prstGeom prst="line">
             <a:avLst/>
@@ -7755,9 +7755,9 @@
           <p:nvPr/>
         </p:nvCxnSpPr>
         <p:spPr>
-          <a:xfrm>
-            <a:off x="6679692" y="5769864"/>
-            <a:ext cx="103452" cy="103452"/>
+          <a:xfrm flipH="1">
+            <a:off x="6576239" y="5769864"/>
+            <a:ext cx="103453" cy="103452"/>
           </a:xfrm>
           <a:prstGeom prst="line">
             <a:avLst/>
@@ -7777,9 +7777,9 @@
           <p:nvPr/>
         </p:nvCxnSpPr>
         <p:spPr>
-          <a:xfrm>
-            <a:off x="6579108" y="5769864"/>
-            <a:ext cx="103452" cy="103452"/>
+          <a:xfrm flipH="1">
+            <a:off x="6475655" y="5769864"/>
+            <a:ext cx="103453" cy="103452"/>
           </a:xfrm>
           <a:prstGeom prst="line">
             <a:avLst/>
@@ -7917,9 +7917,9 @@
           <p:nvPr/>
         </p:nvCxnSpPr>
         <p:spPr>
-          <a:xfrm>
-            <a:off x="6313931" y="5769864"/>
-            <a:ext cx="103453" cy="103452"/>
+          <a:xfrm flipH="1">
+            <a:off x="6210479" y="5769864"/>
+            <a:ext cx="103452" cy="103452"/>
           </a:xfrm>
           <a:prstGeom prst="line">
             <a:avLst/>
@@ -7939,9 +7939,9 @@
           <p:nvPr/>
         </p:nvCxnSpPr>
         <p:spPr>
-          <a:xfrm>
-            <a:off x="6213348" y="5769864"/>
-            <a:ext cx="103452" cy="103452"/>
+          <a:xfrm flipH="1">
+            <a:off x="6109895" y="5769864"/>
+            <a:ext cx="103453" cy="103452"/>
           </a:xfrm>
           <a:prstGeom prst="line">
             <a:avLst/>
@@ -8079,9 +8079,9 @@
           <p:nvPr/>
         </p:nvCxnSpPr>
         <p:spPr>
-          <a:xfrm>
-            <a:off x="5948172" y="5769864"/>
-            <a:ext cx="103452" cy="103452"/>
+          <a:xfrm flipH="1">
+            <a:off x="5844719" y="5769864"/>
+            <a:ext cx="103453" cy="103452"/>
           </a:xfrm>
           <a:prstGeom prst="line">
             <a:avLst/>
@@ -8101,9 +8101,9 @@
           <p:nvPr/>
         </p:nvCxnSpPr>
         <p:spPr>
-          <a:xfrm>
-            <a:off x="5847588" y="5769864"/>
-            <a:ext cx="103452" cy="103452"/>
+          <a:xfrm flipH="1">
+            <a:off x="5744135" y="5769864"/>
+            <a:ext cx="103453" cy="103452"/>
           </a:xfrm>
           <a:prstGeom prst="line">
             <a:avLst/>
@@ -8241,9 +8241,9 @@
           <p:nvPr/>
         </p:nvCxnSpPr>
         <p:spPr>
-          <a:xfrm>
-            <a:off x="5582412" y="5769864"/>
-            <a:ext cx="103452" cy="103452"/>
+          <a:xfrm flipH="1">
+            <a:off x="5478959" y="5769864"/>
+            <a:ext cx="103453" cy="103452"/>
           </a:xfrm>
           <a:prstGeom prst="line">
             <a:avLst/>
@@ -8263,9 +8263,9 @@
           <p:nvPr/>
         </p:nvCxnSpPr>
         <p:spPr>
-          <a:xfrm>
-            <a:off x="5481828" y="5769864"/>
-            <a:ext cx="103452" cy="103452"/>
+          <a:xfrm flipH="1">
+            <a:off x="5378375" y="5769864"/>
+            <a:ext cx="103453" cy="103452"/>
           </a:xfrm>
           <a:prstGeom prst="line">
             <a:avLst/>
@@ -8403,9 +8403,9 @@
           <p:nvPr/>
         </p:nvCxnSpPr>
         <p:spPr>
-          <a:xfrm>
-            <a:off x="5216652" y="5769864"/>
-            <a:ext cx="103452" cy="103452"/>
+          <a:xfrm flipH="1">
+            <a:off x="5113199" y="5769864"/>
+            <a:ext cx="103453" cy="103452"/>
           </a:xfrm>
           <a:prstGeom prst="line">
             <a:avLst/>
@@ -8425,9 +8425,9 @@
           <p:nvPr/>
         </p:nvCxnSpPr>
         <p:spPr>
-          <a:xfrm>
-            <a:off x="5116068" y="5769864"/>
-            <a:ext cx="103452" cy="103452"/>
+          <a:xfrm flipH="1">
+            <a:off x="5012615" y="5769864"/>
+            <a:ext cx="103453" cy="103452"/>
           </a:xfrm>
           <a:prstGeom prst="line">
             <a:avLst/>
@@ -8565,9 +8565,9 @@
           <p:nvPr/>
         </p:nvCxnSpPr>
         <p:spPr>
-          <a:xfrm>
-            <a:off x="4850892" y="5769864"/>
-            <a:ext cx="103452" cy="103452"/>
+          <a:xfrm flipH="1">
+            <a:off x="4747439" y="5769864"/>
+            <a:ext cx="103453" cy="103452"/>
           </a:xfrm>
           <a:prstGeom prst="line">
             <a:avLst/>
@@ -8587,9 +8587,9 @@
           <p:nvPr/>
         </p:nvCxnSpPr>
         <p:spPr>
-          <a:xfrm>
-            <a:off x="4750308" y="5769864"/>
-            <a:ext cx="103452" cy="103452"/>
+          <a:xfrm flipH="1">
+            <a:off x="4646855" y="5769864"/>
+            <a:ext cx="103453" cy="103452"/>
           </a:xfrm>
           <a:prstGeom prst="line">
             <a:avLst/>
@@ -9422,9 +9422,9 @@
           <p:nvPr/>
         </p:nvCxnSpPr>
         <p:spPr>
-          <a:xfrm flipH="1" flipV="1">
-            <a:off x="714935" y="4688003"/>
-            <a:ext cx="103452" cy="103452"/>
+          <a:xfrm flipV="1">
+            <a:off x="818387" y="4688003"/>
+            <a:ext cx="103453" cy="103452"/>
           </a:xfrm>
           <a:prstGeom prst="line">
             <a:avLst/>
@@ -9444,9 +9444,9 @@
           <p:nvPr/>
         </p:nvCxnSpPr>
         <p:spPr>
-          <a:xfrm flipH="1" flipV="1">
-            <a:off x="815519" y="4688003"/>
-            <a:ext cx="103452" cy="103452"/>
+          <a:xfrm flipV="1">
+            <a:off x="918971" y="4688003"/>
+            <a:ext cx="103453" cy="103452"/>
           </a:xfrm>
           <a:prstGeom prst="line">
             <a:avLst/>

</xml_diff>

<commit_message>
Add slide 4: 3-PCB vs single C-shape PCB comparison with recommendation
Co-Authored-By: Claude Opus 5.5 <noreply@anthropic.com>
Claude-Session: https://claude.ai/code/session_01UaF17Au6hV57ugnQjCn17h
</commit_message>
<xml_diff>
--- a/PCB_LIGHTING_updated.pptx
+++ b/PCB_LIGHTING_updated.pptx
@@ -8,6 +8,7 @@
     <p:sldId id="256" r:id="rId2"/>
     <p:sldId id="257" r:id="rId3"/>
     <p:sldId id="258" r:id="rId8"/>
+    <p:sldId id="259" r:id="rId9"/>
   </p:sldIdLst>
   <p:sldSz cx="12192000" cy="6858000"/>
   <p:notesSz cx="6858000" cy="9144000"/>
@@ -10414,6 +10415,3517 @@
                 <a:latin typeface="Calibri"/>
               </a:rPr>
               <a:t>ESD ±8 kV / ±15 kV</a:t>
+            </a:r>
+          </a:p>
+        </p:txBody>
+      </p:sp>
+    </p:spTree>
+  </p:cSld>
+  <p:clrMapOvr>
+    <a:masterClrMapping/>
+  </p:clrMapOvr>
+</p:sld>
+</file>
+
+<file path=ppt/slides/slide4.xml><?xml version="1.0" encoding="utf-8"?>
+<p:sld xmlns:a="http://schemas.openxmlformats.org/drawingml/2006/main" xmlns:p="http://schemas.openxmlformats.org/presentationml/2006/main" xmlns:r="http://schemas.openxmlformats.org/officeDocument/2006/relationships">
+  <p:cSld>
+    <p:bg>
+      <p:bgPr>
+        <a:solidFill>
+          <a:srgbClr val="0E1621"/>
+        </a:solidFill>
+        <a:effectLst/>
+      </p:bgPr>
+    </p:bg>
+    <p:spTree>
+      <p:nvGrpSpPr>
+        <p:cNvPr id="1" name=""/>
+        <p:cNvGrpSpPr/>
+        <p:nvPr/>
+      </p:nvGrpSpPr>
+      <p:grpSpPr/>
+      <p:sp>
+        <p:nvSpPr>
+          <p:cNvPr id="2" name="TextBox 1"/>
+          <p:cNvSpPr txBox="1"/>
+          <p:nvPr/>
+        </p:nvSpPr>
+        <p:spPr>
+          <a:xfrm>
+            <a:off x="457200" y="292608"/>
+            <a:ext cx="11247120" cy="548640"/>
+          </a:xfrm>
+          <a:prstGeom prst="rect">
+            <a:avLst/>
+          </a:prstGeom>
+          <a:noFill/>
+        </p:spPr>
+        <p:txBody>
+          <a:bodyPr wrap="square" lIns="0" rIns="0" tIns="0" bIns="0" anchor="t">
+            <a:spAutoFit/>
+          </a:bodyPr>
+          <a:lstStyle/>
+          <a:p>
+            <a:pPr algn="l"/>
+            <a:r>
+              <a:rPr sz="3000" b="1" i="0">
+                <a:solidFill>
+                  <a:srgbClr val="EAF0F6"/>
+                </a:solidFill>
+                <a:latin typeface="Calibri"/>
+              </a:rPr>
+              <a:t>3-PCB C-Shape vs Single C-Shape PCB</a:t>
+            </a:r>
+          </a:p>
+        </p:txBody>
+      </p:sp>
+      <p:sp>
+        <p:nvSpPr>
+          <p:cNvPr id="3" name="TextBox 2"/>
+          <p:cNvSpPr txBox="1"/>
+          <p:nvPr/>
+        </p:nvSpPr>
+        <p:spPr>
+          <a:xfrm>
+            <a:off x="457200" y="841248"/>
+            <a:ext cx="11247120" cy="320040"/>
+          </a:xfrm>
+          <a:prstGeom prst="rect">
+            <a:avLst/>
+          </a:prstGeom>
+          <a:noFill/>
+        </p:spPr>
+        <p:txBody>
+          <a:bodyPr wrap="square" lIns="0" rIns="0" tIns="0" bIns="0" anchor="t">
+            <a:spAutoFit/>
+          </a:bodyPr>
+          <a:lstStyle/>
+          <a:p>
+            <a:pPr algn="l"/>
+            <a:r>
+              <a:rPr sz="1300" b="0" i="0">
+                <a:solidFill>
+                  <a:srgbClr val="9FB0C3"/>
+                </a:solidFill>
+                <a:latin typeface="Calibri"/>
+              </a:rPr>
+              <a:t>The 10 most relevant parameters for EMC, reliability and manufacturing  (★ = additional technical point)</a:t>
+            </a:r>
+          </a:p>
+        </p:txBody>
+      </p:sp>
+      <p:sp>
+        <p:nvSpPr>
+          <p:cNvPr id="4" name="Rectangle 3"/>
+          <p:cNvSpPr/>
+          <p:nvPr/>
+        </p:nvSpPr>
+        <p:spPr>
+          <a:xfrm>
+            <a:off x="457200" y="1280160"/>
+            <a:ext cx="11274552" cy="475488"/>
+          </a:xfrm>
+          <a:prstGeom prst="rect">
+            <a:avLst/>
+          </a:prstGeom>
+          <a:solidFill>
+            <a:srgbClr val="1D2B3B"/>
+          </a:solidFill>
+          <a:ln>
+            <a:noFill/>
+          </a:ln>
+        </p:spPr>
+        <p:txBody>
+          <a:bodyPr rtlCol="0" anchor="ctr"/>
+          <a:lstStyle/>
+          <a:p>
+            <a:pPr algn="ctr"/>
+          </a:p>
+        </p:txBody>
+      </p:sp>
+      <p:sp>
+        <p:nvSpPr>
+          <p:cNvPr id="5" name="Rectangle 4"/>
+          <p:cNvSpPr/>
+          <p:nvPr/>
+        </p:nvSpPr>
+        <p:spPr>
+          <a:xfrm>
+            <a:off x="7470648" y="1280160"/>
+            <a:ext cx="4261104" cy="475488"/>
+          </a:xfrm>
+          <a:prstGeom prst="rect">
+            <a:avLst/>
+          </a:prstGeom>
+          <a:solidFill>
+            <a:srgbClr val="1E5C3F"/>
+          </a:solidFill>
+          <a:ln>
+            <a:noFill/>
+          </a:ln>
+        </p:spPr>
+        <p:txBody>
+          <a:bodyPr rtlCol="0" anchor="ctr"/>
+          <a:lstStyle/>
+          <a:p>
+            <a:pPr algn="ctr"/>
+          </a:p>
+        </p:txBody>
+      </p:sp>
+      <p:sp>
+        <p:nvSpPr>
+          <p:cNvPr id="6" name="TextBox 5"/>
+          <p:cNvSpPr txBox="1"/>
+          <p:nvPr/>
+        </p:nvSpPr>
+        <p:spPr>
+          <a:xfrm>
+            <a:off x="566928" y="1280160"/>
+            <a:ext cx="228600" cy="475488"/>
+          </a:xfrm>
+          <a:prstGeom prst="rect">
+            <a:avLst/>
+          </a:prstGeom>
+          <a:noFill/>
+        </p:spPr>
+        <p:txBody>
+          <a:bodyPr wrap="square" lIns="0" rIns="0" tIns="0" bIns="0" anchor="ctr">
+            <a:spAutoFit/>
+          </a:bodyPr>
+          <a:lstStyle/>
+          <a:p>
+            <a:pPr algn="l"/>
+            <a:r>
+              <a:rPr sz="1400" b="1" i="0">
+                <a:solidFill>
+                  <a:srgbClr val="EAF0F6"/>
+                </a:solidFill>
+                <a:latin typeface="Calibri"/>
+              </a:rPr>
+              <a:t>#</a:t>
+            </a:r>
+          </a:p>
+        </p:txBody>
+      </p:sp>
+      <p:sp>
+        <p:nvSpPr>
+          <p:cNvPr id="7" name="TextBox 6"/>
+          <p:cNvSpPr txBox="1"/>
+          <p:nvPr/>
+        </p:nvSpPr>
+        <p:spPr>
+          <a:xfrm>
+            <a:off x="978407" y="1280160"/>
+            <a:ext cx="2194560" cy="475488"/>
+          </a:xfrm>
+          <a:prstGeom prst="rect">
+            <a:avLst/>
+          </a:prstGeom>
+          <a:noFill/>
+        </p:spPr>
+        <p:txBody>
+          <a:bodyPr wrap="square" lIns="0" rIns="0" tIns="0" bIns="0" anchor="ctr">
+            <a:spAutoFit/>
+          </a:bodyPr>
+          <a:lstStyle/>
+          <a:p>
+            <a:pPr algn="l"/>
+            <a:r>
+              <a:rPr sz="1400" b="1" i="0">
+                <a:solidFill>
+                  <a:srgbClr val="EAF0F6"/>
+                </a:solidFill>
+                <a:latin typeface="Calibri"/>
+              </a:rPr>
+              <a:t>Parameter</a:t>
+            </a:r>
+          </a:p>
+        </p:txBody>
+      </p:sp>
+      <p:sp>
+        <p:nvSpPr>
+          <p:cNvPr id="8" name="TextBox 7"/>
+          <p:cNvSpPr txBox="1"/>
+          <p:nvPr/>
+        </p:nvSpPr>
+        <p:spPr>
+          <a:xfrm>
+            <a:off x="3355848" y="1280160"/>
+            <a:ext cx="4041648" cy="475488"/>
+          </a:xfrm>
+          <a:prstGeom prst="rect">
+            <a:avLst/>
+          </a:prstGeom>
+          <a:noFill/>
+        </p:spPr>
+        <p:txBody>
+          <a:bodyPr wrap="square" lIns="0" rIns="0" tIns="0" bIns="0" anchor="ctr">
+            <a:spAutoFit/>
+          </a:bodyPr>
+          <a:lstStyle/>
+          <a:p>
+            <a:pPr algn="l"/>
+            <a:r>
+              <a:rPr sz="1400" b="1" i="0">
+                <a:solidFill>
+                  <a:srgbClr val="EAF0F6"/>
+                </a:solidFill>
+                <a:latin typeface="Calibri"/>
+              </a:rPr>
+              <a:t>3-PCB C-Shape</a:t>
+            </a:r>
+          </a:p>
+        </p:txBody>
+      </p:sp>
+      <p:sp>
+        <p:nvSpPr>
+          <p:cNvPr id="9" name="TextBox 8"/>
+          <p:cNvSpPr txBox="1"/>
+          <p:nvPr/>
+        </p:nvSpPr>
+        <p:spPr>
+          <a:xfrm>
+            <a:off x="7580375" y="1280160"/>
+            <a:ext cx="4078224" cy="475488"/>
+          </a:xfrm>
+          <a:prstGeom prst="rect">
+            <a:avLst/>
+          </a:prstGeom>
+          <a:noFill/>
+        </p:spPr>
+        <p:txBody>
+          <a:bodyPr wrap="square" lIns="0" rIns="0" tIns="0" bIns="0" anchor="ctr">
+            <a:spAutoFit/>
+          </a:bodyPr>
+          <a:lstStyle/>
+          <a:p>
+            <a:pPr algn="l"/>
+            <a:r>
+              <a:rPr sz="1400" b="1" i="0">
+                <a:solidFill>
+                  <a:srgbClr val="EAF0F6"/>
+                </a:solidFill>
+                <a:latin typeface="Calibri"/>
+              </a:rPr>
+              <a:t>Single C-Shape PCB</a:t>
+            </a:r>
+          </a:p>
+        </p:txBody>
+      </p:sp>
+      <p:sp>
+        <p:nvSpPr>
+          <p:cNvPr id="10" name="Rounded Rectangle 9"/>
+          <p:cNvSpPr/>
+          <p:nvPr/>
+        </p:nvSpPr>
+        <p:spPr>
+          <a:xfrm>
+            <a:off x="6510528" y="1399031"/>
+            <a:ext cx="822960" cy="265176"/>
+          </a:xfrm>
+          <a:prstGeom prst="roundRect">
+            <a:avLst>
+              <a:gd name="adj" fmla="val 50000"/>
+            </a:avLst>
+          </a:prstGeom>
+          <a:solidFill>
+            <a:srgbClr val="0E1621"/>
+          </a:solidFill>
+          <a:ln>
+            <a:noFill/>
+          </a:ln>
+        </p:spPr>
+        <p:txBody>
+          <a:bodyPr rtlCol="0" anchor="ctr"/>
+          <a:lstStyle/>
+          <a:p>
+            <a:pPr algn="ctr"/>
+          </a:p>
+        </p:txBody>
+      </p:sp>
+      <p:sp>
+        <p:nvSpPr>
+          <p:cNvPr id="11" name="TextBox 10"/>
+          <p:cNvSpPr txBox="1"/>
+          <p:nvPr/>
+        </p:nvSpPr>
+        <p:spPr>
+          <a:xfrm>
+            <a:off x="6510528" y="1399031"/>
+            <a:ext cx="822960" cy="265176"/>
+          </a:xfrm>
+          <a:prstGeom prst="rect">
+            <a:avLst/>
+          </a:prstGeom>
+          <a:noFill/>
+        </p:spPr>
+        <p:txBody>
+          <a:bodyPr wrap="square" lIns="0" rIns="0" tIns="0" bIns="0" anchor="ctr">
+            <a:spAutoFit/>
+          </a:bodyPr>
+          <a:lstStyle/>
+          <a:p>
+            <a:pPr algn="ctr"/>
+            <a:r>
+              <a:rPr sz="1100" b="1" i="0">
+                <a:solidFill>
+                  <a:srgbClr val="FFD34D"/>
+                </a:solidFill>
+                <a:latin typeface="Calibri"/>
+              </a:rPr>
+              <a:t>3 / 10</a:t>
+            </a:r>
+          </a:p>
+        </p:txBody>
+      </p:sp>
+      <p:sp>
+        <p:nvSpPr>
+          <p:cNvPr id="12" name="Rounded Rectangle 11"/>
+          <p:cNvSpPr/>
+          <p:nvPr/>
+        </p:nvSpPr>
+        <p:spPr>
+          <a:xfrm>
+            <a:off x="10771632" y="1399031"/>
+            <a:ext cx="822960" cy="265176"/>
+          </a:xfrm>
+          <a:prstGeom prst="roundRect">
+            <a:avLst>
+              <a:gd name="adj" fmla="val 50000"/>
+            </a:avLst>
+          </a:prstGeom>
+          <a:solidFill>
+            <a:srgbClr val="0E1621"/>
+          </a:solidFill>
+          <a:ln>
+            <a:noFill/>
+          </a:ln>
+        </p:spPr>
+        <p:txBody>
+          <a:bodyPr rtlCol="0" anchor="ctr"/>
+          <a:lstStyle/>
+          <a:p>
+            <a:pPr algn="ctr"/>
+          </a:p>
+        </p:txBody>
+      </p:sp>
+      <p:sp>
+        <p:nvSpPr>
+          <p:cNvPr id="13" name="TextBox 12"/>
+          <p:cNvSpPr txBox="1"/>
+          <p:nvPr/>
+        </p:nvSpPr>
+        <p:spPr>
+          <a:xfrm>
+            <a:off x="10771632" y="1399031"/>
+            <a:ext cx="822960" cy="265176"/>
+          </a:xfrm>
+          <a:prstGeom prst="rect">
+            <a:avLst/>
+          </a:prstGeom>
+          <a:noFill/>
+        </p:spPr>
+        <p:txBody>
+          <a:bodyPr wrap="square" lIns="0" rIns="0" tIns="0" bIns="0" anchor="ctr">
+            <a:spAutoFit/>
+          </a:bodyPr>
+          <a:lstStyle/>
+          <a:p>
+            <a:pPr algn="ctr"/>
+            <a:r>
+              <a:rPr sz="1100" b="1" i="0">
+                <a:solidFill>
+                  <a:srgbClr val="FFD34D"/>
+                </a:solidFill>
+                <a:latin typeface="Calibri"/>
+              </a:rPr>
+              <a:t>7 / 10</a:t>
+            </a:r>
+          </a:p>
+        </p:txBody>
+      </p:sp>
+      <p:sp>
+        <p:nvSpPr>
+          <p:cNvPr id="14" name="Rectangle 13"/>
+          <p:cNvSpPr/>
+          <p:nvPr/>
+        </p:nvSpPr>
+        <p:spPr>
+          <a:xfrm>
+            <a:off x="457200" y="1755648"/>
+            <a:ext cx="11274552" cy="384048"/>
+          </a:xfrm>
+          <a:prstGeom prst="rect">
+            <a:avLst/>
+          </a:prstGeom>
+          <a:solidFill>
+            <a:srgbClr val="172331"/>
+          </a:solidFill>
+          <a:ln>
+            <a:noFill/>
+          </a:ln>
+        </p:spPr>
+        <p:txBody>
+          <a:bodyPr rtlCol="0" anchor="ctr"/>
+          <a:lstStyle/>
+          <a:p>
+            <a:pPr algn="ctr"/>
+          </a:p>
+        </p:txBody>
+      </p:sp>
+      <p:sp>
+        <p:nvSpPr>
+          <p:cNvPr id="15" name="TextBox 14"/>
+          <p:cNvSpPr txBox="1"/>
+          <p:nvPr/>
+        </p:nvSpPr>
+        <p:spPr>
+          <a:xfrm>
+            <a:off x="566928" y="1755648"/>
+            <a:ext cx="274320" cy="384048"/>
+          </a:xfrm>
+          <a:prstGeom prst="rect">
+            <a:avLst/>
+          </a:prstGeom>
+          <a:noFill/>
+        </p:spPr>
+        <p:txBody>
+          <a:bodyPr wrap="square" lIns="0" rIns="0" tIns="0" bIns="0" anchor="ctr">
+            <a:spAutoFit/>
+          </a:bodyPr>
+          <a:lstStyle/>
+          <a:p>
+            <a:pPr algn="l"/>
+            <a:r>
+              <a:rPr sz="1100" b="0" i="0">
+                <a:solidFill>
+                  <a:srgbClr val="9FB0C3"/>
+                </a:solidFill>
+                <a:latin typeface="Calibri"/>
+              </a:rPr>
+              <a:t>1</a:t>
+            </a:r>
+          </a:p>
+        </p:txBody>
+      </p:sp>
+      <p:sp>
+        <p:nvSpPr>
+          <p:cNvPr id="16" name="TextBox 15"/>
+          <p:cNvSpPr txBox="1"/>
+          <p:nvPr/>
+        </p:nvSpPr>
+        <p:spPr>
+          <a:xfrm>
+            <a:off x="978407" y="1755648"/>
+            <a:ext cx="2194560" cy="384048"/>
+          </a:xfrm>
+          <a:prstGeom prst="rect">
+            <a:avLst/>
+          </a:prstGeom>
+          <a:noFill/>
+        </p:spPr>
+        <p:txBody>
+          <a:bodyPr wrap="square" lIns="0" rIns="0" tIns="0" bIns="0" anchor="ctr">
+            <a:spAutoFit/>
+          </a:bodyPr>
+          <a:lstStyle/>
+          <a:p>
+            <a:pPr algn="l"/>
+            <a:r>
+              <a:rPr sz="1150" b="1" i="0">
+                <a:solidFill>
+                  <a:srgbClr val="EAF0F6"/>
+                </a:solidFill>
+                <a:latin typeface="Calibri"/>
+              </a:rPr>
+              <a:t>EMI – Radiated emissions</a:t>
+            </a:r>
+          </a:p>
+        </p:txBody>
+      </p:sp>
+      <p:sp>
+        <p:nvSpPr>
+          <p:cNvPr id="17" name="Oval 16"/>
+          <p:cNvSpPr/>
+          <p:nvPr/>
+        </p:nvSpPr>
+        <p:spPr>
+          <a:xfrm>
+            <a:off x="3355848" y="1828800"/>
+            <a:ext cx="237744" cy="237744"/>
+          </a:xfrm>
+          <a:prstGeom prst="ellipse">
+            <a:avLst/>
+          </a:prstGeom>
+          <a:solidFill>
+            <a:srgbClr val="E05D5D"/>
+          </a:solidFill>
+          <a:ln>
+            <a:noFill/>
+          </a:ln>
+        </p:spPr>
+        <p:txBody>
+          <a:bodyPr rtlCol="0" anchor="ctr"/>
+          <a:lstStyle/>
+          <a:p>
+            <a:pPr algn="ctr"/>
+          </a:p>
+        </p:txBody>
+      </p:sp>
+      <p:sp>
+        <p:nvSpPr>
+          <p:cNvPr id="18" name="TextBox 17"/>
+          <p:cNvSpPr txBox="1"/>
+          <p:nvPr/>
+        </p:nvSpPr>
+        <p:spPr>
+          <a:xfrm>
+            <a:off x="3355848" y="1828800"/>
+            <a:ext cx="237744" cy="237744"/>
+          </a:xfrm>
+          <a:prstGeom prst="rect">
+            <a:avLst/>
+          </a:prstGeom>
+          <a:noFill/>
+        </p:spPr>
+        <p:txBody>
+          <a:bodyPr wrap="square" lIns="0" rIns="0" tIns="0" bIns="0" anchor="ctr">
+            <a:spAutoFit/>
+          </a:bodyPr>
+          <a:lstStyle/>
+          <a:p>
+            <a:pPr algn="ctr"/>
+            <a:r>
+              <a:rPr sz="1100" b="1" i="0">
+                <a:solidFill>
+                  <a:srgbClr val="EAF0F6"/>
+                </a:solidFill>
+                <a:latin typeface="Calibri"/>
+              </a:rPr>
+              <a:t>✗</a:t>
+            </a:r>
+          </a:p>
+        </p:txBody>
+      </p:sp>
+      <p:sp>
+        <p:nvSpPr>
+          <p:cNvPr id="19" name="TextBox 18"/>
+          <p:cNvSpPr txBox="1"/>
+          <p:nvPr/>
+        </p:nvSpPr>
+        <p:spPr>
+          <a:xfrm>
+            <a:off x="3703320" y="1755648"/>
+            <a:ext cx="3675888" cy="384048"/>
+          </a:xfrm>
+          <a:prstGeom prst="rect">
+            <a:avLst/>
+          </a:prstGeom>
+          <a:noFill/>
+        </p:spPr>
+        <p:txBody>
+          <a:bodyPr wrap="square" lIns="0" rIns="0" tIns="0" bIns="0" anchor="ctr">
+            <a:spAutoFit/>
+          </a:bodyPr>
+          <a:lstStyle/>
+          <a:p>
+            <a:pPr algn="l"/>
+            <a:r>
+              <a:rPr sz="1100" b="0" i="0">
+                <a:solidFill>
+                  <a:srgbClr val="9FB0C3"/>
+                </a:solidFill>
+                <a:latin typeface="Calibri"/>
+              </a:rPr>
+              <a:t>Inter-board wires act as unintended antennas</a:t>
+            </a:r>
+          </a:p>
+        </p:txBody>
+      </p:sp>
+      <p:sp>
+        <p:nvSpPr>
+          <p:cNvPr id="20" name="Oval 19"/>
+          <p:cNvSpPr/>
+          <p:nvPr/>
+        </p:nvSpPr>
+        <p:spPr>
+          <a:xfrm>
+            <a:off x="7580375" y="1828800"/>
+            <a:ext cx="237744" cy="237744"/>
+          </a:xfrm>
+          <a:prstGeom prst="ellipse">
+            <a:avLst/>
+          </a:prstGeom>
+          <a:solidFill>
+            <a:srgbClr val="3FA46A"/>
+          </a:solidFill>
+          <a:ln>
+            <a:noFill/>
+          </a:ln>
+        </p:spPr>
+        <p:txBody>
+          <a:bodyPr rtlCol="0" anchor="ctr"/>
+          <a:lstStyle/>
+          <a:p>
+            <a:pPr algn="ctr"/>
+          </a:p>
+        </p:txBody>
+      </p:sp>
+      <p:sp>
+        <p:nvSpPr>
+          <p:cNvPr id="21" name="TextBox 20"/>
+          <p:cNvSpPr txBox="1"/>
+          <p:nvPr/>
+        </p:nvSpPr>
+        <p:spPr>
+          <a:xfrm>
+            <a:off x="7580375" y="1828800"/>
+            <a:ext cx="237744" cy="237744"/>
+          </a:xfrm>
+          <a:prstGeom prst="rect">
+            <a:avLst/>
+          </a:prstGeom>
+          <a:noFill/>
+        </p:spPr>
+        <p:txBody>
+          <a:bodyPr wrap="square" lIns="0" rIns="0" tIns="0" bIns="0" anchor="ctr">
+            <a:spAutoFit/>
+          </a:bodyPr>
+          <a:lstStyle/>
+          <a:p>
+            <a:pPr algn="ctr"/>
+            <a:r>
+              <a:rPr sz="1100" b="1" i="0">
+                <a:solidFill>
+                  <a:srgbClr val="EAF0F6"/>
+                </a:solidFill>
+                <a:latin typeface="Calibri"/>
+              </a:rPr>
+              <a:t>✓</a:t>
+            </a:r>
+          </a:p>
+        </p:txBody>
+      </p:sp>
+      <p:sp>
+        <p:nvSpPr>
+          <p:cNvPr id="22" name="TextBox 21"/>
+          <p:cNvSpPr txBox="1"/>
+          <p:nvPr/>
+        </p:nvSpPr>
+        <p:spPr>
+          <a:xfrm>
+            <a:off x="7927848" y="1755648"/>
+            <a:ext cx="3712464" cy="384048"/>
+          </a:xfrm>
+          <a:prstGeom prst="rect">
+            <a:avLst/>
+          </a:prstGeom>
+          <a:noFill/>
+        </p:spPr>
+        <p:txBody>
+          <a:bodyPr wrap="square" lIns="0" rIns="0" tIns="0" bIns="0" anchor="ctr">
+            <a:spAutoFit/>
+          </a:bodyPr>
+          <a:lstStyle/>
+          <a:p>
+            <a:pPr algn="l"/>
+            <a:r>
+              <a:rPr sz="1100" b="0" i="0">
+                <a:solidFill>
+                  <a:srgbClr val="EAF0F6"/>
+                </a:solidFill>
+                <a:latin typeface="Calibri"/>
+              </a:rPr>
+              <a:t>No PCB-to-PCB harness left to radiate</a:t>
+            </a:r>
+          </a:p>
+        </p:txBody>
+      </p:sp>
+      <p:sp>
+        <p:nvSpPr>
+          <p:cNvPr id="23" name="Rectangle 22"/>
+          <p:cNvSpPr/>
+          <p:nvPr/>
+        </p:nvSpPr>
+        <p:spPr>
+          <a:xfrm>
+            <a:off x="457200" y="2139696"/>
+            <a:ext cx="11274552" cy="384048"/>
+          </a:xfrm>
+          <a:prstGeom prst="rect">
+            <a:avLst/>
+          </a:prstGeom>
+          <a:solidFill>
+            <a:srgbClr val="0E1621"/>
+          </a:solidFill>
+          <a:ln>
+            <a:noFill/>
+          </a:ln>
+        </p:spPr>
+        <p:txBody>
+          <a:bodyPr rtlCol="0" anchor="ctr"/>
+          <a:lstStyle/>
+          <a:p>
+            <a:pPr algn="ctr"/>
+          </a:p>
+        </p:txBody>
+      </p:sp>
+      <p:sp>
+        <p:nvSpPr>
+          <p:cNvPr id="24" name="TextBox 23"/>
+          <p:cNvSpPr txBox="1"/>
+          <p:nvPr/>
+        </p:nvSpPr>
+        <p:spPr>
+          <a:xfrm>
+            <a:off x="566928" y="2139696"/>
+            <a:ext cx="274320" cy="384048"/>
+          </a:xfrm>
+          <a:prstGeom prst="rect">
+            <a:avLst/>
+          </a:prstGeom>
+          <a:noFill/>
+        </p:spPr>
+        <p:txBody>
+          <a:bodyPr wrap="square" lIns="0" rIns="0" tIns="0" bIns="0" anchor="ctr">
+            <a:spAutoFit/>
+          </a:bodyPr>
+          <a:lstStyle/>
+          <a:p>
+            <a:pPr algn="l"/>
+            <a:r>
+              <a:rPr sz="1100" b="0" i="0">
+                <a:solidFill>
+                  <a:srgbClr val="9FB0C3"/>
+                </a:solidFill>
+                <a:latin typeface="Calibri"/>
+              </a:rPr>
+              <a:t>2</a:t>
+            </a:r>
+          </a:p>
+        </p:txBody>
+      </p:sp>
+      <p:sp>
+        <p:nvSpPr>
+          <p:cNvPr id="25" name="TextBox 24"/>
+          <p:cNvSpPr txBox="1"/>
+          <p:nvPr/>
+        </p:nvSpPr>
+        <p:spPr>
+          <a:xfrm>
+            <a:off x="978407" y="2139696"/>
+            <a:ext cx="2194560" cy="384048"/>
+          </a:xfrm>
+          <a:prstGeom prst="rect">
+            <a:avLst/>
+          </a:prstGeom>
+          <a:noFill/>
+        </p:spPr>
+        <p:txBody>
+          <a:bodyPr wrap="square" lIns="0" rIns="0" tIns="0" bIns="0" anchor="ctr">
+            <a:spAutoFit/>
+          </a:bodyPr>
+          <a:lstStyle/>
+          <a:p>
+            <a:pPr algn="l"/>
+            <a:r>
+              <a:rPr sz="1150" b="1" i="0">
+                <a:solidFill>
+                  <a:srgbClr val="EAF0F6"/>
+                </a:solidFill>
+                <a:latin typeface="Calibri"/>
+              </a:rPr>
+              <a:t>Common-mode noise</a:t>
+            </a:r>
+          </a:p>
+        </p:txBody>
+      </p:sp>
+      <p:sp>
+        <p:nvSpPr>
+          <p:cNvPr id="26" name="Oval 25"/>
+          <p:cNvSpPr/>
+          <p:nvPr/>
+        </p:nvSpPr>
+        <p:spPr>
+          <a:xfrm>
+            <a:off x="3355848" y="2212848"/>
+            <a:ext cx="237744" cy="237744"/>
+          </a:xfrm>
+          <a:prstGeom prst="ellipse">
+            <a:avLst/>
+          </a:prstGeom>
+          <a:solidFill>
+            <a:srgbClr val="E05D5D"/>
+          </a:solidFill>
+          <a:ln>
+            <a:noFill/>
+          </a:ln>
+        </p:spPr>
+        <p:txBody>
+          <a:bodyPr rtlCol="0" anchor="ctr"/>
+          <a:lstStyle/>
+          <a:p>
+            <a:pPr algn="ctr"/>
+          </a:p>
+        </p:txBody>
+      </p:sp>
+      <p:sp>
+        <p:nvSpPr>
+          <p:cNvPr id="27" name="TextBox 26"/>
+          <p:cNvSpPr txBox="1"/>
+          <p:nvPr/>
+        </p:nvSpPr>
+        <p:spPr>
+          <a:xfrm>
+            <a:off x="3355848" y="2212848"/>
+            <a:ext cx="237744" cy="237744"/>
+          </a:xfrm>
+          <a:prstGeom prst="rect">
+            <a:avLst/>
+          </a:prstGeom>
+          <a:noFill/>
+        </p:spPr>
+        <p:txBody>
+          <a:bodyPr wrap="square" lIns="0" rIns="0" tIns="0" bIns="0" anchor="ctr">
+            <a:spAutoFit/>
+          </a:bodyPr>
+          <a:lstStyle/>
+          <a:p>
+            <a:pPr algn="ctr"/>
+            <a:r>
+              <a:rPr sz="1100" b="1" i="0">
+                <a:solidFill>
+                  <a:srgbClr val="EAF0F6"/>
+                </a:solidFill>
+                <a:latin typeface="Calibri"/>
+              </a:rPr>
+              <a:t>✗</a:t>
+            </a:r>
+          </a:p>
+        </p:txBody>
+      </p:sp>
+      <p:sp>
+        <p:nvSpPr>
+          <p:cNvPr id="28" name="TextBox 27"/>
+          <p:cNvSpPr txBox="1"/>
+          <p:nvPr/>
+        </p:nvSpPr>
+        <p:spPr>
+          <a:xfrm>
+            <a:off x="3703320" y="2139696"/>
+            <a:ext cx="3675888" cy="384048"/>
+          </a:xfrm>
+          <a:prstGeom prst="rect">
+            <a:avLst/>
+          </a:prstGeom>
+          <a:noFill/>
+        </p:spPr>
+        <p:txBody>
+          <a:bodyPr wrap="square" lIns="0" rIns="0" tIns="0" bIns="0" anchor="ctr">
+            <a:spAutoFit/>
+          </a:bodyPr>
+          <a:lstStyle/>
+          <a:p>
+            <a:pPr algn="l"/>
+            <a:r>
+              <a:rPr sz="1100" b="0" i="0">
+                <a:solidFill>
+                  <a:srgbClr val="9FB0C3"/>
+                </a:solidFill>
+                <a:latin typeface="Calibri"/>
+              </a:rPr>
+              <a:t>Inter-board wires carry common-mode currents</a:t>
+            </a:r>
+          </a:p>
+        </p:txBody>
+      </p:sp>
+      <p:sp>
+        <p:nvSpPr>
+          <p:cNvPr id="29" name="Oval 28"/>
+          <p:cNvSpPr/>
+          <p:nvPr/>
+        </p:nvSpPr>
+        <p:spPr>
+          <a:xfrm>
+            <a:off x="7580375" y="2212848"/>
+            <a:ext cx="237744" cy="237744"/>
+          </a:xfrm>
+          <a:prstGeom prst="ellipse">
+            <a:avLst/>
+          </a:prstGeom>
+          <a:solidFill>
+            <a:srgbClr val="3FA46A"/>
+          </a:solidFill>
+          <a:ln>
+            <a:noFill/>
+          </a:ln>
+        </p:spPr>
+        <p:txBody>
+          <a:bodyPr rtlCol="0" anchor="ctr"/>
+          <a:lstStyle/>
+          <a:p>
+            <a:pPr algn="ctr"/>
+          </a:p>
+        </p:txBody>
+      </p:sp>
+      <p:sp>
+        <p:nvSpPr>
+          <p:cNvPr id="30" name="TextBox 29"/>
+          <p:cNvSpPr txBox="1"/>
+          <p:nvPr/>
+        </p:nvSpPr>
+        <p:spPr>
+          <a:xfrm>
+            <a:off x="7580375" y="2212848"/>
+            <a:ext cx="237744" cy="237744"/>
+          </a:xfrm>
+          <a:prstGeom prst="rect">
+            <a:avLst/>
+          </a:prstGeom>
+          <a:noFill/>
+        </p:spPr>
+        <p:txBody>
+          <a:bodyPr wrap="square" lIns="0" rIns="0" tIns="0" bIns="0" anchor="ctr">
+            <a:spAutoFit/>
+          </a:bodyPr>
+          <a:lstStyle/>
+          <a:p>
+            <a:pPr algn="ctr"/>
+            <a:r>
+              <a:rPr sz="1100" b="1" i="0">
+                <a:solidFill>
+                  <a:srgbClr val="EAF0F6"/>
+                </a:solidFill>
+                <a:latin typeface="Calibri"/>
+              </a:rPr>
+              <a:t>✓</a:t>
+            </a:r>
+          </a:p>
+        </p:txBody>
+      </p:sp>
+      <p:sp>
+        <p:nvSpPr>
+          <p:cNvPr id="31" name="TextBox 30"/>
+          <p:cNvSpPr txBox="1"/>
+          <p:nvPr/>
+        </p:nvSpPr>
+        <p:spPr>
+          <a:xfrm>
+            <a:off x="7927848" y="2139696"/>
+            <a:ext cx="3712464" cy="384048"/>
+          </a:xfrm>
+          <a:prstGeom prst="rect">
+            <a:avLst/>
+          </a:prstGeom>
+          <a:noFill/>
+        </p:spPr>
+        <p:txBody>
+          <a:bodyPr wrap="square" lIns="0" rIns="0" tIns="0" bIns="0" anchor="ctr">
+            <a:spAutoFit/>
+          </a:bodyPr>
+          <a:lstStyle/>
+          <a:p>
+            <a:pPr algn="l"/>
+            <a:r>
+              <a:rPr sz="1100" b="0" i="0">
+                <a:solidFill>
+                  <a:srgbClr val="EAF0F6"/>
+                </a:solidFill>
+                <a:latin typeface="Calibri"/>
+              </a:rPr>
+              <a:t>Short conductors, few CM coupling paths</a:t>
+            </a:r>
+          </a:p>
+        </p:txBody>
+      </p:sp>
+      <p:sp>
+        <p:nvSpPr>
+          <p:cNvPr id="32" name="Rectangle 31"/>
+          <p:cNvSpPr/>
+          <p:nvPr/>
+        </p:nvSpPr>
+        <p:spPr>
+          <a:xfrm>
+            <a:off x="457200" y="2523744"/>
+            <a:ext cx="11274552" cy="384048"/>
+          </a:xfrm>
+          <a:prstGeom prst="rect">
+            <a:avLst/>
+          </a:prstGeom>
+          <a:solidFill>
+            <a:srgbClr val="172331"/>
+          </a:solidFill>
+          <a:ln>
+            <a:noFill/>
+          </a:ln>
+        </p:spPr>
+        <p:txBody>
+          <a:bodyPr rtlCol="0" anchor="ctr"/>
+          <a:lstStyle/>
+          <a:p>
+            <a:pPr algn="ctr"/>
+          </a:p>
+        </p:txBody>
+      </p:sp>
+      <p:sp>
+        <p:nvSpPr>
+          <p:cNvPr id="33" name="TextBox 32"/>
+          <p:cNvSpPr txBox="1"/>
+          <p:nvPr/>
+        </p:nvSpPr>
+        <p:spPr>
+          <a:xfrm>
+            <a:off x="566928" y="2523744"/>
+            <a:ext cx="274320" cy="384048"/>
+          </a:xfrm>
+          <a:prstGeom prst="rect">
+            <a:avLst/>
+          </a:prstGeom>
+          <a:noFill/>
+        </p:spPr>
+        <p:txBody>
+          <a:bodyPr wrap="square" lIns="0" rIns="0" tIns="0" bIns="0" anchor="ctr">
+            <a:spAutoFit/>
+          </a:bodyPr>
+          <a:lstStyle/>
+          <a:p>
+            <a:pPr algn="l"/>
+            <a:r>
+              <a:rPr sz="1100" b="0" i="0">
+                <a:solidFill>
+                  <a:srgbClr val="9FB0C3"/>
+                </a:solidFill>
+                <a:latin typeface="Calibri"/>
+              </a:rPr>
+              <a:t>3</a:t>
+            </a:r>
+          </a:p>
+        </p:txBody>
+      </p:sp>
+      <p:sp>
+        <p:nvSpPr>
+          <p:cNvPr id="34" name="TextBox 33"/>
+          <p:cNvSpPr txBox="1"/>
+          <p:nvPr/>
+        </p:nvSpPr>
+        <p:spPr>
+          <a:xfrm>
+            <a:off x="978407" y="2523744"/>
+            <a:ext cx="2194560" cy="384048"/>
+          </a:xfrm>
+          <a:prstGeom prst="rect">
+            <a:avLst/>
+          </a:prstGeom>
+          <a:noFill/>
+        </p:spPr>
+        <p:txBody>
+          <a:bodyPr wrap="square" lIns="0" rIns="0" tIns="0" bIns="0" anchor="ctr">
+            <a:spAutoFit/>
+          </a:bodyPr>
+          <a:lstStyle/>
+          <a:p>
+            <a:pPr algn="l"/>
+            <a:r>
+              <a:rPr sz="1150" b="1" i="0">
+                <a:solidFill>
+                  <a:srgbClr val="EAF0F6"/>
+                </a:solidFill>
+                <a:latin typeface="Calibri"/>
+              </a:rPr>
+              <a:t>Current loop area</a:t>
+            </a:r>
+          </a:p>
+        </p:txBody>
+      </p:sp>
+      <p:sp>
+        <p:nvSpPr>
+          <p:cNvPr id="35" name="Oval 34"/>
+          <p:cNvSpPr/>
+          <p:nvPr/>
+        </p:nvSpPr>
+        <p:spPr>
+          <a:xfrm>
+            <a:off x="3355848" y="2596896"/>
+            <a:ext cx="237744" cy="237744"/>
+          </a:xfrm>
+          <a:prstGeom prst="ellipse">
+            <a:avLst/>
+          </a:prstGeom>
+          <a:solidFill>
+            <a:srgbClr val="E05D5D"/>
+          </a:solidFill>
+          <a:ln>
+            <a:noFill/>
+          </a:ln>
+        </p:spPr>
+        <p:txBody>
+          <a:bodyPr rtlCol="0" anchor="ctr"/>
+          <a:lstStyle/>
+          <a:p>
+            <a:pPr algn="ctr"/>
+          </a:p>
+        </p:txBody>
+      </p:sp>
+      <p:sp>
+        <p:nvSpPr>
+          <p:cNvPr id="36" name="TextBox 35"/>
+          <p:cNvSpPr txBox="1"/>
+          <p:nvPr/>
+        </p:nvSpPr>
+        <p:spPr>
+          <a:xfrm>
+            <a:off x="3355848" y="2596896"/>
+            <a:ext cx="237744" cy="237744"/>
+          </a:xfrm>
+          <a:prstGeom prst="rect">
+            <a:avLst/>
+          </a:prstGeom>
+          <a:noFill/>
+        </p:spPr>
+        <p:txBody>
+          <a:bodyPr wrap="square" lIns="0" rIns="0" tIns="0" bIns="0" anchor="ctr">
+            <a:spAutoFit/>
+          </a:bodyPr>
+          <a:lstStyle/>
+          <a:p>
+            <a:pPr algn="ctr"/>
+            <a:r>
+              <a:rPr sz="1100" b="1" i="0">
+                <a:solidFill>
+                  <a:srgbClr val="EAF0F6"/>
+                </a:solidFill>
+                <a:latin typeface="Calibri"/>
+              </a:rPr>
+              <a:t>✗</a:t>
+            </a:r>
+          </a:p>
+        </p:txBody>
+      </p:sp>
+      <p:sp>
+        <p:nvSpPr>
+          <p:cNvPr id="37" name="TextBox 36"/>
+          <p:cNvSpPr txBox="1"/>
+          <p:nvPr/>
+        </p:nvSpPr>
+        <p:spPr>
+          <a:xfrm>
+            <a:off x="3703320" y="2523744"/>
+            <a:ext cx="3675888" cy="384048"/>
+          </a:xfrm>
+          <a:prstGeom prst="rect">
+            <a:avLst/>
+          </a:prstGeom>
+          <a:noFill/>
+        </p:spPr>
+        <p:txBody>
+          <a:bodyPr wrap="square" lIns="0" rIns="0" tIns="0" bIns="0" anchor="ctr">
+            <a:spAutoFit/>
+          </a:bodyPr>
+          <a:lstStyle/>
+          <a:p>
+            <a:pPr algn="l"/>
+            <a:r>
+              <a:rPr sz="1100" b="0" i="0">
+                <a:solidFill>
+                  <a:srgbClr val="9FB0C3"/>
+                </a:solidFill>
+                <a:latin typeface="Calibri"/>
+              </a:rPr>
+              <a:t>Harness routing enlarges the loop area</a:t>
+            </a:r>
+          </a:p>
+        </p:txBody>
+      </p:sp>
+      <p:sp>
+        <p:nvSpPr>
+          <p:cNvPr id="38" name="Oval 37"/>
+          <p:cNvSpPr/>
+          <p:nvPr/>
+        </p:nvSpPr>
+        <p:spPr>
+          <a:xfrm>
+            <a:off x="7580375" y="2596896"/>
+            <a:ext cx="237744" cy="237744"/>
+          </a:xfrm>
+          <a:prstGeom prst="ellipse">
+            <a:avLst/>
+          </a:prstGeom>
+          <a:solidFill>
+            <a:srgbClr val="3FA46A"/>
+          </a:solidFill>
+          <a:ln>
+            <a:noFill/>
+          </a:ln>
+        </p:spPr>
+        <p:txBody>
+          <a:bodyPr rtlCol="0" anchor="ctr"/>
+          <a:lstStyle/>
+          <a:p>
+            <a:pPr algn="ctr"/>
+          </a:p>
+        </p:txBody>
+      </p:sp>
+      <p:sp>
+        <p:nvSpPr>
+          <p:cNvPr id="39" name="TextBox 38"/>
+          <p:cNvSpPr txBox="1"/>
+          <p:nvPr/>
+        </p:nvSpPr>
+        <p:spPr>
+          <a:xfrm>
+            <a:off x="7580375" y="2596896"/>
+            <a:ext cx="237744" cy="237744"/>
+          </a:xfrm>
+          <a:prstGeom prst="rect">
+            <a:avLst/>
+          </a:prstGeom>
+          <a:noFill/>
+        </p:spPr>
+        <p:txBody>
+          <a:bodyPr wrap="square" lIns="0" rIns="0" tIns="0" bIns="0" anchor="ctr">
+            <a:spAutoFit/>
+          </a:bodyPr>
+          <a:lstStyle/>
+          <a:p>
+            <a:pPr algn="ctr"/>
+            <a:r>
+              <a:rPr sz="1100" b="1" i="0">
+                <a:solidFill>
+                  <a:srgbClr val="EAF0F6"/>
+                </a:solidFill>
+                <a:latin typeface="Calibri"/>
+              </a:rPr>
+              <a:t>✓</a:t>
+            </a:r>
+          </a:p>
+        </p:txBody>
+      </p:sp>
+      <p:sp>
+        <p:nvSpPr>
+          <p:cNvPr id="40" name="TextBox 39"/>
+          <p:cNvSpPr txBox="1"/>
+          <p:nvPr/>
+        </p:nvSpPr>
+        <p:spPr>
+          <a:xfrm>
+            <a:off x="7927848" y="2523744"/>
+            <a:ext cx="3712464" cy="384048"/>
+          </a:xfrm>
+          <a:prstGeom prst="rect">
+            <a:avLst/>
+          </a:prstGeom>
+          <a:noFill/>
+        </p:spPr>
+        <p:txBody>
+          <a:bodyPr wrap="square" lIns="0" rIns="0" tIns="0" bIns="0" anchor="ctr">
+            <a:spAutoFit/>
+          </a:bodyPr>
+          <a:lstStyle/>
+          <a:p>
+            <a:pPr algn="l"/>
+            <a:r>
+              <a:rPr sz="1100" b="0" i="0">
+                <a:solidFill>
+                  <a:srgbClr val="EAF0F6"/>
+                </a:solidFill>
+                <a:latin typeface="Calibri"/>
+              </a:rPr>
+              <a:t>Forward &amp; return routed tightly in copper</a:t>
+            </a:r>
+          </a:p>
+        </p:txBody>
+      </p:sp>
+      <p:sp>
+        <p:nvSpPr>
+          <p:cNvPr id="41" name="Rectangle 40"/>
+          <p:cNvSpPr/>
+          <p:nvPr/>
+        </p:nvSpPr>
+        <p:spPr>
+          <a:xfrm>
+            <a:off x="457200" y="2907791"/>
+            <a:ext cx="11274552" cy="384048"/>
+          </a:xfrm>
+          <a:prstGeom prst="rect">
+            <a:avLst/>
+          </a:prstGeom>
+          <a:solidFill>
+            <a:srgbClr val="0E1621"/>
+          </a:solidFill>
+          <a:ln>
+            <a:noFill/>
+          </a:ln>
+        </p:spPr>
+        <p:txBody>
+          <a:bodyPr rtlCol="0" anchor="ctr"/>
+          <a:lstStyle/>
+          <a:p>
+            <a:pPr algn="ctr"/>
+          </a:p>
+        </p:txBody>
+      </p:sp>
+      <p:sp>
+        <p:nvSpPr>
+          <p:cNvPr id="42" name="TextBox 41"/>
+          <p:cNvSpPr txBox="1"/>
+          <p:nvPr/>
+        </p:nvSpPr>
+        <p:spPr>
+          <a:xfrm>
+            <a:off x="566928" y="2907791"/>
+            <a:ext cx="274320" cy="384048"/>
+          </a:xfrm>
+          <a:prstGeom prst="rect">
+            <a:avLst/>
+          </a:prstGeom>
+          <a:noFill/>
+        </p:spPr>
+        <p:txBody>
+          <a:bodyPr wrap="square" lIns="0" rIns="0" tIns="0" bIns="0" anchor="ctr">
+            <a:spAutoFit/>
+          </a:bodyPr>
+          <a:lstStyle/>
+          <a:p>
+            <a:pPr algn="l"/>
+            <a:r>
+              <a:rPr sz="1100" b="0" i="0">
+                <a:solidFill>
+                  <a:srgbClr val="9FB0C3"/>
+                </a:solidFill>
+                <a:latin typeface="Calibri"/>
+              </a:rPr>
+              <a:t>4</a:t>
+            </a:r>
+          </a:p>
+        </p:txBody>
+      </p:sp>
+      <p:sp>
+        <p:nvSpPr>
+          <p:cNvPr id="43" name="TextBox 42"/>
+          <p:cNvSpPr txBox="1"/>
+          <p:nvPr/>
+        </p:nvSpPr>
+        <p:spPr>
+          <a:xfrm>
+            <a:off x="978407" y="2907791"/>
+            <a:ext cx="2194560" cy="384048"/>
+          </a:xfrm>
+          <a:prstGeom prst="rect">
+            <a:avLst/>
+          </a:prstGeom>
+          <a:noFill/>
+        </p:spPr>
+        <p:txBody>
+          <a:bodyPr wrap="square" lIns="0" rIns="0" tIns="0" bIns="0" anchor="ctr">
+            <a:spAutoFit/>
+          </a:bodyPr>
+          <a:lstStyle/>
+          <a:p>
+            <a:pPr algn="l"/>
+            <a:r>
+              <a:rPr sz="1150" b="1" i="0">
+                <a:solidFill>
+                  <a:srgbClr val="EAF0F6"/>
+                </a:solidFill>
+                <a:latin typeface="Calibri"/>
+              </a:rPr>
+              <a:t>Ground reference ★</a:t>
+            </a:r>
+          </a:p>
+        </p:txBody>
+      </p:sp>
+      <p:sp>
+        <p:nvSpPr>
+          <p:cNvPr id="44" name="Oval 43"/>
+          <p:cNvSpPr/>
+          <p:nvPr/>
+        </p:nvSpPr>
+        <p:spPr>
+          <a:xfrm>
+            <a:off x="3355848" y="2980944"/>
+            <a:ext cx="237744" cy="237744"/>
+          </a:xfrm>
+          <a:prstGeom prst="ellipse">
+            <a:avLst/>
+          </a:prstGeom>
+          <a:solidFill>
+            <a:srgbClr val="E05D5D"/>
+          </a:solidFill>
+          <a:ln>
+            <a:noFill/>
+          </a:ln>
+        </p:spPr>
+        <p:txBody>
+          <a:bodyPr rtlCol="0" anchor="ctr"/>
+          <a:lstStyle/>
+          <a:p>
+            <a:pPr algn="ctr"/>
+          </a:p>
+        </p:txBody>
+      </p:sp>
+      <p:sp>
+        <p:nvSpPr>
+          <p:cNvPr id="45" name="TextBox 44"/>
+          <p:cNvSpPr txBox="1"/>
+          <p:nvPr/>
+        </p:nvSpPr>
+        <p:spPr>
+          <a:xfrm>
+            <a:off x="3355848" y="2980944"/>
+            <a:ext cx="237744" cy="237744"/>
+          </a:xfrm>
+          <a:prstGeom prst="rect">
+            <a:avLst/>
+          </a:prstGeom>
+          <a:noFill/>
+        </p:spPr>
+        <p:txBody>
+          <a:bodyPr wrap="square" lIns="0" rIns="0" tIns="0" bIns="0" anchor="ctr">
+            <a:spAutoFit/>
+          </a:bodyPr>
+          <a:lstStyle/>
+          <a:p>
+            <a:pPr algn="ctr"/>
+            <a:r>
+              <a:rPr sz="1100" b="1" i="0">
+                <a:solidFill>
+                  <a:srgbClr val="EAF0F6"/>
+                </a:solidFill>
+                <a:latin typeface="Calibri"/>
+              </a:rPr>
+              <a:t>✗</a:t>
+            </a:r>
+          </a:p>
+        </p:txBody>
+      </p:sp>
+      <p:sp>
+        <p:nvSpPr>
+          <p:cNvPr id="46" name="TextBox 45"/>
+          <p:cNvSpPr txBox="1"/>
+          <p:nvPr/>
+        </p:nvSpPr>
+        <p:spPr>
+          <a:xfrm>
+            <a:off x="3703320" y="2907791"/>
+            <a:ext cx="3675888" cy="384048"/>
+          </a:xfrm>
+          <a:prstGeom prst="rect">
+            <a:avLst/>
+          </a:prstGeom>
+          <a:noFill/>
+        </p:spPr>
+        <p:txBody>
+          <a:bodyPr wrap="square" lIns="0" rIns="0" tIns="0" bIns="0" anchor="ctr">
+            <a:spAutoFit/>
+          </a:bodyPr>
+          <a:lstStyle/>
+          <a:p>
+            <a:pPr algn="l"/>
+            <a:r>
+              <a:rPr sz="1100" b="0" i="0">
+                <a:solidFill>
+                  <a:srgbClr val="9FB0C3"/>
+                </a:solidFill>
+                <a:latin typeface="Calibri"/>
+              </a:rPr>
+              <a:t>Ground offset across the harness between boards</a:t>
+            </a:r>
+          </a:p>
+        </p:txBody>
+      </p:sp>
+      <p:sp>
+        <p:nvSpPr>
+          <p:cNvPr id="47" name="Oval 46"/>
+          <p:cNvSpPr/>
+          <p:nvPr/>
+        </p:nvSpPr>
+        <p:spPr>
+          <a:xfrm>
+            <a:off x="7580375" y="2980944"/>
+            <a:ext cx="237744" cy="237744"/>
+          </a:xfrm>
+          <a:prstGeom prst="ellipse">
+            <a:avLst/>
+          </a:prstGeom>
+          <a:solidFill>
+            <a:srgbClr val="3FA46A"/>
+          </a:solidFill>
+          <a:ln>
+            <a:noFill/>
+          </a:ln>
+        </p:spPr>
+        <p:txBody>
+          <a:bodyPr rtlCol="0" anchor="ctr"/>
+          <a:lstStyle/>
+          <a:p>
+            <a:pPr algn="ctr"/>
+          </a:p>
+        </p:txBody>
+      </p:sp>
+      <p:sp>
+        <p:nvSpPr>
+          <p:cNvPr id="48" name="TextBox 47"/>
+          <p:cNvSpPr txBox="1"/>
+          <p:nvPr/>
+        </p:nvSpPr>
+        <p:spPr>
+          <a:xfrm>
+            <a:off x="7580375" y="2980944"/>
+            <a:ext cx="237744" cy="237744"/>
+          </a:xfrm>
+          <a:prstGeom prst="rect">
+            <a:avLst/>
+          </a:prstGeom>
+          <a:noFill/>
+        </p:spPr>
+        <p:txBody>
+          <a:bodyPr wrap="square" lIns="0" rIns="0" tIns="0" bIns="0" anchor="ctr">
+            <a:spAutoFit/>
+          </a:bodyPr>
+          <a:lstStyle/>
+          <a:p>
+            <a:pPr algn="ctr"/>
+            <a:r>
+              <a:rPr sz="1100" b="1" i="0">
+                <a:solidFill>
+                  <a:srgbClr val="EAF0F6"/>
+                </a:solidFill>
+                <a:latin typeface="Calibri"/>
+              </a:rPr>
+              <a:t>✓</a:t>
+            </a:r>
+          </a:p>
+        </p:txBody>
+      </p:sp>
+      <p:sp>
+        <p:nvSpPr>
+          <p:cNvPr id="49" name="TextBox 48"/>
+          <p:cNvSpPr txBox="1"/>
+          <p:nvPr/>
+        </p:nvSpPr>
+        <p:spPr>
+          <a:xfrm>
+            <a:off x="7927848" y="2907791"/>
+            <a:ext cx="3712464" cy="384048"/>
+          </a:xfrm>
+          <a:prstGeom prst="rect">
+            <a:avLst/>
+          </a:prstGeom>
+          <a:noFill/>
+        </p:spPr>
+        <p:txBody>
+          <a:bodyPr wrap="square" lIns="0" rIns="0" tIns="0" bIns="0" anchor="ctr">
+            <a:spAutoFit/>
+          </a:bodyPr>
+          <a:lstStyle/>
+          <a:p>
+            <a:pPr algn="l"/>
+            <a:r>
+              <a:rPr sz="1100" b="0" i="0">
+                <a:solidFill>
+                  <a:srgbClr val="EAF0F6"/>
+                </a:solidFill>
+                <a:latin typeface="Calibri"/>
+              </a:rPr>
+              <a:t>One continuous ground plane end to end</a:t>
+            </a:r>
+          </a:p>
+        </p:txBody>
+      </p:sp>
+      <p:sp>
+        <p:nvSpPr>
+          <p:cNvPr id="50" name="Rectangle 49"/>
+          <p:cNvSpPr/>
+          <p:nvPr/>
+        </p:nvSpPr>
+        <p:spPr>
+          <a:xfrm>
+            <a:off x="457200" y="3291839"/>
+            <a:ext cx="11274552" cy="384048"/>
+          </a:xfrm>
+          <a:prstGeom prst="rect">
+            <a:avLst/>
+          </a:prstGeom>
+          <a:solidFill>
+            <a:srgbClr val="172331"/>
+          </a:solidFill>
+          <a:ln>
+            <a:noFill/>
+          </a:ln>
+        </p:spPr>
+        <p:txBody>
+          <a:bodyPr rtlCol="0" anchor="ctr"/>
+          <a:lstStyle/>
+          <a:p>
+            <a:pPr algn="ctr"/>
+          </a:p>
+        </p:txBody>
+      </p:sp>
+      <p:sp>
+        <p:nvSpPr>
+          <p:cNvPr id="51" name="TextBox 50"/>
+          <p:cNvSpPr txBox="1"/>
+          <p:nvPr/>
+        </p:nvSpPr>
+        <p:spPr>
+          <a:xfrm>
+            <a:off x="566928" y="3291839"/>
+            <a:ext cx="274320" cy="384048"/>
+          </a:xfrm>
+          <a:prstGeom prst="rect">
+            <a:avLst/>
+          </a:prstGeom>
+          <a:noFill/>
+        </p:spPr>
+        <p:txBody>
+          <a:bodyPr wrap="square" lIns="0" rIns="0" tIns="0" bIns="0" anchor="ctr">
+            <a:spAutoFit/>
+          </a:bodyPr>
+          <a:lstStyle/>
+          <a:p>
+            <a:pPr algn="l"/>
+            <a:r>
+              <a:rPr sz="1100" b="0" i="0">
+                <a:solidFill>
+                  <a:srgbClr val="9FB0C3"/>
+                </a:solidFill>
+                <a:latin typeface="Calibri"/>
+              </a:rPr>
+              <a:t>5</a:t>
+            </a:r>
+          </a:p>
+        </p:txBody>
+      </p:sp>
+      <p:sp>
+        <p:nvSpPr>
+          <p:cNvPr id="52" name="TextBox 51"/>
+          <p:cNvSpPr txBox="1"/>
+          <p:nvPr/>
+        </p:nvSpPr>
+        <p:spPr>
+          <a:xfrm>
+            <a:off x="978407" y="3291839"/>
+            <a:ext cx="2194560" cy="384048"/>
+          </a:xfrm>
+          <a:prstGeom prst="rect">
+            <a:avLst/>
+          </a:prstGeom>
+          <a:noFill/>
+        </p:spPr>
+        <p:txBody>
+          <a:bodyPr wrap="square" lIns="0" rIns="0" tIns="0" bIns="0" anchor="ctr">
+            <a:spAutoFit/>
+          </a:bodyPr>
+          <a:lstStyle/>
+          <a:p>
+            <a:pPr algn="l"/>
+            <a:r>
+              <a:rPr sz="1150" b="1" i="0">
+                <a:solidFill>
+                  <a:srgbClr val="EAF0F6"/>
+                </a:solidFill>
+                <a:latin typeface="Calibri"/>
+              </a:rPr>
+              <a:t>RF immunity &amp; ESD</a:t>
+            </a:r>
+          </a:p>
+        </p:txBody>
+      </p:sp>
+      <p:sp>
+        <p:nvSpPr>
+          <p:cNvPr id="53" name="Oval 52"/>
+          <p:cNvSpPr/>
+          <p:nvPr/>
+        </p:nvSpPr>
+        <p:spPr>
+          <a:xfrm>
+            <a:off x="3355848" y="3364991"/>
+            <a:ext cx="237744" cy="237744"/>
+          </a:xfrm>
+          <a:prstGeom prst="ellipse">
+            <a:avLst/>
+          </a:prstGeom>
+          <a:solidFill>
+            <a:srgbClr val="E05D5D"/>
+          </a:solidFill>
+          <a:ln>
+            <a:noFill/>
+          </a:ln>
+        </p:spPr>
+        <p:txBody>
+          <a:bodyPr rtlCol="0" anchor="ctr"/>
+          <a:lstStyle/>
+          <a:p>
+            <a:pPr algn="ctr"/>
+          </a:p>
+        </p:txBody>
+      </p:sp>
+      <p:sp>
+        <p:nvSpPr>
+          <p:cNvPr id="54" name="TextBox 53"/>
+          <p:cNvSpPr txBox="1"/>
+          <p:nvPr/>
+        </p:nvSpPr>
+        <p:spPr>
+          <a:xfrm>
+            <a:off x="3355848" y="3364991"/>
+            <a:ext cx="237744" cy="237744"/>
+          </a:xfrm>
+          <a:prstGeom prst="rect">
+            <a:avLst/>
+          </a:prstGeom>
+          <a:noFill/>
+        </p:spPr>
+        <p:txBody>
+          <a:bodyPr wrap="square" lIns="0" rIns="0" tIns="0" bIns="0" anchor="ctr">
+            <a:spAutoFit/>
+          </a:bodyPr>
+          <a:lstStyle/>
+          <a:p>
+            <a:pPr algn="ctr"/>
+            <a:r>
+              <a:rPr sz="1100" b="1" i="0">
+                <a:solidFill>
+                  <a:srgbClr val="EAF0F6"/>
+                </a:solidFill>
+                <a:latin typeface="Calibri"/>
+              </a:rPr>
+              <a:t>✗</a:t>
+            </a:r>
+          </a:p>
+        </p:txBody>
+      </p:sp>
+      <p:sp>
+        <p:nvSpPr>
+          <p:cNvPr id="55" name="TextBox 54"/>
+          <p:cNvSpPr txBox="1"/>
+          <p:nvPr/>
+        </p:nvSpPr>
+        <p:spPr>
+          <a:xfrm>
+            <a:off x="3703320" y="3291839"/>
+            <a:ext cx="3675888" cy="384048"/>
+          </a:xfrm>
+          <a:prstGeom prst="rect">
+            <a:avLst/>
+          </a:prstGeom>
+          <a:noFill/>
+        </p:spPr>
+        <p:txBody>
+          <a:bodyPr wrap="square" lIns="0" rIns="0" tIns="0" bIns="0" anchor="ctr">
+            <a:spAutoFit/>
+          </a:bodyPr>
+          <a:lstStyle/>
+          <a:p>
+            <a:pPr algn="l"/>
+            <a:r>
+              <a:rPr sz="1100" b="0" i="0">
+                <a:solidFill>
+                  <a:srgbClr val="9FB0C3"/>
+                </a:solidFill>
+                <a:latin typeface="Calibri"/>
+              </a:rPr>
+              <a:t>Harnesses pick up RF; more ESD entry points</a:t>
+            </a:r>
+          </a:p>
+        </p:txBody>
+      </p:sp>
+      <p:sp>
+        <p:nvSpPr>
+          <p:cNvPr id="56" name="Oval 55"/>
+          <p:cNvSpPr/>
+          <p:nvPr/>
+        </p:nvSpPr>
+        <p:spPr>
+          <a:xfrm>
+            <a:off x="7580375" y="3364991"/>
+            <a:ext cx="237744" cy="237744"/>
+          </a:xfrm>
+          <a:prstGeom prst="ellipse">
+            <a:avLst/>
+          </a:prstGeom>
+          <a:solidFill>
+            <a:srgbClr val="3FA46A"/>
+          </a:solidFill>
+          <a:ln>
+            <a:noFill/>
+          </a:ln>
+        </p:spPr>
+        <p:txBody>
+          <a:bodyPr rtlCol="0" anchor="ctr"/>
+          <a:lstStyle/>
+          <a:p>
+            <a:pPr algn="ctr"/>
+          </a:p>
+        </p:txBody>
+      </p:sp>
+      <p:sp>
+        <p:nvSpPr>
+          <p:cNvPr id="57" name="TextBox 56"/>
+          <p:cNvSpPr txBox="1"/>
+          <p:nvPr/>
+        </p:nvSpPr>
+        <p:spPr>
+          <a:xfrm>
+            <a:off x="7580375" y="3364991"/>
+            <a:ext cx="237744" cy="237744"/>
+          </a:xfrm>
+          <a:prstGeom prst="rect">
+            <a:avLst/>
+          </a:prstGeom>
+          <a:noFill/>
+        </p:spPr>
+        <p:txBody>
+          <a:bodyPr wrap="square" lIns="0" rIns="0" tIns="0" bIns="0" anchor="ctr">
+            <a:spAutoFit/>
+          </a:bodyPr>
+          <a:lstStyle/>
+          <a:p>
+            <a:pPr algn="ctr"/>
+            <a:r>
+              <a:rPr sz="1100" b="1" i="0">
+                <a:solidFill>
+                  <a:srgbClr val="EAF0F6"/>
+                </a:solidFill>
+                <a:latin typeface="Calibri"/>
+              </a:rPr>
+              <a:t>✓</a:t>
+            </a:r>
+          </a:p>
+        </p:txBody>
+      </p:sp>
+      <p:sp>
+        <p:nvSpPr>
+          <p:cNvPr id="58" name="TextBox 57"/>
+          <p:cNvSpPr txBox="1"/>
+          <p:nvPr/>
+        </p:nvSpPr>
+        <p:spPr>
+          <a:xfrm>
+            <a:off x="7927848" y="3291839"/>
+            <a:ext cx="3712464" cy="384048"/>
+          </a:xfrm>
+          <a:prstGeom prst="rect">
+            <a:avLst/>
+          </a:prstGeom>
+          <a:noFill/>
+        </p:spPr>
+        <p:txBody>
+          <a:bodyPr wrap="square" lIns="0" rIns="0" tIns="0" bIns="0" anchor="ctr">
+            <a:spAutoFit/>
+          </a:bodyPr>
+          <a:lstStyle/>
+          <a:p>
+            <a:pPr algn="l"/>
+            <a:r>
+              <a:rPr sz="1100" b="0" i="0">
+                <a:solidFill>
+                  <a:srgbClr val="EAF0F6"/>
+                </a:solidFill>
+                <a:latin typeface="Calibri"/>
+              </a:rPr>
+              <a:t>Fewer conductors and interfaces to protect</a:t>
+            </a:r>
+          </a:p>
+        </p:txBody>
+      </p:sp>
+      <p:sp>
+        <p:nvSpPr>
+          <p:cNvPr id="59" name="Rectangle 58"/>
+          <p:cNvSpPr/>
+          <p:nvPr/>
+        </p:nvSpPr>
+        <p:spPr>
+          <a:xfrm>
+            <a:off x="457200" y="3675887"/>
+            <a:ext cx="11274552" cy="384048"/>
+          </a:xfrm>
+          <a:prstGeom prst="rect">
+            <a:avLst/>
+          </a:prstGeom>
+          <a:solidFill>
+            <a:srgbClr val="0E1621"/>
+          </a:solidFill>
+          <a:ln>
+            <a:noFill/>
+          </a:ln>
+        </p:spPr>
+        <p:txBody>
+          <a:bodyPr rtlCol="0" anchor="ctr"/>
+          <a:lstStyle/>
+          <a:p>
+            <a:pPr algn="ctr"/>
+          </a:p>
+        </p:txBody>
+      </p:sp>
+      <p:sp>
+        <p:nvSpPr>
+          <p:cNvPr id="60" name="TextBox 59"/>
+          <p:cNvSpPr txBox="1"/>
+          <p:nvPr/>
+        </p:nvSpPr>
+        <p:spPr>
+          <a:xfrm>
+            <a:off x="566928" y="3675887"/>
+            <a:ext cx="274320" cy="384048"/>
+          </a:xfrm>
+          <a:prstGeom prst="rect">
+            <a:avLst/>
+          </a:prstGeom>
+          <a:noFill/>
+        </p:spPr>
+        <p:txBody>
+          <a:bodyPr wrap="square" lIns="0" rIns="0" tIns="0" bIns="0" anchor="ctr">
+            <a:spAutoFit/>
+          </a:bodyPr>
+          <a:lstStyle/>
+          <a:p>
+            <a:pPr algn="l"/>
+            <a:r>
+              <a:rPr sz="1100" b="0" i="0">
+                <a:solidFill>
+                  <a:srgbClr val="9FB0C3"/>
+                </a:solidFill>
+                <a:latin typeface="Calibri"/>
+              </a:rPr>
+              <a:t>6</a:t>
+            </a:r>
+          </a:p>
+        </p:txBody>
+      </p:sp>
+      <p:sp>
+        <p:nvSpPr>
+          <p:cNvPr id="61" name="TextBox 60"/>
+          <p:cNvSpPr txBox="1"/>
+          <p:nvPr/>
+        </p:nvSpPr>
+        <p:spPr>
+          <a:xfrm>
+            <a:off x="978407" y="3675887"/>
+            <a:ext cx="2194560" cy="384048"/>
+          </a:xfrm>
+          <a:prstGeom prst="rect">
+            <a:avLst/>
+          </a:prstGeom>
+          <a:noFill/>
+        </p:spPr>
+        <p:txBody>
+          <a:bodyPr wrap="square" lIns="0" rIns="0" tIns="0" bIns="0" anchor="ctr">
+            <a:spAutoFit/>
+          </a:bodyPr>
+          <a:lstStyle/>
+          <a:p>
+            <a:pPr algn="l"/>
+            <a:r>
+              <a:rPr sz="1150" b="1" i="0">
+                <a:solidFill>
+                  <a:srgbClr val="EAF0F6"/>
+                </a:solidFill>
+                <a:latin typeface="Calibri"/>
+              </a:rPr>
+              <a:t>Connector reliability</a:t>
+            </a:r>
+          </a:p>
+        </p:txBody>
+      </p:sp>
+      <p:sp>
+        <p:nvSpPr>
+          <p:cNvPr id="62" name="Oval 61"/>
+          <p:cNvSpPr/>
+          <p:nvPr/>
+        </p:nvSpPr>
+        <p:spPr>
+          <a:xfrm>
+            <a:off x="3355848" y="3749039"/>
+            <a:ext cx="237744" cy="237744"/>
+          </a:xfrm>
+          <a:prstGeom prst="ellipse">
+            <a:avLst/>
+          </a:prstGeom>
+          <a:solidFill>
+            <a:srgbClr val="E05D5D"/>
+          </a:solidFill>
+          <a:ln>
+            <a:noFill/>
+          </a:ln>
+        </p:spPr>
+        <p:txBody>
+          <a:bodyPr rtlCol="0" anchor="ctr"/>
+          <a:lstStyle/>
+          <a:p>
+            <a:pPr algn="ctr"/>
+          </a:p>
+        </p:txBody>
+      </p:sp>
+      <p:sp>
+        <p:nvSpPr>
+          <p:cNvPr id="63" name="TextBox 62"/>
+          <p:cNvSpPr txBox="1"/>
+          <p:nvPr/>
+        </p:nvSpPr>
+        <p:spPr>
+          <a:xfrm>
+            <a:off x="3355848" y="3749039"/>
+            <a:ext cx="237744" cy="237744"/>
+          </a:xfrm>
+          <a:prstGeom prst="rect">
+            <a:avLst/>
+          </a:prstGeom>
+          <a:noFill/>
+        </p:spPr>
+        <p:txBody>
+          <a:bodyPr wrap="square" lIns="0" rIns="0" tIns="0" bIns="0" anchor="ctr">
+            <a:spAutoFit/>
+          </a:bodyPr>
+          <a:lstStyle/>
+          <a:p>
+            <a:pPr algn="ctr"/>
+            <a:r>
+              <a:rPr sz="1100" b="1" i="0">
+                <a:solidFill>
+                  <a:srgbClr val="EAF0F6"/>
+                </a:solidFill>
+                <a:latin typeface="Calibri"/>
+              </a:rPr>
+              <a:t>✗</a:t>
+            </a:r>
+          </a:p>
+        </p:txBody>
+      </p:sp>
+      <p:sp>
+        <p:nvSpPr>
+          <p:cNvPr id="64" name="TextBox 63"/>
+          <p:cNvSpPr txBox="1"/>
+          <p:nvPr/>
+        </p:nvSpPr>
+        <p:spPr>
+          <a:xfrm>
+            <a:off x="3703320" y="3675887"/>
+            <a:ext cx="3675888" cy="384048"/>
+          </a:xfrm>
+          <a:prstGeom prst="rect">
+            <a:avLst/>
+          </a:prstGeom>
+          <a:noFill/>
+        </p:spPr>
+        <p:txBody>
+          <a:bodyPr wrap="square" lIns="0" rIns="0" tIns="0" bIns="0" anchor="ctr">
+            <a:spAutoFit/>
+          </a:bodyPr>
+          <a:lstStyle/>
+          <a:p>
+            <a:pPr algn="l"/>
+            <a:r>
+              <a:rPr sz="1100" b="0" i="0">
+                <a:solidFill>
+                  <a:srgbClr val="9FB0C3"/>
+                </a:solidFill>
+                <a:latin typeface="Calibri"/>
+              </a:rPr>
+              <a:t>More connectors/crimps stressed by vibration</a:t>
+            </a:r>
+          </a:p>
+        </p:txBody>
+      </p:sp>
+      <p:sp>
+        <p:nvSpPr>
+          <p:cNvPr id="65" name="Oval 64"/>
+          <p:cNvSpPr/>
+          <p:nvPr/>
+        </p:nvSpPr>
+        <p:spPr>
+          <a:xfrm>
+            <a:off x="7580375" y="3749039"/>
+            <a:ext cx="237744" cy="237744"/>
+          </a:xfrm>
+          <a:prstGeom prst="ellipse">
+            <a:avLst/>
+          </a:prstGeom>
+          <a:solidFill>
+            <a:srgbClr val="3FA46A"/>
+          </a:solidFill>
+          <a:ln>
+            <a:noFill/>
+          </a:ln>
+        </p:spPr>
+        <p:txBody>
+          <a:bodyPr rtlCol="0" anchor="ctr"/>
+          <a:lstStyle/>
+          <a:p>
+            <a:pPr algn="ctr"/>
+          </a:p>
+        </p:txBody>
+      </p:sp>
+      <p:sp>
+        <p:nvSpPr>
+          <p:cNvPr id="66" name="TextBox 65"/>
+          <p:cNvSpPr txBox="1"/>
+          <p:nvPr/>
+        </p:nvSpPr>
+        <p:spPr>
+          <a:xfrm>
+            <a:off x="7580375" y="3749039"/>
+            <a:ext cx="237744" cy="237744"/>
+          </a:xfrm>
+          <a:prstGeom prst="rect">
+            <a:avLst/>
+          </a:prstGeom>
+          <a:noFill/>
+        </p:spPr>
+        <p:txBody>
+          <a:bodyPr wrap="square" lIns="0" rIns="0" tIns="0" bIns="0" anchor="ctr">
+            <a:spAutoFit/>
+          </a:bodyPr>
+          <a:lstStyle/>
+          <a:p>
+            <a:pPr algn="ctr"/>
+            <a:r>
+              <a:rPr sz="1100" b="1" i="0">
+                <a:solidFill>
+                  <a:srgbClr val="EAF0F6"/>
+                </a:solidFill>
+                <a:latin typeface="Calibri"/>
+              </a:rPr>
+              <a:t>✓</a:t>
+            </a:r>
+          </a:p>
+        </p:txBody>
+      </p:sp>
+      <p:sp>
+        <p:nvSpPr>
+          <p:cNvPr id="67" name="TextBox 66"/>
+          <p:cNvSpPr txBox="1"/>
+          <p:nvPr/>
+        </p:nvSpPr>
+        <p:spPr>
+          <a:xfrm>
+            <a:off x="7927848" y="3675887"/>
+            <a:ext cx="3712464" cy="384048"/>
+          </a:xfrm>
+          <a:prstGeom prst="rect">
+            <a:avLst/>
+          </a:prstGeom>
+          <a:noFill/>
+        </p:spPr>
+        <p:txBody>
+          <a:bodyPr wrap="square" lIns="0" rIns="0" tIns="0" bIns="0" anchor="ctr">
+            <a:spAutoFit/>
+          </a:bodyPr>
+          <a:lstStyle/>
+          <a:p>
+            <a:pPr algn="l"/>
+            <a:r>
+              <a:rPr sz="1100" b="0" i="0">
+                <a:solidFill>
+                  <a:srgbClr val="EAF0F6"/>
+                </a:solidFill>
+                <a:latin typeface="Calibri"/>
+              </a:rPr>
+              <a:t>Fewer interfaces, fewer failure points</a:t>
+            </a:r>
+          </a:p>
+        </p:txBody>
+      </p:sp>
+      <p:sp>
+        <p:nvSpPr>
+          <p:cNvPr id="68" name="Rectangle 67"/>
+          <p:cNvSpPr/>
+          <p:nvPr/>
+        </p:nvSpPr>
+        <p:spPr>
+          <a:xfrm>
+            <a:off x="457200" y="4059935"/>
+            <a:ext cx="11274552" cy="384048"/>
+          </a:xfrm>
+          <a:prstGeom prst="rect">
+            <a:avLst/>
+          </a:prstGeom>
+          <a:solidFill>
+            <a:srgbClr val="172331"/>
+          </a:solidFill>
+          <a:ln>
+            <a:noFill/>
+          </a:ln>
+        </p:spPr>
+        <p:txBody>
+          <a:bodyPr rtlCol="0" anchor="ctr"/>
+          <a:lstStyle/>
+          <a:p>
+            <a:pPr algn="ctr"/>
+          </a:p>
+        </p:txBody>
+      </p:sp>
+      <p:sp>
+        <p:nvSpPr>
+          <p:cNvPr id="69" name="TextBox 68"/>
+          <p:cNvSpPr txBox="1"/>
+          <p:nvPr/>
+        </p:nvSpPr>
+        <p:spPr>
+          <a:xfrm>
+            <a:off x="566928" y="4059935"/>
+            <a:ext cx="274320" cy="384048"/>
+          </a:xfrm>
+          <a:prstGeom prst="rect">
+            <a:avLst/>
+          </a:prstGeom>
+          <a:noFill/>
+        </p:spPr>
+        <p:txBody>
+          <a:bodyPr wrap="square" lIns="0" rIns="0" tIns="0" bIns="0" anchor="ctr">
+            <a:spAutoFit/>
+          </a:bodyPr>
+          <a:lstStyle/>
+          <a:p>
+            <a:pPr algn="l"/>
+            <a:r>
+              <a:rPr sz="1100" b="0" i="0">
+                <a:solidFill>
+                  <a:srgbClr val="9FB0C3"/>
+                </a:solidFill>
+                <a:latin typeface="Calibri"/>
+              </a:rPr>
+              <a:t>7</a:t>
+            </a:r>
+          </a:p>
+        </p:txBody>
+      </p:sp>
+      <p:sp>
+        <p:nvSpPr>
+          <p:cNvPr id="70" name="TextBox 69"/>
+          <p:cNvSpPr txBox="1"/>
+          <p:nvPr/>
+        </p:nvSpPr>
+        <p:spPr>
+          <a:xfrm>
+            <a:off x="978407" y="4059935"/>
+            <a:ext cx="2194560" cy="384048"/>
+          </a:xfrm>
+          <a:prstGeom prst="rect">
+            <a:avLst/>
+          </a:prstGeom>
+          <a:noFill/>
+        </p:spPr>
+        <p:txBody>
+          <a:bodyPr wrap="square" lIns="0" rIns="0" tIns="0" bIns="0" anchor="ctr">
+            <a:spAutoFit/>
+          </a:bodyPr>
+          <a:lstStyle/>
+          <a:p>
+            <a:pPr algn="l"/>
+            <a:r>
+              <a:rPr sz="1150" b="1" i="0">
+                <a:solidFill>
+                  <a:srgbClr val="EAF0F6"/>
+                </a:solidFill>
+                <a:latin typeface="Calibri"/>
+              </a:rPr>
+              <a:t>BOM &amp; assembly</a:t>
+            </a:r>
+          </a:p>
+        </p:txBody>
+      </p:sp>
+      <p:sp>
+        <p:nvSpPr>
+          <p:cNvPr id="71" name="Oval 70"/>
+          <p:cNvSpPr/>
+          <p:nvPr/>
+        </p:nvSpPr>
+        <p:spPr>
+          <a:xfrm>
+            <a:off x="3355848" y="4133087"/>
+            <a:ext cx="237744" cy="237744"/>
+          </a:xfrm>
+          <a:prstGeom prst="ellipse">
+            <a:avLst/>
+          </a:prstGeom>
+          <a:solidFill>
+            <a:srgbClr val="E05D5D"/>
+          </a:solidFill>
+          <a:ln>
+            <a:noFill/>
+          </a:ln>
+        </p:spPr>
+        <p:txBody>
+          <a:bodyPr rtlCol="0" anchor="ctr"/>
+          <a:lstStyle/>
+          <a:p>
+            <a:pPr algn="ctr"/>
+          </a:p>
+        </p:txBody>
+      </p:sp>
+      <p:sp>
+        <p:nvSpPr>
+          <p:cNvPr id="72" name="TextBox 71"/>
+          <p:cNvSpPr txBox="1"/>
+          <p:nvPr/>
+        </p:nvSpPr>
+        <p:spPr>
+          <a:xfrm>
+            <a:off x="3355848" y="4133087"/>
+            <a:ext cx="237744" cy="237744"/>
+          </a:xfrm>
+          <a:prstGeom prst="rect">
+            <a:avLst/>
+          </a:prstGeom>
+          <a:noFill/>
+        </p:spPr>
+        <p:txBody>
+          <a:bodyPr wrap="square" lIns="0" rIns="0" tIns="0" bIns="0" anchor="ctr">
+            <a:spAutoFit/>
+          </a:bodyPr>
+          <a:lstStyle/>
+          <a:p>
+            <a:pPr algn="ctr"/>
+            <a:r>
+              <a:rPr sz="1100" b="1" i="0">
+                <a:solidFill>
+                  <a:srgbClr val="EAF0F6"/>
+                </a:solidFill>
+                <a:latin typeface="Calibri"/>
+              </a:rPr>
+              <a:t>✗</a:t>
+            </a:r>
+          </a:p>
+        </p:txBody>
+      </p:sp>
+      <p:sp>
+        <p:nvSpPr>
+          <p:cNvPr id="73" name="TextBox 72"/>
+          <p:cNvSpPr txBox="1"/>
+          <p:nvPr/>
+        </p:nvSpPr>
+        <p:spPr>
+          <a:xfrm>
+            <a:off x="3703320" y="4059935"/>
+            <a:ext cx="3675888" cy="384048"/>
+          </a:xfrm>
+          <a:prstGeom prst="rect">
+            <a:avLst/>
+          </a:prstGeom>
+          <a:noFill/>
+        </p:spPr>
+        <p:txBody>
+          <a:bodyPr wrap="square" lIns="0" rIns="0" tIns="0" bIns="0" anchor="ctr">
+            <a:spAutoFit/>
+          </a:bodyPr>
+          <a:lstStyle/>
+          <a:p>
+            <a:pPr algn="l"/>
+            <a:r>
+              <a:rPr sz="1100" b="0" i="0">
+                <a:solidFill>
+                  <a:srgbClr val="9FB0C3"/>
+                </a:solidFill>
+                <a:latin typeface="Calibri"/>
+              </a:rPr>
+              <a:t>Extra connectors, wires, terminals, 3 PCBs</a:t>
+            </a:r>
+          </a:p>
+        </p:txBody>
+      </p:sp>
+      <p:sp>
+        <p:nvSpPr>
+          <p:cNvPr id="74" name="Oval 73"/>
+          <p:cNvSpPr/>
+          <p:nvPr/>
+        </p:nvSpPr>
+        <p:spPr>
+          <a:xfrm>
+            <a:off x="7580375" y="4133087"/>
+            <a:ext cx="237744" cy="237744"/>
+          </a:xfrm>
+          <a:prstGeom prst="ellipse">
+            <a:avLst/>
+          </a:prstGeom>
+          <a:solidFill>
+            <a:srgbClr val="3FA46A"/>
+          </a:solidFill>
+          <a:ln>
+            <a:noFill/>
+          </a:ln>
+        </p:spPr>
+        <p:txBody>
+          <a:bodyPr rtlCol="0" anchor="ctr"/>
+          <a:lstStyle/>
+          <a:p>
+            <a:pPr algn="ctr"/>
+          </a:p>
+        </p:txBody>
+      </p:sp>
+      <p:sp>
+        <p:nvSpPr>
+          <p:cNvPr id="75" name="TextBox 74"/>
+          <p:cNvSpPr txBox="1"/>
+          <p:nvPr/>
+        </p:nvSpPr>
+        <p:spPr>
+          <a:xfrm>
+            <a:off x="7580375" y="4133087"/>
+            <a:ext cx="237744" cy="237744"/>
+          </a:xfrm>
+          <a:prstGeom prst="rect">
+            <a:avLst/>
+          </a:prstGeom>
+          <a:noFill/>
+        </p:spPr>
+        <p:txBody>
+          <a:bodyPr wrap="square" lIns="0" rIns="0" tIns="0" bIns="0" anchor="ctr">
+            <a:spAutoFit/>
+          </a:bodyPr>
+          <a:lstStyle/>
+          <a:p>
+            <a:pPr algn="ctr"/>
+            <a:r>
+              <a:rPr sz="1100" b="1" i="0">
+                <a:solidFill>
+                  <a:srgbClr val="EAF0F6"/>
+                </a:solidFill>
+                <a:latin typeface="Calibri"/>
+              </a:rPr>
+              <a:t>✓</a:t>
+            </a:r>
+          </a:p>
+        </p:txBody>
+      </p:sp>
+      <p:sp>
+        <p:nvSpPr>
+          <p:cNvPr id="76" name="TextBox 75"/>
+          <p:cNvSpPr txBox="1"/>
+          <p:nvPr/>
+        </p:nvSpPr>
+        <p:spPr>
+          <a:xfrm>
+            <a:off x="7927848" y="4059935"/>
+            <a:ext cx="3712464" cy="384048"/>
+          </a:xfrm>
+          <a:prstGeom prst="rect">
+            <a:avLst/>
+          </a:prstGeom>
+          <a:noFill/>
+        </p:spPr>
+        <p:txBody>
+          <a:bodyPr wrap="square" lIns="0" rIns="0" tIns="0" bIns="0" anchor="ctr">
+            <a:spAutoFit/>
+          </a:bodyPr>
+          <a:lstStyle/>
+          <a:p>
+            <a:pPr algn="l"/>
+            <a:r>
+              <a:rPr sz="1100" b="0" i="0">
+                <a:solidFill>
+                  <a:srgbClr val="EAF0F6"/>
+                </a:solidFill>
+                <a:latin typeface="Calibri"/>
+              </a:rPr>
+              <a:t>One part number, single assembly step</a:t>
+            </a:r>
+          </a:p>
+        </p:txBody>
+      </p:sp>
+      <p:sp>
+        <p:nvSpPr>
+          <p:cNvPr id="77" name="Rectangle 76"/>
+          <p:cNvSpPr/>
+          <p:nvPr/>
+        </p:nvSpPr>
+        <p:spPr>
+          <a:xfrm>
+            <a:off x="457200" y="4443983"/>
+            <a:ext cx="11274552" cy="384048"/>
+          </a:xfrm>
+          <a:prstGeom prst="rect">
+            <a:avLst/>
+          </a:prstGeom>
+          <a:solidFill>
+            <a:srgbClr val="0E1621"/>
+          </a:solidFill>
+          <a:ln>
+            <a:noFill/>
+          </a:ln>
+        </p:spPr>
+        <p:txBody>
+          <a:bodyPr rtlCol="0" anchor="ctr"/>
+          <a:lstStyle/>
+          <a:p>
+            <a:pPr algn="ctr"/>
+          </a:p>
+        </p:txBody>
+      </p:sp>
+      <p:sp>
+        <p:nvSpPr>
+          <p:cNvPr id="78" name="TextBox 77"/>
+          <p:cNvSpPr txBox="1"/>
+          <p:nvPr/>
+        </p:nvSpPr>
+        <p:spPr>
+          <a:xfrm>
+            <a:off x="566928" y="4443983"/>
+            <a:ext cx="274320" cy="384048"/>
+          </a:xfrm>
+          <a:prstGeom prst="rect">
+            <a:avLst/>
+          </a:prstGeom>
+          <a:noFill/>
+        </p:spPr>
+        <p:txBody>
+          <a:bodyPr wrap="square" lIns="0" rIns="0" tIns="0" bIns="0" anchor="ctr">
+            <a:spAutoFit/>
+          </a:bodyPr>
+          <a:lstStyle/>
+          <a:p>
+            <a:pPr algn="l"/>
+            <a:r>
+              <a:rPr sz="1100" b="0" i="0">
+                <a:solidFill>
+                  <a:srgbClr val="9FB0C3"/>
+                </a:solidFill>
+                <a:latin typeface="Calibri"/>
+              </a:rPr>
+              <a:t>8</a:t>
+            </a:r>
+          </a:p>
+        </p:txBody>
+      </p:sp>
+      <p:sp>
+        <p:nvSpPr>
+          <p:cNvPr id="79" name="TextBox 78"/>
+          <p:cNvSpPr txBox="1"/>
+          <p:nvPr/>
+        </p:nvSpPr>
+        <p:spPr>
+          <a:xfrm>
+            <a:off x="978407" y="4443983"/>
+            <a:ext cx="2194560" cy="384048"/>
+          </a:xfrm>
+          <a:prstGeom prst="rect">
+            <a:avLst/>
+          </a:prstGeom>
+          <a:noFill/>
+        </p:spPr>
+        <p:txBody>
+          <a:bodyPr wrap="square" lIns="0" rIns="0" tIns="0" bIns="0" anchor="ctr">
+            <a:spAutoFit/>
+          </a:bodyPr>
+          <a:lstStyle/>
+          <a:p>
+            <a:pPr algn="l"/>
+            <a:r>
+              <a:rPr sz="1150" b="1" i="0">
+                <a:solidFill>
+                  <a:srgbClr val="EAF0F6"/>
+                </a:solidFill>
+                <a:latin typeface="Calibri"/>
+              </a:rPr>
+              <a:t>Panel utilization</a:t>
+            </a:r>
+          </a:p>
+        </p:txBody>
+      </p:sp>
+      <p:sp>
+        <p:nvSpPr>
+          <p:cNvPr id="80" name="Oval 79"/>
+          <p:cNvSpPr/>
+          <p:nvPr/>
+        </p:nvSpPr>
+        <p:spPr>
+          <a:xfrm>
+            <a:off x="3355848" y="4517136"/>
+            <a:ext cx="237744" cy="237744"/>
+          </a:xfrm>
+          <a:prstGeom prst="ellipse">
+            <a:avLst/>
+          </a:prstGeom>
+          <a:solidFill>
+            <a:srgbClr val="3FA46A"/>
+          </a:solidFill>
+          <a:ln>
+            <a:noFill/>
+          </a:ln>
+        </p:spPr>
+        <p:txBody>
+          <a:bodyPr rtlCol="0" anchor="ctr"/>
+          <a:lstStyle/>
+          <a:p>
+            <a:pPr algn="ctr"/>
+          </a:p>
+        </p:txBody>
+      </p:sp>
+      <p:sp>
+        <p:nvSpPr>
+          <p:cNvPr id="81" name="TextBox 80"/>
+          <p:cNvSpPr txBox="1"/>
+          <p:nvPr/>
+        </p:nvSpPr>
+        <p:spPr>
+          <a:xfrm>
+            <a:off x="3355848" y="4517136"/>
+            <a:ext cx="237744" cy="237744"/>
+          </a:xfrm>
+          <a:prstGeom prst="rect">
+            <a:avLst/>
+          </a:prstGeom>
+          <a:noFill/>
+        </p:spPr>
+        <p:txBody>
+          <a:bodyPr wrap="square" lIns="0" rIns="0" tIns="0" bIns="0" anchor="ctr">
+            <a:spAutoFit/>
+          </a:bodyPr>
+          <a:lstStyle/>
+          <a:p>
+            <a:pPr algn="ctr"/>
+            <a:r>
+              <a:rPr sz="1100" b="1" i="0">
+                <a:solidFill>
+                  <a:srgbClr val="EAF0F6"/>
+                </a:solidFill>
+                <a:latin typeface="Calibri"/>
+              </a:rPr>
+              <a:t>✓</a:t>
+            </a:r>
+          </a:p>
+        </p:txBody>
+      </p:sp>
+      <p:sp>
+        <p:nvSpPr>
+          <p:cNvPr id="82" name="TextBox 81"/>
+          <p:cNvSpPr txBox="1"/>
+          <p:nvPr/>
+        </p:nvSpPr>
+        <p:spPr>
+          <a:xfrm>
+            <a:off x="3703320" y="4443983"/>
+            <a:ext cx="3675888" cy="384048"/>
+          </a:xfrm>
+          <a:prstGeom prst="rect">
+            <a:avLst/>
+          </a:prstGeom>
+          <a:noFill/>
+        </p:spPr>
+        <p:txBody>
+          <a:bodyPr wrap="square" lIns="0" rIns="0" tIns="0" bIns="0" anchor="ctr">
+            <a:spAutoFit/>
+          </a:bodyPr>
+          <a:lstStyle/>
+          <a:p>
+            <a:pPr algn="l"/>
+            <a:r>
+              <a:rPr sz="1100" b="0" i="0">
+                <a:solidFill>
+                  <a:srgbClr val="EAF0F6"/>
+                </a:solidFill>
+                <a:latin typeface="Calibri"/>
+              </a:rPr>
+              <a:t>Small rectangular boards nest efficiently</a:t>
+            </a:r>
+          </a:p>
+        </p:txBody>
+      </p:sp>
+      <p:sp>
+        <p:nvSpPr>
+          <p:cNvPr id="83" name="Oval 82"/>
+          <p:cNvSpPr/>
+          <p:nvPr/>
+        </p:nvSpPr>
+        <p:spPr>
+          <a:xfrm>
+            <a:off x="7580375" y="4517136"/>
+            <a:ext cx="237744" cy="237744"/>
+          </a:xfrm>
+          <a:prstGeom prst="ellipse">
+            <a:avLst/>
+          </a:prstGeom>
+          <a:solidFill>
+            <a:srgbClr val="E05D5D"/>
+          </a:solidFill>
+          <a:ln>
+            <a:noFill/>
+          </a:ln>
+        </p:spPr>
+        <p:txBody>
+          <a:bodyPr rtlCol="0" anchor="ctr"/>
+          <a:lstStyle/>
+          <a:p>
+            <a:pPr algn="ctr"/>
+          </a:p>
+        </p:txBody>
+      </p:sp>
+      <p:sp>
+        <p:nvSpPr>
+          <p:cNvPr id="84" name="TextBox 83"/>
+          <p:cNvSpPr txBox="1"/>
+          <p:nvPr/>
+        </p:nvSpPr>
+        <p:spPr>
+          <a:xfrm>
+            <a:off x="7580375" y="4517136"/>
+            <a:ext cx="237744" cy="237744"/>
+          </a:xfrm>
+          <a:prstGeom prst="rect">
+            <a:avLst/>
+          </a:prstGeom>
+          <a:noFill/>
+        </p:spPr>
+        <p:txBody>
+          <a:bodyPr wrap="square" lIns="0" rIns="0" tIns="0" bIns="0" anchor="ctr">
+            <a:spAutoFit/>
+          </a:bodyPr>
+          <a:lstStyle/>
+          <a:p>
+            <a:pPr algn="ctr"/>
+            <a:r>
+              <a:rPr sz="1100" b="1" i="0">
+                <a:solidFill>
+                  <a:srgbClr val="EAF0F6"/>
+                </a:solidFill>
+                <a:latin typeface="Calibri"/>
+              </a:rPr>
+              <a:t>✗</a:t>
+            </a:r>
+          </a:p>
+        </p:txBody>
+      </p:sp>
+      <p:sp>
+        <p:nvSpPr>
+          <p:cNvPr id="85" name="TextBox 84"/>
+          <p:cNvSpPr txBox="1"/>
+          <p:nvPr/>
+        </p:nvSpPr>
+        <p:spPr>
+          <a:xfrm>
+            <a:off x="7927848" y="4443983"/>
+            <a:ext cx="3712464" cy="384048"/>
+          </a:xfrm>
+          <a:prstGeom prst="rect">
+            <a:avLst/>
+          </a:prstGeom>
+          <a:noFill/>
+        </p:spPr>
+        <p:txBody>
+          <a:bodyPr wrap="square" lIns="0" rIns="0" tIns="0" bIns="0" anchor="ctr">
+            <a:spAutoFit/>
+          </a:bodyPr>
+          <a:lstStyle/>
+          <a:p>
+            <a:pPr algn="l"/>
+            <a:r>
+              <a:rPr sz="1100" b="0" i="0">
+                <a:solidFill>
+                  <a:srgbClr val="9FB0C3"/>
+                </a:solidFill>
+                <a:latin typeface="Calibri"/>
+              </a:rPr>
+              <a:t>C-outline leaves unused panel area</a:t>
+            </a:r>
+          </a:p>
+        </p:txBody>
+      </p:sp>
+      <p:sp>
+        <p:nvSpPr>
+          <p:cNvPr id="86" name="Rectangle 85"/>
+          <p:cNvSpPr/>
+          <p:nvPr/>
+        </p:nvSpPr>
+        <p:spPr>
+          <a:xfrm>
+            <a:off x="457200" y="4828031"/>
+            <a:ext cx="11274552" cy="384048"/>
+          </a:xfrm>
+          <a:prstGeom prst="rect">
+            <a:avLst/>
+          </a:prstGeom>
+          <a:solidFill>
+            <a:srgbClr val="172331"/>
+          </a:solidFill>
+          <a:ln>
+            <a:noFill/>
+          </a:ln>
+        </p:spPr>
+        <p:txBody>
+          <a:bodyPr rtlCol="0" anchor="ctr"/>
+          <a:lstStyle/>
+          <a:p>
+            <a:pPr algn="ctr"/>
+          </a:p>
+        </p:txBody>
+      </p:sp>
+      <p:sp>
+        <p:nvSpPr>
+          <p:cNvPr id="87" name="TextBox 86"/>
+          <p:cNvSpPr txBox="1"/>
+          <p:nvPr/>
+        </p:nvSpPr>
+        <p:spPr>
+          <a:xfrm>
+            <a:off x="566928" y="4828031"/>
+            <a:ext cx="274320" cy="384048"/>
+          </a:xfrm>
+          <a:prstGeom prst="rect">
+            <a:avLst/>
+          </a:prstGeom>
+          <a:noFill/>
+        </p:spPr>
+        <p:txBody>
+          <a:bodyPr wrap="square" lIns="0" rIns="0" tIns="0" bIns="0" anchor="ctr">
+            <a:spAutoFit/>
+          </a:bodyPr>
+          <a:lstStyle/>
+          <a:p>
+            <a:pPr algn="l"/>
+            <a:r>
+              <a:rPr sz="1100" b="0" i="0">
+                <a:solidFill>
+                  <a:srgbClr val="9FB0C3"/>
+                </a:solidFill>
+                <a:latin typeface="Calibri"/>
+              </a:rPr>
+              <a:t>9</a:t>
+            </a:r>
+          </a:p>
+        </p:txBody>
+      </p:sp>
+      <p:sp>
+        <p:nvSpPr>
+          <p:cNvPr id="88" name="TextBox 87"/>
+          <p:cNvSpPr txBox="1"/>
+          <p:nvPr/>
+        </p:nvSpPr>
+        <p:spPr>
+          <a:xfrm>
+            <a:off x="978407" y="4828031"/>
+            <a:ext cx="2194560" cy="384048"/>
+          </a:xfrm>
+          <a:prstGeom prst="rect">
+            <a:avLst/>
+          </a:prstGeom>
+          <a:noFill/>
+        </p:spPr>
+        <p:txBody>
+          <a:bodyPr wrap="square" lIns="0" rIns="0" tIns="0" bIns="0" anchor="ctr">
+            <a:spAutoFit/>
+          </a:bodyPr>
+          <a:lstStyle/>
+          <a:p>
+            <a:pPr algn="l"/>
+            <a:r>
+              <a:rPr sz="1150" b="1" i="0">
+                <a:solidFill>
+                  <a:srgbClr val="EAF0F6"/>
+                </a:solidFill>
+                <a:latin typeface="Calibri"/>
+              </a:rPr>
+              <a:t>Warpage &amp; depaneling ★</a:t>
+            </a:r>
+          </a:p>
+        </p:txBody>
+      </p:sp>
+      <p:sp>
+        <p:nvSpPr>
+          <p:cNvPr id="89" name="Oval 88"/>
+          <p:cNvSpPr/>
+          <p:nvPr/>
+        </p:nvSpPr>
+        <p:spPr>
+          <a:xfrm>
+            <a:off x="3355848" y="4901183"/>
+            <a:ext cx="237744" cy="237744"/>
+          </a:xfrm>
+          <a:prstGeom prst="ellipse">
+            <a:avLst/>
+          </a:prstGeom>
+          <a:solidFill>
+            <a:srgbClr val="3FA46A"/>
+          </a:solidFill>
+          <a:ln>
+            <a:noFill/>
+          </a:ln>
+        </p:spPr>
+        <p:txBody>
+          <a:bodyPr rtlCol="0" anchor="ctr"/>
+          <a:lstStyle/>
+          <a:p>
+            <a:pPr algn="ctr"/>
+          </a:p>
+        </p:txBody>
+      </p:sp>
+      <p:sp>
+        <p:nvSpPr>
+          <p:cNvPr id="90" name="TextBox 89"/>
+          <p:cNvSpPr txBox="1"/>
+          <p:nvPr/>
+        </p:nvSpPr>
+        <p:spPr>
+          <a:xfrm>
+            <a:off x="3355848" y="4901183"/>
+            <a:ext cx="237744" cy="237744"/>
+          </a:xfrm>
+          <a:prstGeom prst="rect">
+            <a:avLst/>
+          </a:prstGeom>
+          <a:noFill/>
+        </p:spPr>
+        <p:txBody>
+          <a:bodyPr wrap="square" lIns="0" rIns="0" tIns="0" bIns="0" anchor="ctr">
+            <a:spAutoFit/>
+          </a:bodyPr>
+          <a:lstStyle/>
+          <a:p>
+            <a:pPr algn="ctr"/>
+            <a:r>
+              <a:rPr sz="1100" b="1" i="0">
+                <a:solidFill>
+                  <a:srgbClr val="EAF0F6"/>
+                </a:solidFill>
+                <a:latin typeface="Calibri"/>
+              </a:rPr>
+              <a:t>✓</a:t>
+            </a:r>
+          </a:p>
+        </p:txBody>
+      </p:sp>
+      <p:sp>
+        <p:nvSpPr>
+          <p:cNvPr id="91" name="TextBox 90"/>
+          <p:cNvSpPr txBox="1"/>
+          <p:nvPr/>
+        </p:nvSpPr>
+        <p:spPr>
+          <a:xfrm>
+            <a:off x="3703320" y="4828031"/>
+            <a:ext cx="3675888" cy="384048"/>
+          </a:xfrm>
+          <a:prstGeom prst="rect">
+            <a:avLst/>
+          </a:prstGeom>
+          <a:noFill/>
+        </p:spPr>
+        <p:txBody>
+          <a:bodyPr wrap="square" lIns="0" rIns="0" tIns="0" bIns="0" anchor="ctr">
+            <a:spAutoFit/>
+          </a:bodyPr>
+          <a:lstStyle/>
+          <a:p>
+            <a:pPr algn="l"/>
+            <a:r>
+              <a:rPr sz="1100" b="0" i="0">
+                <a:solidFill>
+                  <a:srgbClr val="EAF0F6"/>
+                </a:solidFill>
+                <a:latin typeface="Calibri"/>
+              </a:rPr>
+              <a:t>Short boards stay flat; low joint stress</a:t>
+            </a:r>
+          </a:p>
+        </p:txBody>
+      </p:sp>
+      <p:sp>
+        <p:nvSpPr>
+          <p:cNvPr id="92" name="Oval 91"/>
+          <p:cNvSpPr/>
+          <p:nvPr/>
+        </p:nvSpPr>
+        <p:spPr>
+          <a:xfrm>
+            <a:off x="7580375" y="4901183"/>
+            <a:ext cx="237744" cy="237744"/>
+          </a:xfrm>
+          <a:prstGeom prst="ellipse">
+            <a:avLst/>
+          </a:prstGeom>
+          <a:solidFill>
+            <a:srgbClr val="E05D5D"/>
+          </a:solidFill>
+          <a:ln>
+            <a:noFill/>
+          </a:ln>
+        </p:spPr>
+        <p:txBody>
+          <a:bodyPr rtlCol="0" anchor="ctr"/>
+          <a:lstStyle/>
+          <a:p>
+            <a:pPr algn="ctr"/>
+          </a:p>
+        </p:txBody>
+      </p:sp>
+      <p:sp>
+        <p:nvSpPr>
+          <p:cNvPr id="93" name="TextBox 92"/>
+          <p:cNvSpPr txBox="1"/>
+          <p:nvPr/>
+        </p:nvSpPr>
+        <p:spPr>
+          <a:xfrm>
+            <a:off x="7580375" y="4901183"/>
+            <a:ext cx="237744" cy="237744"/>
+          </a:xfrm>
+          <a:prstGeom prst="rect">
+            <a:avLst/>
+          </a:prstGeom>
+          <a:noFill/>
+        </p:spPr>
+        <p:txBody>
+          <a:bodyPr wrap="square" lIns="0" rIns="0" tIns="0" bIns="0" anchor="ctr">
+            <a:spAutoFit/>
+          </a:bodyPr>
+          <a:lstStyle/>
+          <a:p>
+            <a:pPr algn="ctr"/>
+            <a:r>
+              <a:rPr sz="1100" b="1" i="0">
+                <a:solidFill>
+                  <a:srgbClr val="EAF0F6"/>
+                </a:solidFill>
+                <a:latin typeface="Calibri"/>
+              </a:rPr>
+              <a:t>✗</a:t>
+            </a:r>
+          </a:p>
+        </p:txBody>
+      </p:sp>
+      <p:sp>
+        <p:nvSpPr>
+          <p:cNvPr id="94" name="TextBox 93"/>
+          <p:cNvSpPr txBox="1"/>
+          <p:nvPr/>
+        </p:nvSpPr>
+        <p:spPr>
+          <a:xfrm>
+            <a:off x="7927848" y="4828031"/>
+            <a:ext cx="3712464" cy="384048"/>
+          </a:xfrm>
+          <a:prstGeom prst="rect">
+            <a:avLst/>
+          </a:prstGeom>
+          <a:noFill/>
+        </p:spPr>
+        <p:txBody>
+          <a:bodyPr wrap="square" lIns="0" rIns="0" tIns="0" bIns="0" anchor="ctr">
+            <a:spAutoFit/>
+          </a:bodyPr>
+          <a:lstStyle/>
+          <a:p>
+            <a:pPr algn="l"/>
+            <a:r>
+              <a:rPr sz="1100" b="0" i="0">
+                <a:solidFill>
+                  <a:srgbClr val="9FB0C3"/>
+                </a:solidFill>
+                <a:latin typeface="Calibri"/>
+              </a:rPr>
+              <a:t>Long C-shape can warp, stressing LED joints</a:t>
+            </a:r>
+          </a:p>
+        </p:txBody>
+      </p:sp>
+      <p:sp>
+        <p:nvSpPr>
+          <p:cNvPr id="95" name="Rectangle 94"/>
+          <p:cNvSpPr/>
+          <p:nvPr/>
+        </p:nvSpPr>
+        <p:spPr>
+          <a:xfrm>
+            <a:off x="457200" y="5212079"/>
+            <a:ext cx="11274552" cy="384048"/>
+          </a:xfrm>
+          <a:prstGeom prst="rect">
+            <a:avLst/>
+          </a:prstGeom>
+          <a:solidFill>
+            <a:srgbClr val="0E1621"/>
+          </a:solidFill>
+          <a:ln>
+            <a:noFill/>
+          </a:ln>
+        </p:spPr>
+        <p:txBody>
+          <a:bodyPr rtlCol="0" anchor="ctr"/>
+          <a:lstStyle/>
+          <a:p>
+            <a:pPr algn="ctr"/>
+          </a:p>
+        </p:txBody>
+      </p:sp>
+      <p:sp>
+        <p:nvSpPr>
+          <p:cNvPr id="96" name="TextBox 95"/>
+          <p:cNvSpPr txBox="1"/>
+          <p:nvPr/>
+        </p:nvSpPr>
+        <p:spPr>
+          <a:xfrm>
+            <a:off x="566928" y="5212079"/>
+            <a:ext cx="274320" cy="384048"/>
+          </a:xfrm>
+          <a:prstGeom prst="rect">
+            <a:avLst/>
+          </a:prstGeom>
+          <a:noFill/>
+        </p:spPr>
+        <p:txBody>
+          <a:bodyPr wrap="square" lIns="0" rIns="0" tIns="0" bIns="0" anchor="ctr">
+            <a:spAutoFit/>
+          </a:bodyPr>
+          <a:lstStyle/>
+          <a:p>
+            <a:pPr algn="l"/>
+            <a:r>
+              <a:rPr sz="1100" b="0" i="0">
+                <a:solidFill>
+                  <a:srgbClr val="9FB0C3"/>
+                </a:solidFill>
+                <a:latin typeface="Calibri"/>
+              </a:rPr>
+              <a:t>10</a:t>
+            </a:r>
+          </a:p>
+        </p:txBody>
+      </p:sp>
+      <p:sp>
+        <p:nvSpPr>
+          <p:cNvPr id="97" name="TextBox 96"/>
+          <p:cNvSpPr txBox="1"/>
+          <p:nvPr/>
+        </p:nvSpPr>
+        <p:spPr>
+          <a:xfrm>
+            <a:off x="978407" y="5212079"/>
+            <a:ext cx="2194560" cy="384048"/>
+          </a:xfrm>
+          <a:prstGeom prst="rect">
+            <a:avLst/>
+          </a:prstGeom>
+          <a:noFill/>
+        </p:spPr>
+        <p:txBody>
+          <a:bodyPr wrap="square" lIns="0" rIns="0" tIns="0" bIns="0" anchor="ctr">
+            <a:spAutoFit/>
+          </a:bodyPr>
+          <a:lstStyle/>
+          <a:p>
+            <a:pPr algn="l"/>
+            <a:r>
+              <a:rPr sz="1150" b="1" i="0">
+                <a:solidFill>
+                  <a:srgbClr val="EAF0F6"/>
+                </a:solidFill>
+                <a:latin typeface="Calibri"/>
+              </a:rPr>
+              <a:t>Mechanical fit &amp; service</a:t>
+            </a:r>
+          </a:p>
+        </p:txBody>
+      </p:sp>
+      <p:sp>
+        <p:nvSpPr>
+          <p:cNvPr id="98" name="Oval 97"/>
+          <p:cNvSpPr/>
+          <p:nvPr/>
+        </p:nvSpPr>
+        <p:spPr>
+          <a:xfrm>
+            <a:off x="3355848" y="5285231"/>
+            <a:ext cx="237744" cy="237744"/>
+          </a:xfrm>
+          <a:prstGeom prst="ellipse">
+            <a:avLst/>
+          </a:prstGeom>
+          <a:solidFill>
+            <a:srgbClr val="3FA46A"/>
+          </a:solidFill>
+          <a:ln>
+            <a:noFill/>
+          </a:ln>
+        </p:spPr>
+        <p:txBody>
+          <a:bodyPr rtlCol="0" anchor="ctr"/>
+          <a:lstStyle/>
+          <a:p>
+            <a:pPr algn="ctr"/>
+          </a:p>
+        </p:txBody>
+      </p:sp>
+      <p:sp>
+        <p:nvSpPr>
+          <p:cNvPr id="99" name="TextBox 98"/>
+          <p:cNvSpPr txBox="1"/>
+          <p:nvPr/>
+        </p:nvSpPr>
+        <p:spPr>
+          <a:xfrm>
+            <a:off x="3355848" y="5285231"/>
+            <a:ext cx="237744" cy="237744"/>
+          </a:xfrm>
+          <a:prstGeom prst="rect">
+            <a:avLst/>
+          </a:prstGeom>
+          <a:noFill/>
+        </p:spPr>
+        <p:txBody>
+          <a:bodyPr wrap="square" lIns="0" rIns="0" tIns="0" bIns="0" anchor="ctr">
+            <a:spAutoFit/>
+          </a:bodyPr>
+          <a:lstStyle/>
+          <a:p>
+            <a:pPr algn="ctr"/>
+            <a:r>
+              <a:rPr sz="1100" b="1" i="0">
+                <a:solidFill>
+                  <a:srgbClr val="EAF0F6"/>
+                </a:solidFill>
+                <a:latin typeface="Calibri"/>
+              </a:rPr>
+              <a:t>✓</a:t>
+            </a:r>
+          </a:p>
+        </p:txBody>
+      </p:sp>
+      <p:sp>
+        <p:nvSpPr>
+          <p:cNvPr id="100" name="TextBox 99"/>
+          <p:cNvSpPr txBox="1"/>
+          <p:nvPr/>
+        </p:nvSpPr>
+        <p:spPr>
+          <a:xfrm>
+            <a:off x="3703320" y="5212079"/>
+            <a:ext cx="3675888" cy="384048"/>
+          </a:xfrm>
+          <a:prstGeom prst="rect">
+            <a:avLst/>
+          </a:prstGeom>
+          <a:noFill/>
+        </p:spPr>
+        <p:txBody>
+          <a:bodyPr wrap="square" lIns="0" rIns="0" tIns="0" bIns="0" anchor="ctr">
+            <a:spAutoFit/>
+          </a:bodyPr>
+          <a:lstStyle/>
+          <a:p>
+            <a:pPr algn="l"/>
+            <a:r>
+              <a:rPr sz="1100" b="0" i="0">
+                <a:solidFill>
+                  <a:srgbClr val="EAF0F6"/>
+                </a:solidFill>
+                <a:latin typeface="Calibri"/>
+              </a:rPr>
+              <a:t>Boards placed and replaced independently</a:t>
+            </a:r>
+          </a:p>
+        </p:txBody>
+      </p:sp>
+      <p:sp>
+        <p:nvSpPr>
+          <p:cNvPr id="101" name="Oval 100"/>
+          <p:cNvSpPr/>
+          <p:nvPr/>
+        </p:nvSpPr>
+        <p:spPr>
+          <a:xfrm>
+            <a:off x="7580375" y="5285231"/>
+            <a:ext cx="237744" cy="237744"/>
+          </a:xfrm>
+          <a:prstGeom prst="ellipse">
+            <a:avLst/>
+          </a:prstGeom>
+          <a:solidFill>
+            <a:srgbClr val="E05D5D"/>
+          </a:solidFill>
+          <a:ln>
+            <a:noFill/>
+          </a:ln>
+        </p:spPr>
+        <p:txBody>
+          <a:bodyPr rtlCol="0" anchor="ctr"/>
+          <a:lstStyle/>
+          <a:p>
+            <a:pPr algn="ctr"/>
+          </a:p>
+        </p:txBody>
+      </p:sp>
+      <p:sp>
+        <p:nvSpPr>
+          <p:cNvPr id="102" name="TextBox 101"/>
+          <p:cNvSpPr txBox="1"/>
+          <p:nvPr/>
+        </p:nvSpPr>
+        <p:spPr>
+          <a:xfrm>
+            <a:off x="7580375" y="5285231"/>
+            <a:ext cx="237744" cy="237744"/>
+          </a:xfrm>
+          <a:prstGeom prst="rect">
+            <a:avLst/>
+          </a:prstGeom>
+          <a:noFill/>
+        </p:spPr>
+        <p:txBody>
+          <a:bodyPr wrap="square" lIns="0" rIns="0" tIns="0" bIns="0" anchor="ctr">
+            <a:spAutoFit/>
+          </a:bodyPr>
+          <a:lstStyle/>
+          <a:p>
+            <a:pPr algn="ctr"/>
+            <a:r>
+              <a:rPr sz="1100" b="1" i="0">
+                <a:solidFill>
+                  <a:srgbClr val="EAF0F6"/>
+                </a:solidFill>
+                <a:latin typeface="Calibri"/>
+              </a:rPr>
+              <a:t>✗</a:t>
+            </a:r>
+          </a:p>
+        </p:txBody>
+      </p:sp>
+      <p:sp>
+        <p:nvSpPr>
+          <p:cNvPr id="103" name="TextBox 102"/>
+          <p:cNvSpPr txBox="1"/>
+          <p:nvPr/>
+        </p:nvSpPr>
+        <p:spPr>
+          <a:xfrm>
+            <a:off x="7927848" y="5212079"/>
+            <a:ext cx="3712464" cy="384048"/>
+          </a:xfrm>
+          <a:prstGeom prst="rect">
+            <a:avLst/>
+          </a:prstGeom>
+          <a:noFill/>
+        </p:spPr>
+        <p:txBody>
+          <a:bodyPr wrap="square" lIns="0" rIns="0" tIns="0" bIns="0" anchor="ctr">
+            <a:spAutoFit/>
+          </a:bodyPr>
+          <a:lstStyle/>
+          <a:p>
+            <a:pPr algn="l"/>
+            <a:r>
+              <a:rPr sz="1100" b="0" i="0">
+                <a:solidFill>
+                  <a:srgbClr val="9FB0C3"/>
+                </a:solidFill>
+                <a:latin typeface="Calibri"/>
+              </a:rPr>
+              <a:t>Whole C must meet the housing tolerance</a:t>
+            </a:r>
+          </a:p>
+        </p:txBody>
+      </p:sp>
+      <p:sp>
+        <p:nvSpPr>
+          <p:cNvPr id="104" name="Rounded Rectangle 103"/>
+          <p:cNvSpPr/>
+          <p:nvPr/>
+        </p:nvSpPr>
+        <p:spPr>
+          <a:xfrm>
+            <a:off x="457200" y="5760720"/>
+            <a:ext cx="11274552" cy="731519"/>
+          </a:xfrm>
+          <a:prstGeom prst="roundRect">
+            <a:avLst>
+              <a:gd name="adj" fmla="val 12000"/>
+            </a:avLst>
+          </a:prstGeom>
+          <a:solidFill>
+            <a:srgbClr val="1D2B3B"/>
+          </a:solidFill>
+          <a:ln w="15875">
+            <a:solidFill>
+              <a:srgbClr val="3FA46A"/>
+            </a:solidFill>
+          </a:ln>
+        </p:spPr>
+        <p:txBody>
+          <a:bodyPr rtlCol="0" anchor="ctr"/>
+          <a:lstStyle/>
+          <a:p>
+            <a:pPr algn="ctr"/>
+          </a:p>
+        </p:txBody>
+      </p:sp>
+      <p:sp>
+        <p:nvSpPr>
+          <p:cNvPr id="105" name="TextBox 104"/>
+          <p:cNvSpPr txBox="1"/>
+          <p:nvPr/>
+        </p:nvSpPr>
+        <p:spPr>
+          <a:xfrm>
+            <a:off x="685800" y="5760720"/>
+            <a:ext cx="3108960" cy="731519"/>
+          </a:xfrm>
+          <a:prstGeom prst="rect">
+            <a:avLst/>
+          </a:prstGeom>
+          <a:noFill/>
+        </p:spPr>
+        <p:txBody>
+          <a:bodyPr wrap="square" lIns="0" rIns="0" tIns="0" bIns="0" anchor="ctr">
+            <a:spAutoFit/>
+          </a:bodyPr>
+          <a:lstStyle/>
+          <a:p>
+            <a:pPr algn="l"/>
+            <a:r>
+              <a:rPr sz="1100" b="0" i="0">
+                <a:solidFill>
+                  <a:srgbClr val="9FB0C3"/>
+                </a:solidFill>
+                <a:latin typeface="Calibri"/>
+              </a:rPr>
+              <a:t>Best overall</a:t>
+            </a:r>
+          </a:p>
+          <a:p>
+            <a:pPr algn="l"/>
+            <a:r>
+              <a:rPr sz="1700" b="1" i="0">
+                <a:solidFill>
+                  <a:srgbClr val="FFD34D"/>
+                </a:solidFill>
+                <a:latin typeface="Calibri"/>
+              </a:rPr>
+              <a:t>Single C-Shape PCB</a:t>
+            </a:r>
+          </a:p>
+        </p:txBody>
+      </p:sp>
+      <p:sp>
+        <p:nvSpPr>
+          <p:cNvPr id="106" name="TextBox 105"/>
+          <p:cNvSpPr txBox="1"/>
+          <p:nvPr/>
+        </p:nvSpPr>
+        <p:spPr>
+          <a:xfrm>
+            <a:off x="3840480" y="5760720"/>
+            <a:ext cx="7680960" cy="731519"/>
+          </a:xfrm>
+          <a:prstGeom prst="rect">
+            <a:avLst/>
+          </a:prstGeom>
+          <a:noFill/>
+        </p:spPr>
+        <p:txBody>
+          <a:bodyPr wrap="square" lIns="0" rIns="0" tIns="0" bIns="0" anchor="ctr">
+            <a:spAutoFit/>
+          </a:bodyPr>
+          <a:lstStyle/>
+          <a:p>
+            <a:pPr algn="l"/>
+            <a:r>
+              <a:rPr sz="1100" b="0" i="0">
+                <a:solidFill>
+                  <a:srgbClr val="EAF0F6"/>
+                </a:solidFill>
+                <a:latin typeface="Calibri"/>
+              </a:rPr>
+              <a:t>Wins 7 of 10, including every EMC criterion: removing the inter-board harness removes the main emission, immunity and reliability risk. Pick the 3-PCB split only when panel cost or housing tolerance dominates, and then use flex jumpers with common-mode filtering at each interface.</a:t>
             </a:r>
           </a:p>
         </p:txBody>

</xml_diff>

<commit_message>
Slide 4: replace styled comparison with a plain standard table
Co-Authored-By: Claude Opus 5.5 <noreply@anthropic.com>
Claude-Session: https://claude.ai/code/session_01UaF17Au6hV57ugnQjCn17h
</commit_message>
<xml_diff>
--- a/PCB_LIGHTING_updated.pptx
+++ b/PCB_LIGHTING_updated.pptx
@@ -10433,7 +10433,7 @@
     <p:bg>
       <p:bgPr>
         <a:solidFill>
-          <a:srgbClr val="0E1621"/>
+          <a:srgbClr val="FFFFFF"/>
         </a:solidFill>
         <a:effectLst/>
       </p:bgPr>
@@ -10453,7 +10453,7 @@
         </p:nvSpPr>
         <p:spPr>
           <a:xfrm>
-            <a:off x="457200" y="292608"/>
+            <a:off x="457200" y="274320"/>
             <a:ext cx="11247120" cy="548640"/>
           </a:xfrm>
           <a:prstGeom prst="rect">
@@ -10469,9 +10469,9 @@
           <a:p>
             <a:pPr algn="l"/>
             <a:r>
-              <a:rPr sz="3000" b="1" i="0">
+              <a:rPr sz="2800" b="1" i="0">
                 <a:solidFill>
-                  <a:srgbClr val="EAF0F6"/>
+                  <a:srgbClr val="000000"/>
                 </a:solidFill>
                 <a:latin typeface="Calibri"/>
               </a:rPr>
@@ -10480,16 +10480,726 @@
           </a:p>
         </p:txBody>
       </p:sp>
-      <p:sp>
-        <p:nvSpPr>
-          <p:cNvPr id="3" name="TextBox 2"/>
+      <p:graphicFrame>
+        <p:nvGraphicFramePr>
+          <p:cNvPr id="3" name="Table 2"/>
+          <p:cNvGraphicFramePr>
+            <a:graphicFrameLocks noGrp="1"/>
+          </p:cNvGraphicFramePr>
+          <p:nvPr/>
+        </p:nvGraphicFramePr>
+        <p:xfrm>
+          <a:off x="457200" y="1005840"/>
+          <a:ext cx="11274552" cy="4937760"/>
+        </p:xfrm>
+        <a:graphic>
+          <a:graphicData uri="http://schemas.openxmlformats.org/drawingml/2006/table">
+            <a:tbl>
+              <a:tblPr firstRow="1" bandRow="1">
+                <a:tableStyleId>{5C22544A-7EE6-4342-B048-85BDC9FD1C3A}</a:tableStyleId>
+              </a:tblPr>
+              <a:tblGrid>
+                <a:gridCol w="457200"/>
+                <a:gridCol w="2377440"/>
+                <a:gridCol w="4206240"/>
+                <a:gridCol w="4233672"/>
+              </a:tblGrid>
+              <a:tr h="448887">
+                <a:tc>
+                  <a:txBody>
+                    <a:bodyPr/>
+                    <a:lstStyle/>
+                    <a:p>
+                      <a:r>
+                        <a:rPr sz="1200">
+                          <a:latin typeface="Calibri"/>
+                        </a:rPr>
+                        <a:t>#</a:t>
+                      </a:r>
+                    </a:p>
+                  </a:txBody>
+                  <a:tcPr/>
+                </a:tc>
+                <a:tc>
+                  <a:txBody>
+                    <a:bodyPr/>
+                    <a:lstStyle/>
+                    <a:p>
+                      <a:r>
+                        <a:rPr sz="1200">
+                          <a:latin typeface="Calibri"/>
+                        </a:rPr>
+                        <a:t>Parameter</a:t>
+                      </a:r>
+                    </a:p>
+                  </a:txBody>
+                  <a:tcPr/>
+                </a:tc>
+                <a:tc>
+                  <a:txBody>
+                    <a:bodyPr/>
+                    <a:lstStyle/>
+                    <a:p>
+                      <a:r>
+                        <a:rPr sz="1200">
+                          <a:latin typeface="Calibri"/>
+                        </a:rPr>
+                        <a:t>3-PCB C-Shape</a:t>
+                      </a:r>
+                    </a:p>
+                  </a:txBody>
+                  <a:tcPr/>
+                </a:tc>
+                <a:tc>
+                  <a:txBody>
+                    <a:bodyPr/>
+                    <a:lstStyle/>
+                    <a:p>
+                      <a:r>
+                        <a:rPr sz="1200">
+                          <a:latin typeface="Calibri"/>
+                        </a:rPr>
+                        <a:t>Single C-Shape PCB</a:t>
+                      </a:r>
+                    </a:p>
+                  </a:txBody>
+                  <a:tcPr/>
+                </a:tc>
+              </a:tr>
+              <a:tr h="448887">
+                <a:tc>
+                  <a:txBody>
+                    <a:bodyPr/>
+                    <a:lstStyle/>
+                    <a:p>
+                      <a:r>
+                        <a:rPr sz="1200">
+                          <a:latin typeface="Calibri"/>
+                        </a:rPr>
+                        <a:t>1</a:t>
+                      </a:r>
+                    </a:p>
+                  </a:txBody>
+                  <a:tcPr/>
+                </a:tc>
+                <a:tc>
+                  <a:txBody>
+                    <a:bodyPr/>
+                    <a:lstStyle/>
+                    <a:p>
+                      <a:r>
+                        <a:rPr sz="1200">
+                          <a:latin typeface="Calibri"/>
+                        </a:rPr>
+                        <a:t>EMI – Radiated Emissions</a:t>
+                      </a:r>
+                    </a:p>
+                  </a:txBody>
+                  <a:tcPr/>
+                </a:tc>
+                <a:tc>
+                  <a:txBody>
+                    <a:bodyPr/>
+                    <a:lstStyle/>
+                    <a:p>
+                      <a:r>
+                        <a:rPr sz="1200">
+                          <a:latin typeface="Calibri"/>
+                        </a:rPr>
+                        <a:t>❌ Interconnecting wires can act as unintended antennas.</a:t>
+                      </a:r>
+                    </a:p>
+                  </a:txBody>
+                  <a:tcPr/>
+                </a:tc>
+                <a:tc>
+                  <a:txBody>
+                    <a:bodyPr/>
+                    <a:lstStyle/>
+                    <a:p>
+                      <a:r>
+                        <a:rPr sz="1200">
+                          <a:latin typeface="Calibri"/>
+                        </a:rPr>
+                        <a:t>✅ PCB-to-PCB harnesses are eliminated.</a:t>
+                      </a:r>
+                    </a:p>
+                  </a:txBody>
+                  <a:tcPr/>
+                </a:tc>
+              </a:tr>
+              <a:tr h="448887">
+                <a:tc>
+                  <a:txBody>
+                    <a:bodyPr/>
+                    <a:lstStyle/>
+                    <a:p>
+                      <a:r>
+                        <a:rPr sz="1200">
+                          <a:latin typeface="Calibri"/>
+                        </a:rPr>
+                        <a:t>2</a:t>
+                      </a:r>
+                    </a:p>
+                  </a:txBody>
+                  <a:tcPr/>
+                </a:tc>
+                <a:tc>
+                  <a:txBody>
+                    <a:bodyPr/>
+                    <a:lstStyle/>
+                    <a:p>
+                      <a:r>
+                        <a:rPr sz="1200">
+                          <a:latin typeface="Calibri"/>
+                        </a:rPr>
+                        <a:t>Common-Mode Noise</a:t>
+                      </a:r>
+                    </a:p>
+                  </a:txBody>
+                  <a:tcPr/>
+                </a:tc>
+                <a:tc>
+                  <a:txBody>
+                    <a:bodyPr/>
+                    <a:lstStyle/>
+                    <a:p>
+                      <a:r>
+                        <a:rPr sz="1200">
+                          <a:latin typeface="Calibri"/>
+                        </a:rPr>
+                        <a:t>❌ Inter-board wires can carry common-mode currents.</a:t>
+                      </a:r>
+                    </a:p>
+                  </a:txBody>
+                  <a:tcPr/>
+                </a:tc>
+                <a:tc>
+                  <a:txBody>
+                    <a:bodyPr/>
+                    <a:lstStyle/>
+                    <a:p>
+                      <a:r>
+                        <a:rPr sz="1200">
+                          <a:latin typeface="Calibri"/>
+                        </a:rPr>
+                        <a:t>✅ Shorter external conductors, fewer common-mode coupling paths.</a:t>
+                      </a:r>
+                    </a:p>
+                  </a:txBody>
+                  <a:tcPr/>
+                </a:tc>
+              </a:tr>
+              <a:tr h="448887">
+                <a:tc>
+                  <a:txBody>
+                    <a:bodyPr/>
+                    <a:lstStyle/>
+                    <a:p>
+                      <a:r>
+                        <a:rPr sz="1200">
+                          <a:latin typeface="Calibri"/>
+                        </a:rPr>
+                        <a:t>3</a:t>
+                      </a:r>
+                    </a:p>
+                  </a:txBody>
+                  <a:tcPr/>
+                </a:tc>
+                <a:tc>
+                  <a:txBody>
+                    <a:bodyPr/>
+                    <a:lstStyle/>
+                    <a:p>
+                      <a:r>
+                        <a:rPr sz="1200">
+                          <a:latin typeface="Calibri"/>
+                        </a:rPr>
+                        <a:t>Current Loop Area</a:t>
+                      </a:r>
+                    </a:p>
+                  </a:txBody>
+                  <a:tcPr/>
+                </a:tc>
+                <a:tc>
+                  <a:txBody>
+                    <a:bodyPr/>
+                    <a:lstStyle/>
+                    <a:p>
+                      <a:r>
+                        <a:rPr sz="1200">
+                          <a:latin typeface="Calibri"/>
+                        </a:rPr>
+                        <a:t>❌ Harness routing can increase loop area and magnetic coupling.</a:t>
+                      </a:r>
+                    </a:p>
+                  </a:txBody>
+                  <a:tcPr/>
+                </a:tc>
+                <a:tc>
+                  <a:txBody>
+                    <a:bodyPr/>
+                    <a:lstStyle/>
+                    <a:p>
+                      <a:r>
+                        <a:rPr sz="1200">
+                          <a:latin typeface="Calibri"/>
+                        </a:rPr>
+                        <a:t>✅ Forward and return paths routed closely, minimising loop area.</a:t>
+                      </a:r>
+                    </a:p>
+                  </a:txBody>
+                  <a:tcPr/>
+                </a:tc>
+              </a:tr>
+              <a:tr h="448887">
+                <a:tc>
+                  <a:txBody>
+                    <a:bodyPr/>
+                    <a:lstStyle/>
+                    <a:p>
+                      <a:r>
+                        <a:rPr sz="1200">
+                          <a:latin typeface="Calibri"/>
+                        </a:rPr>
+                        <a:t>4</a:t>
+                      </a:r>
+                    </a:p>
+                  </a:txBody>
+                  <a:tcPr/>
+                </a:tc>
+                <a:tc>
+                  <a:txBody>
+                    <a:bodyPr/>
+                    <a:lstStyle/>
+                    <a:p>
+                      <a:r>
+                        <a:rPr sz="1200">
+                          <a:latin typeface="Calibri"/>
+                        </a:rPr>
+                        <a:t>Ground Reference</a:t>
+                      </a:r>
+                    </a:p>
+                  </a:txBody>
+                  <a:tcPr/>
+                </a:tc>
+                <a:tc>
+                  <a:txBody>
+                    <a:bodyPr/>
+                    <a:lstStyle/>
+                    <a:p>
+                      <a:r>
+                        <a:rPr sz="1200">
+                          <a:latin typeface="Calibri"/>
+                        </a:rPr>
+                        <a:t>❌ Ground potential can shift between boards across the interconnect.</a:t>
+                      </a:r>
+                    </a:p>
+                  </a:txBody>
+                  <a:tcPr/>
+                </a:tc>
+                <a:tc>
+                  <a:txBody>
+                    <a:bodyPr/>
+                    <a:lstStyle/>
+                    <a:p>
+                      <a:r>
+                        <a:rPr sz="1200">
+                          <a:latin typeface="Calibri"/>
+                        </a:rPr>
+                        <a:t>✅ One continuous ground plane across the whole PCB.</a:t>
+                      </a:r>
+                    </a:p>
+                  </a:txBody>
+                  <a:tcPr/>
+                </a:tc>
+              </a:tr>
+              <a:tr h="448887">
+                <a:tc>
+                  <a:txBody>
+                    <a:bodyPr/>
+                    <a:lstStyle/>
+                    <a:p>
+                      <a:r>
+                        <a:rPr sz="1200">
+                          <a:latin typeface="Calibri"/>
+                        </a:rPr>
+                        <a:t>5</a:t>
+                      </a:r>
+                    </a:p>
+                  </a:txBody>
+                  <a:tcPr/>
+                </a:tc>
+                <a:tc>
+                  <a:txBody>
+                    <a:bodyPr/>
+                    <a:lstStyle/>
+                    <a:p>
+                      <a:r>
+                        <a:rPr sz="1200">
+                          <a:latin typeface="Calibri"/>
+                        </a:rPr>
+                        <a:t>Radiated Immunity &amp; ESD</a:t>
+                      </a:r>
+                    </a:p>
+                  </a:txBody>
+                  <a:tcPr/>
+                </a:tc>
+                <a:tc>
+                  <a:txBody>
+                    <a:bodyPr/>
+                    <a:lstStyle/>
+                    <a:p>
+                      <a:r>
+                        <a:rPr sz="1200">
+                          <a:latin typeface="Calibri"/>
+                        </a:rPr>
+                        <a:t>❌ Harnesses act as receiving antennas; more connectors add ESD paths.</a:t>
+                      </a:r>
+                    </a:p>
+                  </a:txBody>
+                  <a:tcPr/>
+                </a:tc>
+                <a:tc>
+                  <a:txBody>
+                    <a:bodyPr/>
+                    <a:lstStyle/>
+                    <a:p>
+                      <a:r>
+                        <a:rPr sz="1200">
+                          <a:latin typeface="Calibri"/>
+                        </a:rPr>
+                        <a:t>✅ Fewer conductors and interfaces simplify immunity and ESD protection.</a:t>
+                      </a:r>
+                    </a:p>
+                  </a:txBody>
+                  <a:tcPr/>
+                </a:tc>
+              </a:tr>
+              <a:tr h="448887">
+                <a:tc>
+                  <a:txBody>
+                    <a:bodyPr/>
+                    <a:lstStyle/>
+                    <a:p>
+                      <a:r>
+                        <a:rPr sz="1200">
+                          <a:latin typeface="Calibri"/>
+                        </a:rPr>
+                        <a:t>6</a:t>
+                      </a:r>
+                    </a:p>
+                  </a:txBody>
+                  <a:tcPr/>
+                </a:tc>
+                <a:tc>
+                  <a:txBody>
+                    <a:bodyPr/>
+                    <a:lstStyle/>
+                    <a:p>
+                      <a:r>
+                        <a:rPr sz="1200">
+                          <a:latin typeface="Calibri"/>
+                        </a:rPr>
+                        <a:t>Electrical &amp; Vibration Reliability</a:t>
+                      </a:r>
+                    </a:p>
+                  </a:txBody>
+                  <a:tcPr/>
+                </a:tc>
+                <a:tc>
+                  <a:txBody>
+                    <a:bodyPr/>
+                    <a:lstStyle/>
+                    <a:p>
+                      <a:r>
+                        <a:rPr sz="1200">
+                          <a:latin typeface="Calibri"/>
+                        </a:rPr>
+                        <a:t>❌ More connectors and crimps are potential failure points under vibration.</a:t>
+                      </a:r>
+                    </a:p>
+                  </a:txBody>
+                  <a:tcPr/>
+                </a:tc>
+                <a:tc>
+                  <a:txBody>
+                    <a:bodyPr/>
+                    <a:lstStyle/>
+                    <a:p>
+                      <a:r>
+                        <a:rPr sz="1200">
+                          <a:latin typeface="Calibri"/>
+                        </a:rPr>
+                        <a:t>✅ Fewer electrical/mechanical interfaces reduce failure mechanisms.</a:t>
+                      </a:r>
+                    </a:p>
+                  </a:txBody>
+                  <a:tcPr/>
+                </a:tc>
+              </a:tr>
+              <a:tr h="448887">
+                <a:tc>
+                  <a:txBody>
+                    <a:bodyPr/>
+                    <a:lstStyle/>
+                    <a:p>
+                      <a:r>
+                        <a:rPr sz="1200">
+                          <a:latin typeface="Calibri"/>
+                        </a:rPr>
+                        <a:t>7</a:t>
+                      </a:r>
+                    </a:p>
+                  </a:txBody>
+                  <a:tcPr/>
+                </a:tc>
+                <a:tc>
+                  <a:txBody>
+                    <a:bodyPr/>
+                    <a:lstStyle/>
+                    <a:p>
+                      <a:r>
+                        <a:rPr sz="1200">
+                          <a:latin typeface="Calibri"/>
+                        </a:rPr>
+                        <a:t>BOM &amp; Assembly</a:t>
+                      </a:r>
+                    </a:p>
+                  </a:txBody>
+                  <a:tcPr/>
+                </a:tc>
+                <a:tc>
+                  <a:txBody>
+                    <a:bodyPr/>
+                    <a:lstStyle/>
+                    <a:p>
+                      <a:r>
+                        <a:rPr sz="1200">
+                          <a:latin typeface="Calibri"/>
+                        </a:rPr>
+                        <a:t>❌ Three PCBs plus connectors, wires, terminals and harness assembly.</a:t>
+                      </a:r>
+                    </a:p>
+                  </a:txBody>
+                  <a:tcPr/>
+                </a:tc>
+                <a:tc>
+                  <a:txBody>
+                    <a:bodyPr/>
+                    <a:lstStyle/>
+                    <a:p>
+                      <a:r>
+                        <a:rPr sz="1200">
+                          <a:latin typeface="Calibri"/>
+                        </a:rPr>
+                        <a:t>✅ One PCB part number and a single assembly.</a:t>
+                      </a:r>
+                    </a:p>
+                  </a:txBody>
+                  <a:tcPr/>
+                </a:tc>
+              </a:tr>
+              <a:tr h="448887">
+                <a:tc>
+                  <a:txBody>
+                    <a:bodyPr/>
+                    <a:lstStyle/>
+                    <a:p>
+                      <a:r>
+                        <a:rPr sz="1200">
+                          <a:latin typeface="Calibri"/>
+                        </a:rPr>
+                        <a:t>8</a:t>
+                      </a:r>
+                    </a:p>
+                  </a:txBody>
+                  <a:tcPr/>
+                </a:tc>
+                <a:tc>
+                  <a:txBody>
+                    <a:bodyPr/>
+                    <a:lstStyle/>
+                    <a:p>
+                      <a:r>
+                        <a:rPr sz="1200">
+                          <a:latin typeface="Calibri"/>
+                        </a:rPr>
+                        <a:t>Panel Utilization</a:t>
+                      </a:r>
+                    </a:p>
+                  </a:txBody>
+                  <a:tcPr/>
+                </a:tc>
+                <a:tc>
+                  <a:txBody>
+                    <a:bodyPr/>
+                    <a:lstStyle/>
+                    <a:p>
+                      <a:r>
+                        <a:rPr sz="1200">
+                          <a:latin typeface="Calibri"/>
+                        </a:rPr>
+                        <a:t>✅ Rectangular boards nest efficiently on panels.</a:t>
+                      </a:r>
+                    </a:p>
+                  </a:txBody>
+                  <a:tcPr/>
+                </a:tc>
+                <a:tc>
+                  <a:txBody>
+                    <a:bodyPr/>
+                    <a:lstStyle/>
+                    <a:p>
+                      <a:r>
+                        <a:rPr sz="1200">
+                          <a:latin typeface="Calibri"/>
+                        </a:rPr>
+                        <a:t>❌ C-shaped outline leaves more unused panel area.</a:t>
+                      </a:r>
+                    </a:p>
+                  </a:txBody>
+                  <a:tcPr/>
+                </a:tc>
+              </a:tr>
+              <a:tr h="448887">
+                <a:tc>
+                  <a:txBody>
+                    <a:bodyPr/>
+                    <a:lstStyle/>
+                    <a:p>
+                      <a:r>
+                        <a:rPr sz="1200">
+                          <a:latin typeface="Calibri"/>
+                        </a:rPr>
+                        <a:t>9</a:t>
+                      </a:r>
+                    </a:p>
+                  </a:txBody>
+                  <a:tcPr/>
+                </a:tc>
+                <a:tc>
+                  <a:txBody>
+                    <a:bodyPr/>
+                    <a:lstStyle/>
+                    <a:p>
+                      <a:r>
+                        <a:rPr sz="1200">
+                          <a:latin typeface="Calibri"/>
+                        </a:rPr>
+                        <a:t>Warpage &amp; Depaneling</a:t>
+                      </a:r>
+                    </a:p>
+                  </a:txBody>
+                  <a:tcPr/>
+                </a:tc>
+                <a:tc>
+                  <a:txBody>
+                    <a:bodyPr/>
+                    <a:lstStyle/>
+                    <a:p>
+                      <a:r>
+                        <a:rPr sz="1200">
+                          <a:latin typeface="Calibri"/>
+                        </a:rPr>
+                        <a:t>✅ Short boards stay flat, with low stress on LED solder joints.</a:t>
+                      </a:r>
+                    </a:p>
+                  </a:txBody>
+                  <a:tcPr/>
+                </a:tc>
+                <a:tc>
+                  <a:txBody>
+                    <a:bodyPr/>
+                    <a:lstStyle/>
+                    <a:p>
+                      <a:r>
+                        <a:rPr sz="1200">
+                          <a:latin typeface="Calibri"/>
+                        </a:rPr>
+                        <a:t>❌ Long C-shape can warp during reflow and depaneling, stressing LED joints.</a:t>
+                      </a:r>
+                    </a:p>
+                  </a:txBody>
+                  <a:tcPr/>
+                </a:tc>
+              </a:tr>
+              <a:tr h="448890">
+                <a:tc>
+                  <a:txBody>
+                    <a:bodyPr/>
+                    <a:lstStyle/>
+                    <a:p>
+                      <a:r>
+                        <a:rPr sz="1200">
+                          <a:latin typeface="Calibri"/>
+                        </a:rPr>
+                        <a:t>10</a:t>
+                      </a:r>
+                    </a:p>
+                  </a:txBody>
+                  <a:tcPr/>
+                </a:tc>
+                <a:tc>
+                  <a:txBody>
+                    <a:bodyPr/>
+                    <a:lstStyle/>
+                    <a:p>
+                      <a:r>
+                        <a:rPr sz="1200">
+                          <a:latin typeface="Calibri"/>
+                        </a:rPr>
+                        <a:t>Mechanical Flexibility &amp; Serviceability</a:t>
+                      </a:r>
+                    </a:p>
+                  </a:txBody>
+                  <a:tcPr/>
+                </a:tc>
+                <a:tc>
+                  <a:txBody>
+                    <a:bodyPr/>
+                    <a:lstStyle/>
+                    <a:p>
+                      <a:r>
+                        <a:rPr sz="1200">
+                          <a:latin typeface="Calibri"/>
+                        </a:rPr>
+                        <a:t>✅ Boards can be positioned and replaced independently.</a:t>
+                      </a:r>
+                    </a:p>
+                  </a:txBody>
+                  <a:tcPr/>
+                </a:tc>
+                <a:tc>
+                  <a:txBody>
+                    <a:bodyPr/>
+                    <a:lstStyle/>
+                    <a:p>
+                      <a:r>
+                        <a:rPr sz="1200">
+                          <a:latin typeface="Calibri"/>
+                        </a:rPr>
+                        <a:t>❌ Whole C-shape must fit the housing tolerance and is replaced as one part.</a:t>
+                      </a:r>
+                    </a:p>
+                  </a:txBody>
+                  <a:tcPr/>
+                </a:tc>
+              </a:tr>
+            </a:tbl>
+          </a:graphicData>
+        </a:graphic>
+      </p:graphicFrame>
+      <p:sp>
+        <p:nvSpPr>
+          <p:cNvPr id="4" name="TextBox 3"/>
           <p:cNvSpPr txBox="1"/>
           <p:nvPr/>
         </p:nvSpPr>
         <p:spPr>
           <a:xfrm>
-            <a:off x="457200" y="841248"/>
-            <a:ext cx="11247120" cy="320040"/>
+            <a:off x="457200" y="6172200"/>
+            <a:ext cx="11247120" cy="365760"/>
           </a:xfrm>
           <a:prstGeom prst="rect">
             <a:avLst/>
@@ -10504,3428 +11214,22 @@
           <a:p>
             <a:pPr algn="l"/>
             <a:r>
-              <a:rPr sz="1300" b="0" i="0">
+              <a:rPr sz="1400" b="1" i="0">
                 <a:solidFill>
-                  <a:srgbClr val="9FB0C3"/>
+                  <a:srgbClr val="000000"/>
                 </a:solidFill>
                 <a:latin typeface="Calibri"/>
               </a:rPr>
-              <a:t>The 10 most relevant parameters for EMC, reliability and manufacturing  (★ = additional technical point)</a:t>
-            </a:r>
-          </a:p>
-        </p:txBody>
-      </p:sp>
-      <p:sp>
-        <p:nvSpPr>
-          <p:cNvPr id="4" name="Rectangle 3"/>
-          <p:cNvSpPr/>
-          <p:nvPr/>
-        </p:nvSpPr>
-        <p:spPr>
-          <a:xfrm>
-            <a:off x="457200" y="1280160"/>
-            <a:ext cx="11274552" cy="475488"/>
-          </a:xfrm>
-          <a:prstGeom prst="rect">
-            <a:avLst/>
-          </a:prstGeom>
-          <a:solidFill>
-            <a:srgbClr val="1D2B3B"/>
-          </a:solidFill>
-          <a:ln>
-            <a:noFill/>
-          </a:ln>
-        </p:spPr>
-        <p:txBody>
-          <a:bodyPr rtlCol="0" anchor="ctr"/>
-          <a:lstStyle/>
-          <a:p>
-            <a:pPr algn="ctr"/>
-          </a:p>
-        </p:txBody>
-      </p:sp>
-      <p:sp>
-        <p:nvSpPr>
-          <p:cNvPr id="5" name="Rectangle 4"/>
-          <p:cNvSpPr/>
-          <p:nvPr/>
-        </p:nvSpPr>
-        <p:spPr>
-          <a:xfrm>
-            <a:off x="7470648" y="1280160"/>
-            <a:ext cx="4261104" cy="475488"/>
-          </a:xfrm>
-          <a:prstGeom prst="rect">
-            <a:avLst/>
-          </a:prstGeom>
-          <a:solidFill>
-            <a:srgbClr val="1E5C3F"/>
-          </a:solidFill>
-          <a:ln>
-            <a:noFill/>
-          </a:ln>
-        </p:spPr>
-        <p:txBody>
-          <a:bodyPr rtlCol="0" anchor="ctr"/>
-          <a:lstStyle/>
-          <a:p>
-            <a:pPr algn="ctr"/>
-          </a:p>
-        </p:txBody>
-      </p:sp>
-      <p:sp>
-        <p:nvSpPr>
-          <p:cNvPr id="6" name="TextBox 5"/>
-          <p:cNvSpPr txBox="1"/>
-          <p:nvPr/>
-        </p:nvSpPr>
-        <p:spPr>
-          <a:xfrm>
-            <a:off x="566928" y="1280160"/>
-            <a:ext cx="228600" cy="475488"/>
-          </a:xfrm>
-          <a:prstGeom prst="rect">
-            <a:avLst/>
-          </a:prstGeom>
-          <a:noFill/>
-        </p:spPr>
-        <p:txBody>
-          <a:bodyPr wrap="square" lIns="0" rIns="0" tIns="0" bIns="0" anchor="ctr">
-            <a:spAutoFit/>
-          </a:bodyPr>
-          <a:lstStyle/>
-          <a:p>
-            <a:pPr algn="l"/>
-            <a:r>
-              <a:rPr sz="1400" b="1" i="0">
+              <a:t>Best overall: Single C-Shape PCB</a:t>
+            </a:r>
+            <a:r>
+              <a:rPr sz="1400" b="0" i="0">
                 <a:solidFill>
-                  <a:srgbClr val="EAF0F6"/>
+                  <a:srgbClr val="000000"/>
                 </a:solidFill>
                 <a:latin typeface="Calibri"/>
               </a:rPr>
-              <a:t>#</a:t>
-            </a:r>
-          </a:p>
-        </p:txBody>
-      </p:sp>
-      <p:sp>
-        <p:nvSpPr>
-          <p:cNvPr id="7" name="TextBox 6"/>
-          <p:cNvSpPr txBox="1"/>
-          <p:nvPr/>
-        </p:nvSpPr>
-        <p:spPr>
-          <a:xfrm>
-            <a:off x="978407" y="1280160"/>
-            <a:ext cx="2194560" cy="475488"/>
-          </a:xfrm>
-          <a:prstGeom prst="rect">
-            <a:avLst/>
-          </a:prstGeom>
-          <a:noFill/>
-        </p:spPr>
-        <p:txBody>
-          <a:bodyPr wrap="square" lIns="0" rIns="0" tIns="0" bIns="0" anchor="ctr">
-            <a:spAutoFit/>
-          </a:bodyPr>
-          <a:lstStyle/>
-          <a:p>
-            <a:pPr algn="l"/>
-            <a:r>
-              <a:rPr sz="1400" b="1" i="0">
-                <a:solidFill>
-                  <a:srgbClr val="EAF0F6"/>
-                </a:solidFill>
-                <a:latin typeface="Calibri"/>
-              </a:rPr>
-              <a:t>Parameter</a:t>
-            </a:r>
-          </a:p>
-        </p:txBody>
-      </p:sp>
-      <p:sp>
-        <p:nvSpPr>
-          <p:cNvPr id="8" name="TextBox 7"/>
-          <p:cNvSpPr txBox="1"/>
-          <p:nvPr/>
-        </p:nvSpPr>
-        <p:spPr>
-          <a:xfrm>
-            <a:off x="3355848" y="1280160"/>
-            <a:ext cx="4041648" cy="475488"/>
-          </a:xfrm>
-          <a:prstGeom prst="rect">
-            <a:avLst/>
-          </a:prstGeom>
-          <a:noFill/>
-        </p:spPr>
-        <p:txBody>
-          <a:bodyPr wrap="square" lIns="0" rIns="0" tIns="0" bIns="0" anchor="ctr">
-            <a:spAutoFit/>
-          </a:bodyPr>
-          <a:lstStyle/>
-          <a:p>
-            <a:pPr algn="l"/>
-            <a:r>
-              <a:rPr sz="1400" b="1" i="0">
-                <a:solidFill>
-                  <a:srgbClr val="EAF0F6"/>
-                </a:solidFill>
-                <a:latin typeface="Calibri"/>
-              </a:rPr>
-              <a:t>3-PCB C-Shape</a:t>
-            </a:r>
-          </a:p>
-        </p:txBody>
-      </p:sp>
-      <p:sp>
-        <p:nvSpPr>
-          <p:cNvPr id="9" name="TextBox 8"/>
-          <p:cNvSpPr txBox="1"/>
-          <p:nvPr/>
-        </p:nvSpPr>
-        <p:spPr>
-          <a:xfrm>
-            <a:off x="7580375" y="1280160"/>
-            <a:ext cx="4078224" cy="475488"/>
-          </a:xfrm>
-          <a:prstGeom prst="rect">
-            <a:avLst/>
-          </a:prstGeom>
-          <a:noFill/>
-        </p:spPr>
-        <p:txBody>
-          <a:bodyPr wrap="square" lIns="0" rIns="0" tIns="0" bIns="0" anchor="ctr">
-            <a:spAutoFit/>
-          </a:bodyPr>
-          <a:lstStyle/>
-          <a:p>
-            <a:pPr algn="l"/>
-            <a:r>
-              <a:rPr sz="1400" b="1" i="0">
-                <a:solidFill>
-                  <a:srgbClr val="EAF0F6"/>
-                </a:solidFill>
-                <a:latin typeface="Calibri"/>
-              </a:rPr>
-              <a:t>Single C-Shape PCB</a:t>
-            </a:r>
-          </a:p>
-        </p:txBody>
-      </p:sp>
-      <p:sp>
-        <p:nvSpPr>
-          <p:cNvPr id="10" name="Rounded Rectangle 9"/>
-          <p:cNvSpPr/>
-          <p:nvPr/>
-        </p:nvSpPr>
-        <p:spPr>
-          <a:xfrm>
-            <a:off x="6510528" y="1399031"/>
-            <a:ext cx="822960" cy="265176"/>
-          </a:xfrm>
-          <a:prstGeom prst="roundRect">
-            <a:avLst>
-              <a:gd name="adj" fmla="val 50000"/>
-            </a:avLst>
-          </a:prstGeom>
-          <a:solidFill>
-            <a:srgbClr val="0E1621"/>
-          </a:solidFill>
-          <a:ln>
-            <a:noFill/>
-          </a:ln>
-        </p:spPr>
-        <p:txBody>
-          <a:bodyPr rtlCol="0" anchor="ctr"/>
-          <a:lstStyle/>
-          <a:p>
-            <a:pPr algn="ctr"/>
-          </a:p>
-        </p:txBody>
-      </p:sp>
-      <p:sp>
-        <p:nvSpPr>
-          <p:cNvPr id="11" name="TextBox 10"/>
-          <p:cNvSpPr txBox="1"/>
-          <p:nvPr/>
-        </p:nvSpPr>
-        <p:spPr>
-          <a:xfrm>
-            <a:off x="6510528" y="1399031"/>
-            <a:ext cx="822960" cy="265176"/>
-          </a:xfrm>
-          <a:prstGeom prst="rect">
-            <a:avLst/>
-          </a:prstGeom>
-          <a:noFill/>
-        </p:spPr>
-        <p:txBody>
-          <a:bodyPr wrap="square" lIns="0" rIns="0" tIns="0" bIns="0" anchor="ctr">
-            <a:spAutoFit/>
-          </a:bodyPr>
-          <a:lstStyle/>
-          <a:p>
-            <a:pPr algn="ctr"/>
-            <a:r>
-              <a:rPr sz="1100" b="1" i="0">
-                <a:solidFill>
-                  <a:srgbClr val="FFD34D"/>
-                </a:solidFill>
-                <a:latin typeface="Calibri"/>
-              </a:rPr>
-              <a:t>3 / 10</a:t>
-            </a:r>
-          </a:p>
-        </p:txBody>
-      </p:sp>
-      <p:sp>
-        <p:nvSpPr>
-          <p:cNvPr id="12" name="Rounded Rectangle 11"/>
-          <p:cNvSpPr/>
-          <p:nvPr/>
-        </p:nvSpPr>
-        <p:spPr>
-          <a:xfrm>
-            <a:off x="10771632" y="1399031"/>
-            <a:ext cx="822960" cy="265176"/>
-          </a:xfrm>
-          <a:prstGeom prst="roundRect">
-            <a:avLst>
-              <a:gd name="adj" fmla="val 50000"/>
-            </a:avLst>
-          </a:prstGeom>
-          <a:solidFill>
-            <a:srgbClr val="0E1621"/>
-          </a:solidFill>
-          <a:ln>
-            <a:noFill/>
-          </a:ln>
-        </p:spPr>
-        <p:txBody>
-          <a:bodyPr rtlCol="0" anchor="ctr"/>
-          <a:lstStyle/>
-          <a:p>
-            <a:pPr algn="ctr"/>
-          </a:p>
-        </p:txBody>
-      </p:sp>
-      <p:sp>
-        <p:nvSpPr>
-          <p:cNvPr id="13" name="TextBox 12"/>
-          <p:cNvSpPr txBox="1"/>
-          <p:nvPr/>
-        </p:nvSpPr>
-        <p:spPr>
-          <a:xfrm>
-            <a:off x="10771632" y="1399031"/>
-            <a:ext cx="822960" cy="265176"/>
-          </a:xfrm>
-          <a:prstGeom prst="rect">
-            <a:avLst/>
-          </a:prstGeom>
-          <a:noFill/>
-        </p:spPr>
-        <p:txBody>
-          <a:bodyPr wrap="square" lIns="0" rIns="0" tIns="0" bIns="0" anchor="ctr">
-            <a:spAutoFit/>
-          </a:bodyPr>
-          <a:lstStyle/>
-          <a:p>
-            <a:pPr algn="ctr"/>
-            <a:r>
-              <a:rPr sz="1100" b="1" i="0">
-                <a:solidFill>
-                  <a:srgbClr val="FFD34D"/>
-                </a:solidFill>
-                <a:latin typeface="Calibri"/>
-              </a:rPr>
-              <a:t>7 / 10</a:t>
-            </a:r>
-          </a:p>
-        </p:txBody>
-      </p:sp>
-      <p:sp>
-        <p:nvSpPr>
-          <p:cNvPr id="14" name="Rectangle 13"/>
-          <p:cNvSpPr/>
-          <p:nvPr/>
-        </p:nvSpPr>
-        <p:spPr>
-          <a:xfrm>
-            <a:off x="457200" y="1755648"/>
-            <a:ext cx="11274552" cy="384048"/>
-          </a:xfrm>
-          <a:prstGeom prst="rect">
-            <a:avLst/>
-          </a:prstGeom>
-          <a:solidFill>
-            <a:srgbClr val="172331"/>
-          </a:solidFill>
-          <a:ln>
-            <a:noFill/>
-          </a:ln>
-        </p:spPr>
-        <p:txBody>
-          <a:bodyPr rtlCol="0" anchor="ctr"/>
-          <a:lstStyle/>
-          <a:p>
-            <a:pPr algn="ctr"/>
-          </a:p>
-        </p:txBody>
-      </p:sp>
-      <p:sp>
-        <p:nvSpPr>
-          <p:cNvPr id="15" name="TextBox 14"/>
-          <p:cNvSpPr txBox="1"/>
-          <p:nvPr/>
-        </p:nvSpPr>
-        <p:spPr>
-          <a:xfrm>
-            <a:off x="566928" y="1755648"/>
-            <a:ext cx="274320" cy="384048"/>
-          </a:xfrm>
-          <a:prstGeom prst="rect">
-            <a:avLst/>
-          </a:prstGeom>
-          <a:noFill/>
-        </p:spPr>
-        <p:txBody>
-          <a:bodyPr wrap="square" lIns="0" rIns="0" tIns="0" bIns="0" anchor="ctr">
-            <a:spAutoFit/>
-          </a:bodyPr>
-          <a:lstStyle/>
-          <a:p>
-            <a:pPr algn="l"/>
-            <a:r>
-              <a:rPr sz="1100" b="0" i="0">
-                <a:solidFill>
-                  <a:srgbClr val="9FB0C3"/>
-                </a:solidFill>
-                <a:latin typeface="Calibri"/>
-              </a:rPr>
-              <a:t>1</a:t>
-            </a:r>
-          </a:p>
-        </p:txBody>
-      </p:sp>
-      <p:sp>
-        <p:nvSpPr>
-          <p:cNvPr id="16" name="TextBox 15"/>
-          <p:cNvSpPr txBox="1"/>
-          <p:nvPr/>
-        </p:nvSpPr>
-        <p:spPr>
-          <a:xfrm>
-            <a:off x="978407" y="1755648"/>
-            <a:ext cx="2194560" cy="384048"/>
-          </a:xfrm>
-          <a:prstGeom prst="rect">
-            <a:avLst/>
-          </a:prstGeom>
-          <a:noFill/>
-        </p:spPr>
-        <p:txBody>
-          <a:bodyPr wrap="square" lIns="0" rIns="0" tIns="0" bIns="0" anchor="ctr">
-            <a:spAutoFit/>
-          </a:bodyPr>
-          <a:lstStyle/>
-          <a:p>
-            <a:pPr algn="l"/>
-            <a:r>
-              <a:rPr sz="1150" b="1" i="0">
-                <a:solidFill>
-                  <a:srgbClr val="EAF0F6"/>
-                </a:solidFill>
-                <a:latin typeface="Calibri"/>
-              </a:rPr>
-              <a:t>EMI – Radiated emissions</a:t>
-            </a:r>
-          </a:p>
-        </p:txBody>
-      </p:sp>
-      <p:sp>
-        <p:nvSpPr>
-          <p:cNvPr id="17" name="Oval 16"/>
-          <p:cNvSpPr/>
-          <p:nvPr/>
-        </p:nvSpPr>
-        <p:spPr>
-          <a:xfrm>
-            <a:off x="3355848" y="1828800"/>
-            <a:ext cx="237744" cy="237744"/>
-          </a:xfrm>
-          <a:prstGeom prst="ellipse">
-            <a:avLst/>
-          </a:prstGeom>
-          <a:solidFill>
-            <a:srgbClr val="E05D5D"/>
-          </a:solidFill>
-          <a:ln>
-            <a:noFill/>
-          </a:ln>
-        </p:spPr>
-        <p:txBody>
-          <a:bodyPr rtlCol="0" anchor="ctr"/>
-          <a:lstStyle/>
-          <a:p>
-            <a:pPr algn="ctr"/>
-          </a:p>
-        </p:txBody>
-      </p:sp>
-      <p:sp>
-        <p:nvSpPr>
-          <p:cNvPr id="18" name="TextBox 17"/>
-          <p:cNvSpPr txBox="1"/>
-          <p:nvPr/>
-        </p:nvSpPr>
-        <p:spPr>
-          <a:xfrm>
-            <a:off x="3355848" y="1828800"/>
-            <a:ext cx="237744" cy="237744"/>
-          </a:xfrm>
-          <a:prstGeom prst="rect">
-            <a:avLst/>
-          </a:prstGeom>
-          <a:noFill/>
-        </p:spPr>
-        <p:txBody>
-          <a:bodyPr wrap="square" lIns="0" rIns="0" tIns="0" bIns="0" anchor="ctr">
-            <a:spAutoFit/>
-          </a:bodyPr>
-          <a:lstStyle/>
-          <a:p>
-            <a:pPr algn="ctr"/>
-            <a:r>
-              <a:rPr sz="1100" b="1" i="0">
-                <a:solidFill>
-                  <a:srgbClr val="EAF0F6"/>
-                </a:solidFill>
-                <a:latin typeface="Calibri"/>
-              </a:rPr>
-              <a:t>✗</a:t>
-            </a:r>
-          </a:p>
-        </p:txBody>
-      </p:sp>
-      <p:sp>
-        <p:nvSpPr>
-          <p:cNvPr id="19" name="TextBox 18"/>
-          <p:cNvSpPr txBox="1"/>
-          <p:nvPr/>
-        </p:nvSpPr>
-        <p:spPr>
-          <a:xfrm>
-            <a:off x="3703320" y="1755648"/>
-            <a:ext cx="3675888" cy="384048"/>
-          </a:xfrm>
-          <a:prstGeom prst="rect">
-            <a:avLst/>
-          </a:prstGeom>
-          <a:noFill/>
-        </p:spPr>
-        <p:txBody>
-          <a:bodyPr wrap="square" lIns="0" rIns="0" tIns="0" bIns="0" anchor="ctr">
-            <a:spAutoFit/>
-          </a:bodyPr>
-          <a:lstStyle/>
-          <a:p>
-            <a:pPr algn="l"/>
-            <a:r>
-              <a:rPr sz="1100" b="0" i="0">
-                <a:solidFill>
-                  <a:srgbClr val="9FB0C3"/>
-                </a:solidFill>
-                <a:latin typeface="Calibri"/>
-              </a:rPr>
-              <a:t>Inter-board wires act as unintended antennas</a:t>
-            </a:r>
-          </a:p>
-        </p:txBody>
-      </p:sp>
-      <p:sp>
-        <p:nvSpPr>
-          <p:cNvPr id="20" name="Oval 19"/>
-          <p:cNvSpPr/>
-          <p:nvPr/>
-        </p:nvSpPr>
-        <p:spPr>
-          <a:xfrm>
-            <a:off x="7580375" y="1828800"/>
-            <a:ext cx="237744" cy="237744"/>
-          </a:xfrm>
-          <a:prstGeom prst="ellipse">
-            <a:avLst/>
-          </a:prstGeom>
-          <a:solidFill>
-            <a:srgbClr val="3FA46A"/>
-          </a:solidFill>
-          <a:ln>
-            <a:noFill/>
-          </a:ln>
-        </p:spPr>
-        <p:txBody>
-          <a:bodyPr rtlCol="0" anchor="ctr"/>
-          <a:lstStyle/>
-          <a:p>
-            <a:pPr algn="ctr"/>
-          </a:p>
-        </p:txBody>
-      </p:sp>
-      <p:sp>
-        <p:nvSpPr>
-          <p:cNvPr id="21" name="TextBox 20"/>
-          <p:cNvSpPr txBox="1"/>
-          <p:nvPr/>
-        </p:nvSpPr>
-        <p:spPr>
-          <a:xfrm>
-            <a:off x="7580375" y="1828800"/>
-            <a:ext cx="237744" cy="237744"/>
-          </a:xfrm>
-          <a:prstGeom prst="rect">
-            <a:avLst/>
-          </a:prstGeom>
-          <a:noFill/>
-        </p:spPr>
-        <p:txBody>
-          <a:bodyPr wrap="square" lIns="0" rIns="0" tIns="0" bIns="0" anchor="ctr">
-            <a:spAutoFit/>
-          </a:bodyPr>
-          <a:lstStyle/>
-          <a:p>
-            <a:pPr algn="ctr"/>
-            <a:r>
-              <a:rPr sz="1100" b="1" i="0">
-                <a:solidFill>
-                  <a:srgbClr val="EAF0F6"/>
-                </a:solidFill>
-                <a:latin typeface="Calibri"/>
-              </a:rPr>
-              <a:t>✓</a:t>
-            </a:r>
-          </a:p>
-        </p:txBody>
-      </p:sp>
-      <p:sp>
-        <p:nvSpPr>
-          <p:cNvPr id="22" name="TextBox 21"/>
-          <p:cNvSpPr txBox="1"/>
-          <p:nvPr/>
-        </p:nvSpPr>
-        <p:spPr>
-          <a:xfrm>
-            <a:off x="7927848" y="1755648"/>
-            <a:ext cx="3712464" cy="384048"/>
-          </a:xfrm>
-          <a:prstGeom prst="rect">
-            <a:avLst/>
-          </a:prstGeom>
-          <a:noFill/>
-        </p:spPr>
-        <p:txBody>
-          <a:bodyPr wrap="square" lIns="0" rIns="0" tIns="0" bIns="0" anchor="ctr">
-            <a:spAutoFit/>
-          </a:bodyPr>
-          <a:lstStyle/>
-          <a:p>
-            <a:pPr algn="l"/>
-            <a:r>
-              <a:rPr sz="1100" b="0" i="0">
-                <a:solidFill>
-                  <a:srgbClr val="EAF0F6"/>
-                </a:solidFill>
-                <a:latin typeface="Calibri"/>
-              </a:rPr>
-              <a:t>No PCB-to-PCB harness left to radiate</a:t>
-            </a:r>
-          </a:p>
-        </p:txBody>
-      </p:sp>
-      <p:sp>
-        <p:nvSpPr>
-          <p:cNvPr id="23" name="Rectangle 22"/>
-          <p:cNvSpPr/>
-          <p:nvPr/>
-        </p:nvSpPr>
-        <p:spPr>
-          <a:xfrm>
-            <a:off x="457200" y="2139696"/>
-            <a:ext cx="11274552" cy="384048"/>
-          </a:xfrm>
-          <a:prstGeom prst="rect">
-            <a:avLst/>
-          </a:prstGeom>
-          <a:solidFill>
-            <a:srgbClr val="0E1621"/>
-          </a:solidFill>
-          <a:ln>
-            <a:noFill/>
-          </a:ln>
-        </p:spPr>
-        <p:txBody>
-          <a:bodyPr rtlCol="0" anchor="ctr"/>
-          <a:lstStyle/>
-          <a:p>
-            <a:pPr algn="ctr"/>
-          </a:p>
-        </p:txBody>
-      </p:sp>
-      <p:sp>
-        <p:nvSpPr>
-          <p:cNvPr id="24" name="TextBox 23"/>
-          <p:cNvSpPr txBox="1"/>
-          <p:nvPr/>
-        </p:nvSpPr>
-        <p:spPr>
-          <a:xfrm>
-            <a:off x="566928" y="2139696"/>
-            <a:ext cx="274320" cy="384048"/>
-          </a:xfrm>
-          <a:prstGeom prst="rect">
-            <a:avLst/>
-          </a:prstGeom>
-          <a:noFill/>
-        </p:spPr>
-        <p:txBody>
-          <a:bodyPr wrap="square" lIns="0" rIns="0" tIns="0" bIns="0" anchor="ctr">
-            <a:spAutoFit/>
-          </a:bodyPr>
-          <a:lstStyle/>
-          <a:p>
-            <a:pPr algn="l"/>
-            <a:r>
-              <a:rPr sz="1100" b="0" i="0">
-                <a:solidFill>
-                  <a:srgbClr val="9FB0C3"/>
-                </a:solidFill>
-                <a:latin typeface="Calibri"/>
-              </a:rPr>
-              <a:t>2</a:t>
-            </a:r>
-          </a:p>
-        </p:txBody>
-      </p:sp>
-      <p:sp>
-        <p:nvSpPr>
-          <p:cNvPr id="25" name="TextBox 24"/>
-          <p:cNvSpPr txBox="1"/>
-          <p:nvPr/>
-        </p:nvSpPr>
-        <p:spPr>
-          <a:xfrm>
-            <a:off x="978407" y="2139696"/>
-            <a:ext cx="2194560" cy="384048"/>
-          </a:xfrm>
-          <a:prstGeom prst="rect">
-            <a:avLst/>
-          </a:prstGeom>
-          <a:noFill/>
-        </p:spPr>
-        <p:txBody>
-          <a:bodyPr wrap="square" lIns="0" rIns="0" tIns="0" bIns="0" anchor="ctr">
-            <a:spAutoFit/>
-          </a:bodyPr>
-          <a:lstStyle/>
-          <a:p>
-            <a:pPr algn="l"/>
-            <a:r>
-              <a:rPr sz="1150" b="1" i="0">
-                <a:solidFill>
-                  <a:srgbClr val="EAF0F6"/>
-                </a:solidFill>
-                <a:latin typeface="Calibri"/>
-              </a:rPr>
-              <a:t>Common-mode noise</a:t>
-            </a:r>
-          </a:p>
-        </p:txBody>
-      </p:sp>
-      <p:sp>
-        <p:nvSpPr>
-          <p:cNvPr id="26" name="Oval 25"/>
-          <p:cNvSpPr/>
-          <p:nvPr/>
-        </p:nvSpPr>
-        <p:spPr>
-          <a:xfrm>
-            <a:off x="3355848" y="2212848"/>
-            <a:ext cx="237744" cy="237744"/>
-          </a:xfrm>
-          <a:prstGeom prst="ellipse">
-            <a:avLst/>
-          </a:prstGeom>
-          <a:solidFill>
-            <a:srgbClr val="E05D5D"/>
-          </a:solidFill>
-          <a:ln>
-            <a:noFill/>
-          </a:ln>
-        </p:spPr>
-        <p:txBody>
-          <a:bodyPr rtlCol="0" anchor="ctr"/>
-          <a:lstStyle/>
-          <a:p>
-            <a:pPr algn="ctr"/>
-          </a:p>
-        </p:txBody>
-      </p:sp>
-      <p:sp>
-        <p:nvSpPr>
-          <p:cNvPr id="27" name="TextBox 26"/>
-          <p:cNvSpPr txBox="1"/>
-          <p:nvPr/>
-        </p:nvSpPr>
-        <p:spPr>
-          <a:xfrm>
-            <a:off x="3355848" y="2212848"/>
-            <a:ext cx="237744" cy="237744"/>
-          </a:xfrm>
-          <a:prstGeom prst="rect">
-            <a:avLst/>
-          </a:prstGeom>
-          <a:noFill/>
-        </p:spPr>
-        <p:txBody>
-          <a:bodyPr wrap="square" lIns="0" rIns="0" tIns="0" bIns="0" anchor="ctr">
-            <a:spAutoFit/>
-          </a:bodyPr>
-          <a:lstStyle/>
-          <a:p>
-            <a:pPr algn="ctr"/>
-            <a:r>
-              <a:rPr sz="1100" b="1" i="0">
-                <a:solidFill>
-                  <a:srgbClr val="EAF0F6"/>
-                </a:solidFill>
-                <a:latin typeface="Calibri"/>
-              </a:rPr>
-              <a:t>✗</a:t>
-            </a:r>
-          </a:p>
-        </p:txBody>
-      </p:sp>
-      <p:sp>
-        <p:nvSpPr>
-          <p:cNvPr id="28" name="TextBox 27"/>
-          <p:cNvSpPr txBox="1"/>
-          <p:nvPr/>
-        </p:nvSpPr>
-        <p:spPr>
-          <a:xfrm>
-            <a:off x="3703320" y="2139696"/>
-            <a:ext cx="3675888" cy="384048"/>
-          </a:xfrm>
-          <a:prstGeom prst="rect">
-            <a:avLst/>
-          </a:prstGeom>
-          <a:noFill/>
-        </p:spPr>
-        <p:txBody>
-          <a:bodyPr wrap="square" lIns="0" rIns="0" tIns="0" bIns="0" anchor="ctr">
-            <a:spAutoFit/>
-          </a:bodyPr>
-          <a:lstStyle/>
-          <a:p>
-            <a:pPr algn="l"/>
-            <a:r>
-              <a:rPr sz="1100" b="0" i="0">
-                <a:solidFill>
-                  <a:srgbClr val="9FB0C3"/>
-                </a:solidFill>
-                <a:latin typeface="Calibri"/>
-              </a:rPr>
-              <a:t>Inter-board wires carry common-mode currents</a:t>
-            </a:r>
-          </a:p>
-        </p:txBody>
-      </p:sp>
-      <p:sp>
-        <p:nvSpPr>
-          <p:cNvPr id="29" name="Oval 28"/>
-          <p:cNvSpPr/>
-          <p:nvPr/>
-        </p:nvSpPr>
-        <p:spPr>
-          <a:xfrm>
-            <a:off x="7580375" y="2212848"/>
-            <a:ext cx="237744" cy="237744"/>
-          </a:xfrm>
-          <a:prstGeom prst="ellipse">
-            <a:avLst/>
-          </a:prstGeom>
-          <a:solidFill>
-            <a:srgbClr val="3FA46A"/>
-          </a:solidFill>
-          <a:ln>
-            <a:noFill/>
-          </a:ln>
-        </p:spPr>
-        <p:txBody>
-          <a:bodyPr rtlCol="0" anchor="ctr"/>
-          <a:lstStyle/>
-          <a:p>
-            <a:pPr algn="ctr"/>
-          </a:p>
-        </p:txBody>
-      </p:sp>
-      <p:sp>
-        <p:nvSpPr>
-          <p:cNvPr id="30" name="TextBox 29"/>
-          <p:cNvSpPr txBox="1"/>
-          <p:nvPr/>
-        </p:nvSpPr>
-        <p:spPr>
-          <a:xfrm>
-            <a:off x="7580375" y="2212848"/>
-            <a:ext cx="237744" cy="237744"/>
-          </a:xfrm>
-          <a:prstGeom prst="rect">
-            <a:avLst/>
-          </a:prstGeom>
-          <a:noFill/>
-        </p:spPr>
-        <p:txBody>
-          <a:bodyPr wrap="square" lIns="0" rIns="0" tIns="0" bIns="0" anchor="ctr">
-            <a:spAutoFit/>
-          </a:bodyPr>
-          <a:lstStyle/>
-          <a:p>
-            <a:pPr algn="ctr"/>
-            <a:r>
-              <a:rPr sz="1100" b="1" i="0">
-                <a:solidFill>
-                  <a:srgbClr val="EAF0F6"/>
-                </a:solidFill>
-                <a:latin typeface="Calibri"/>
-              </a:rPr>
-              <a:t>✓</a:t>
-            </a:r>
-          </a:p>
-        </p:txBody>
-      </p:sp>
-      <p:sp>
-        <p:nvSpPr>
-          <p:cNvPr id="31" name="TextBox 30"/>
-          <p:cNvSpPr txBox="1"/>
-          <p:nvPr/>
-        </p:nvSpPr>
-        <p:spPr>
-          <a:xfrm>
-            <a:off x="7927848" y="2139696"/>
-            <a:ext cx="3712464" cy="384048"/>
-          </a:xfrm>
-          <a:prstGeom prst="rect">
-            <a:avLst/>
-          </a:prstGeom>
-          <a:noFill/>
-        </p:spPr>
-        <p:txBody>
-          <a:bodyPr wrap="square" lIns="0" rIns="0" tIns="0" bIns="0" anchor="ctr">
-            <a:spAutoFit/>
-          </a:bodyPr>
-          <a:lstStyle/>
-          <a:p>
-            <a:pPr algn="l"/>
-            <a:r>
-              <a:rPr sz="1100" b="0" i="0">
-                <a:solidFill>
-                  <a:srgbClr val="EAF0F6"/>
-                </a:solidFill>
-                <a:latin typeface="Calibri"/>
-              </a:rPr>
-              <a:t>Short conductors, few CM coupling paths</a:t>
-            </a:r>
-          </a:p>
-        </p:txBody>
-      </p:sp>
-      <p:sp>
-        <p:nvSpPr>
-          <p:cNvPr id="32" name="Rectangle 31"/>
-          <p:cNvSpPr/>
-          <p:nvPr/>
-        </p:nvSpPr>
-        <p:spPr>
-          <a:xfrm>
-            <a:off x="457200" y="2523744"/>
-            <a:ext cx="11274552" cy="384048"/>
-          </a:xfrm>
-          <a:prstGeom prst="rect">
-            <a:avLst/>
-          </a:prstGeom>
-          <a:solidFill>
-            <a:srgbClr val="172331"/>
-          </a:solidFill>
-          <a:ln>
-            <a:noFill/>
-          </a:ln>
-        </p:spPr>
-        <p:txBody>
-          <a:bodyPr rtlCol="0" anchor="ctr"/>
-          <a:lstStyle/>
-          <a:p>
-            <a:pPr algn="ctr"/>
-          </a:p>
-        </p:txBody>
-      </p:sp>
-      <p:sp>
-        <p:nvSpPr>
-          <p:cNvPr id="33" name="TextBox 32"/>
-          <p:cNvSpPr txBox="1"/>
-          <p:nvPr/>
-        </p:nvSpPr>
-        <p:spPr>
-          <a:xfrm>
-            <a:off x="566928" y="2523744"/>
-            <a:ext cx="274320" cy="384048"/>
-          </a:xfrm>
-          <a:prstGeom prst="rect">
-            <a:avLst/>
-          </a:prstGeom>
-          <a:noFill/>
-        </p:spPr>
-        <p:txBody>
-          <a:bodyPr wrap="square" lIns="0" rIns="0" tIns="0" bIns="0" anchor="ctr">
-            <a:spAutoFit/>
-          </a:bodyPr>
-          <a:lstStyle/>
-          <a:p>
-            <a:pPr algn="l"/>
-            <a:r>
-              <a:rPr sz="1100" b="0" i="0">
-                <a:solidFill>
-                  <a:srgbClr val="9FB0C3"/>
-                </a:solidFill>
-                <a:latin typeface="Calibri"/>
-              </a:rPr>
-              <a:t>3</a:t>
-            </a:r>
-          </a:p>
-        </p:txBody>
-      </p:sp>
-      <p:sp>
-        <p:nvSpPr>
-          <p:cNvPr id="34" name="TextBox 33"/>
-          <p:cNvSpPr txBox="1"/>
-          <p:nvPr/>
-        </p:nvSpPr>
-        <p:spPr>
-          <a:xfrm>
-            <a:off x="978407" y="2523744"/>
-            <a:ext cx="2194560" cy="384048"/>
-          </a:xfrm>
-          <a:prstGeom prst="rect">
-            <a:avLst/>
-          </a:prstGeom>
-          <a:noFill/>
-        </p:spPr>
-        <p:txBody>
-          <a:bodyPr wrap="square" lIns="0" rIns="0" tIns="0" bIns="0" anchor="ctr">
-            <a:spAutoFit/>
-          </a:bodyPr>
-          <a:lstStyle/>
-          <a:p>
-            <a:pPr algn="l"/>
-            <a:r>
-              <a:rPr sz="1150" b="1" i="0">
-                <a:solidFill>
-                  <a:srgbClr val="EAF0F6"/>
-                </a:solidFill>
-                <a:latin typeface="Calibri"/>
-              </a:rPr>
-              <a:t>Current loop area</a:t>
-            </a:r>
-          </a:p>
-        </p:txBody>
-      </p:sp>
-      <p:sp>
-        <p:nvSpPr>
-          <p:cNvPr id="35" name="Oval 34"/>
-          <p:cNvSpPr/>
-          <p:nvPr/>
-        </p:nvSpPr>
-        <p:spPr>
-          <a:xfrm>
-            <a:off x="3355848" y="2596896"/>
-            <a:ext cx="237744" cy="237744"/>
-          </a:xfrm>
-          <a:prstGeom prst="ellipse">
-            <a:avLst/>
-          </a:prstGeom>
-          <a:solidFill>
-            <a:srgbClr val="E05D5D"/>
-          </a:solidFill>
-          <a:ln>
-            <a:noFill/>
-          </a:ln>
-        </p:spPr>
-        <p:txBody>
-          <a:bodyPr rtlCol="0" anchor="ctr"/>
-          <a:lstStyle/>
-          <a:p>
-            <a:pPr algn="ctr"/>
-          </a:p>
-        </p:txBody>
-      </p:sp>
-      <p:sp>
-        <p:nvSpPr>
-          <p:cNvPr id="36" name="TextBox 35"/>
-          <p:cNvSpPr txBox="1"/>
-          <p:nvPr/>
-        </p:nvSpPr>
-        <p:spPr>
-          <a:xfrm>
-            <a:off x="3355848" y="2596896"/>
-            <a:ext cx="237744" cy="237744"/>
-          </a:xfrm>
-          <a:prstGeom prst="rect">
-            <a:avLst/>
-          </a:prstGeom>
-          <a:noFill/>
-        </p:spPr>
-        <p:txBody>
-          <a:bodyPr wrap="square" lIns="0" rIns="0" tIns="0" bIns="0" anchor="ctr">
-            <a:spAutoFit/>
-          </a:bodyPr>
-          <a:lstStyle/>
-          <a:p>
-            <a:pPr algn="ctr"/>
-            <a:r>
-              <a:rPr sz="1100" b="1" i="0">
-                <a:solidFill>
-                  <a:srgbClr val="EAF0F6"/>
-                </a:solidFill>
-                <a:latin typeface="Calibri"/>
-              </a:rPr>
-              <a:t>✗</a:t>
-            </a:r>
-          </a:p>
-        </p:txBody>
-      </p:sp>
-      <p:sp>
-        <p:nvSpPr>
-          <p:cNvPr id="37" name="TextBox 36"/>
-          <p:cNvSpPr txBox="1"/>
-          <p:nvPr/>
-        </p:nvSpPr>
-        <p:spPr>
-          <a:xfrm>
-            <a:off x="3703320" y="2523744"/>
-            <a:ext cx="3675888" cy="384048"/>
-          </a:xfrm>
-          <a:prstGeom prst="rect">
-            <a:avLst/>
-          </a:prstGeom>
-          <a:noFill/>
-        </p:spPr>
-        <p:txBody>
-          <a:bodyPr wrap="square" lIns="0" rIns="0" tIns="0" bIns="0" anchor="ctr">
-            <a:spAutoFit/>
-          </a:bodyPr>
-          <a:lstStyle/>
-          <a:p>
-            <a:pPr algn="l"/>
-            <a:r>
-              <a:rPr sz="1100" b="0" i="0">
-                <a:solidFill>
-                  <a:srgbClr val="9FB0C3"/>
-                </a:solidFill>
-                <a:latin typeface="Calibri"/>
-              </a:rPr>
-              <a:t>Harness routing enlarges the loop area</a:t>
-            </a:r>
-          </a:p>
-        </p:txBody>
-      </p:sp>
-      <p:sp>
-        <p:nvSpPr>
-          <p:cNvPr id="38" name="Oval 37"/>
-          <p:cNvSpPr/>
-          <p:nvPr/>
-        </p:nvSpPr>
-        <p:spPr>
-          <a:xfrm>
-            <a:off x="7580375" y="2596896"/>
-            <a:ext cx="237744" cy="237744"/>
-          </a:xfrm>
-          <a:prstGeom prst="ellipse">
-            <a:avLst/>
-          </a:prstGeom>
-          <a:solidFill>
-            <a:srgbClr val="3FA46A"/>
-          </a:solidFill>
-          <a:ln>
-            <a:noFill/>
-          </a:ln>
-        </p:spPr>
-        <p:txBody>
-          <a:bodyPr rtlCol="0" anchor="ctr"/>
-          <a:lstStyle/>
-          <a:p>
-            <a:pPr algn="ctr"/>
-          </a:p>
-        </p:txBody>
-      </p:sp>
-      <p:sp>
-        <p:nvSpPr>
-          <p:cNvPr id="39" name="TextBox 38"/>
-          <p:cNvSpPr txBox="1"/>
-          <p:nvPr/>
-        </p:nvSpPr>
-        <p:spPr>
-          <a:xfrm>
-            <a:off x="7580375" y="2596896"/>
-            <a:ext cx="237744" cy="237744"/>
-          </a:xfrm>
-          <a:prstGeom prst="rect">
-            <a:avLst/>
-          </a:prstGeom>
-          <a:noFill/>
-        </p:spPr>
-        <p:txBody>
-          <a:bodyPr wrap="square" lIns="0" rIns="0" tIns="0" bIns="0" anchor="ctr">
-            <a:spAutoFit/>
-          </a:bodyPr>
-          <a:lstStyle/>
-          <a:p>
-            <a:pPr algn="ctr"/>
-            <a:r>
-              <a:rPr sz="1100" b="1" i="0">
-                <a:solidFill>
-                  <a:srgbClr val="EAF0F6"/>
-                </a:solidFill>
-                <a:latin typeface="Calibri"/>
-              </a:rPr>
-              <a:t>✓</a:t>
-            </a:r>
-          </a:p>
-        </p:txBody>
-      </p:sp>
-      <p:sp>
-        <p:nvSpPr>
-          <p:cNvPr id="40" name="TextBox 39"/>
-          <p:cNvSpPr txBox="1"/>
-          <p:nvPr/>
-        </p:nvSpPr>
-        <p:spPr>
-          <a:xfrm>
-            <a:off x="7927848" y="2523744"/>
-            <a:ext cx="3712464" cy="384048"/>
-          </a:xfrm>
-          <a:prstGeom prst="rect">
-            <a:avLst/>
-          </a:prstGeom>
-          <a:noFill/>
-        </p:spPr>
-        <p:txBody>
-          <a:bodyPr wrap="square" lIns="0" rIns="0" tIns="0" bIns="0" anchor="ctr">
-            <a:spAutoFit/>
-          </a:bodyPr>
-          <a:lstStyle/>
-          <a:p>
-            <a:pPr algn="l"/>
-            <a:r>
-              <a:rPr sz="1100" b="0" i="0">
-                <a:solidFill>
-                  <a:srgbClr val="EAF0F6"/>
-                </a:solidFill>
-                <a:latin typeface="Calibri"/>
-              </a:rPr>
-              <a:t>Forward &amp; return routed tightly in copper</a:t>
-            </a:r>
-          </a:p>
-        </p:txBody>
-      </p:sp>
-      <p:sp>
-        <p:nvSpPr>
-          <p:cNvPr id="41" name="Rectangle 40"/>
-          <p:cNvSpPr/>
-          <p:nvPr/>
-        </p:nvSpPr>
-        <p:spPr>
-          <a:xfrm>
-            <a:off x="457200" y="2907791"/>
-            <a:ext cx="11274552" cy="384048"/>
-          </a:xfrm>
-          <a:prstGeom prst="rect">
-            <a:avLst/>
-          </a:prstGeom>
-          <a:solidFill>
-            <a:srgbClr val="0E1621"/>
-          </a:solidFill>
-          <a:ln>
-            <a:noFill/>
-          </a:ln>
-        </p:spPr>
-        <p:txBody>
-          <a:bodyPr rtlCol="0" anchor="ctr"/>
-          <a:lstStyle/>
-          <a:p>
-            <a:pPr algn="ctr"/>
-          </a:p>
-        </p:txBody>
-      </p:sp>
-      <p:sp>
-        <p:nvSpPr>
-          <p:cNvPr id="42" name="TextBox 41"/>
-          <p:cNvSpPr txBox="1"/>
-          <p:nvPr/>
-        </p:nvSpPr>
-        <p:spPr>
-          <a:xfrm>
-            <a:off x="566928" y="2907791"/>
-            <a:ext cx="274320" cy="384048"/>
-          </a:xfrm>
-          <a:prstGeom prst="rect">
-            <a:avLst/>
-          </a:prstGeom>
-          <a:noFill/>
-        </p:spPr>
-        <p:txBody>
-          <a:bodyPr wrap="square" lIns="0" rIns="0" tIns="0" bIns="0" anchor="ctr">
-            <a:spAutoFit/>
-          </a:bodyPr>
-          <a:lstStyle/>
-          <a:p>
-            <a:pPr algn="l"/>
-            <a:r>
-              <a:rPr sz="1100" b="0" i="0">
-                <a:solidFill>
-                  <a:srgbClr val="9FB0C3"/>
-                </a:solidFill>
-                <a:latin typeface="Calibri"/>
-              </a:rPr>
-              <a:t>4</a:t>
-            </a:r>
-          </a:p>
-        </p:txBody>
-      </p:sp>
-      <p:sp>
-        <p:nvSpPr>
-          <p:cNvPr id="43" name="TextBox 42"/>
-          <p:cNvSpPr txBox="1"/>
-          <p:nvPr/>
-        </p:nvSpPr>
-        <p:spPr>
-          <a:xfrm>
-            <a:off x="978407" y="2907791"/>
-            <a:ext cx="2194560" cy="384048"/>
-          </a:xfrm>
-          <a:prstGeom prst="rect">
-            <a:avLst/>
-          </a:prstGeom>
-          <a:noFill/>
-        </p:spPr>
-        <p:txBody>
-          <a:bodyPr wrap="square" lIns="0" rIns="0" tIns="0" bIns="0" anchor="ctr">
-            <a:spAutoFit/>
-          </a:bodyPr>
-          <a:lstStyle/>
-          <a:p>
-            <a:pPr algn="l"/>
-            <a:r>
-              <a:rPr sz="1150" b="1" i="0">
-                <a:solidFill>
-                  <a:srgbClr val="EAF0F6"/>
-                </a:solidFill>
-                <a:latin typeface="Calibri"/>
-              </a:rPr>
-              <a:t>Ground reference ★</a:t>
-            </a:r>
-          </a:p>
-        </p:txBody>
-      </p:sp>
-      <p:sp>
-        <p:nvSpPr>
-          <p:cNvPr id="44" name="Oval 43"/>
-          <p:cNvSpPr/>
-          <p:nvPr/>
-        </p:nvSpPr>
-        <p:spPr>
-          <a:xfrm>
-            <a:off x="3355848" y="2980944"/>
-            <a:ext cx="237744" cy="237744"/>
-          </a:xfrm>
-          <a:prstGeom prst="ellipse">
-            <a:avLst/>
-          </a:prstGeom>
-          <a:solidFill>
-            <a:srgbClr val="E05D5D"/>
-          </a:solidFill>
-          <a:ln>
-            <a:noFill/>
-          </a:ln>
-        </p:spPr>
-        <p:txBody>
-          <a:bodyPr rtlCol="0" anchor="ctr"/>
-          <a:lstStyle/>
-          <a:p>
-            <a:pPr algn="ctr"/>
-          </a:p>
-        </p:txBody>
-      </p:sp>
-      <p:sp>
-        <p:nvSpPr>
-          <p:cNvPr id="45" name="TextBox 44"/>
-          <p:cNvSpPr txBox="1"/>
-          <p:nvPr/>
-        </p:nvSpPr>
-        <p:spPr>
-          <a:xfrm>
-            <a:off x="3355848" y="2980944"/>
-            <a:ext cx="237744" cy="237744"/>
-          </a:xfrm>
-          <a:prstGeom prst="rect">
-            <a:avLst/>
-          </a:prstGeom>
-          <a:noFill/>
-        </p:spPr>
-        <p:txBody>
-          <a:bodyPr wrap="square" lIns="0" rIns="0" tIns="0" bIns="0" anchor="ctr">
-            <a:spAutoFit/>
-          </a:bodyPr>
-          <a:lstStyle/>
-          <a:p>
-            <a:pPr algn="ctr"/>
-            <a:r>
-              <a:rPr sz="1100" b="1" i="0">
-                <a:solidFill>
-                  <a:srgbClr val="EAF0F6"/>
-                </a:solidFill>
-                <a:latin typeface="Calibri"/>
-              </a:rPr>
-              <a:t>✗</a:t>
-            </a:r>
-          </a:p>
-        </p:txBody>
-      </p:sp>
-      <p:sp>
-        <p:nvSpPr>
-          <p:cNvPr id="46" name="TextBox 45"/>
-          <p:cNvSpPr txBox="1"/>
-          <p:nvPr/>
-        </p:nvSpPr>
-        <p:spPr>
-          <a:xfrm>
-            <a:off x="3703320" y="2907791"/>
-            <a:ext cx="3675888" cy="384048"/>
-          </a:xfrm>
-          <a:prstGeom prst="rect">
-            <a:avLst/>
-          </a:prstGeom>
-          <a:noFill/>
-        </p:spPr>
-        <p:txBody>
-          <a:bodyPr wrap="square" lIns="0" rIns="0" tIns="0" bIns="0" anchor="ctr">
-            <a:spAutoFit/>
-          </a:bodyPr>
-          <a:lstStyle/>
-          <a:p>
-            <a:pPr algn="l"/>
-            <a:r>
-              <a:rPr sz="1100" b="0" i="0">
-                <a:solidFill>
-                  <a:srgbClr val="9FB0C3"/>
-                </a:solidFill>
-                <a:latin typeface="Calibri"/>
-              </a:rPr>
-              <a:t>Ground offset across the harness between boards</a:t>
-            </a:r>
-          </a:p>
-        </p:txBody>
-      </p:sp>
-      <p:sp>
-        <p:nvSpPr>
-          <p:cNvPr id="47" name="Oval 46"/>
-          <p:cNvSpPr/>
-          <p:nvPr/>
-        </p:nvSpPr>
-        <p:spPr>
-          <a:xfrm>
-            <a:off x="7580375" y="2980944"/>
-            <a:ext cx="237744" cy="237744"/>
-          </a:xfrm>
-          <a:prstGeom prst="ellipse">
-            <a:avLst/>
-          </a:prstGeom>
-          <a:solidFill>
-            <a:srgbClr val="3FA46A"/>
-          </a:solidFill>
-          <a:ln>
-            <a:noFill/>
-          </a:ln>
-        </p:spPr>
-        <p:txBody>
-          <a:bodyPr rtlCol="0" anchor="ctr"/>
-          <a:lstStyle/>
-          <a:p>
-            <a:pPr algn="ctr"/>
-          </a:p>
-        </p:txBody>
-      </p:sp>
-      <p:sp>
-        <p:nvSpPr>
-          <p:cNvPr id="48" name="TextBox 47"/>
-          <p:cNvSpPr txBox="1"/>
-          <p:nvPr/>
-        </p:nvSpPr>
-        <p:spPr>
-          <a:xfrm>
-            <a:off x="7580375" y="2980944"/>
-            <a:ext cx="237744" cy="237744"/>
-          </a:xfrm>
-          <a:prstGeom prst="rect">
-            <a:avLst/>
-          </a:prstGeom>
-          <a:noFill/>
-        </p:spPr>
-        <p:txBody>
-          <a:bodyPr wrap="square" lIns="0" rIns="0" tIns="0" bIns="0" anchor="ctr">
-            <a:spAutoFit/>
-          </a:bodyPr>
-          <a:lstStyle/>
-          <a:p>
-            <a:pPr algn="ctr"/>
-            <a:r>
-              <a:rPr sz="1100" b="1" i="0">
-                <a:solidFill>
-                  <a:srgbClr val="EAF0F6"/>
-                </a:solidFill>
-                <a:latin typeface="Calibri"/>
-              </a:rPr>
-              <a:t>✓</a:t>
-            </a:r>
-          </a:p>
-        </p:txBody>
-      </p:sp>
-      <p:sp>
-        <p:nvSpPr>
-          <p:cNvPr id="49" name="TextBox 48"/>
-          <p:cNvSpPr txBox="1"/>
-          <p:nvPr/>
-        </p:nvSpPr>
-        <p:spPr>
-          <a:xfrm>
-            <a:off x="7927848" y="2907791"/>
-            <a:ext cx="3712464" cy="384048"/>
-          </a:xfrm>
-          <a:prstGeom prst="rect">
-            <a:avLst/>
-          </a:prstGeom>
-          <a:noFill/>
-        </p:spPr>
-        <p:txBody>
-          <a:bodyPr wrap="square" lIns="0" rIns="0" tIns="0" bIns="0" anchor="ctr">
-            <a:spAutoFit/>
-          </a:bodyPr>
-          <a:lstStyle/>
-          <a:p>
-            <a:pPr algn="l"/>
-            <a:r>
-              <a:rPr sz="1100" b="0" i="0">
-                <a:solidFill>
-                  <a:srgbClr val="EAF0F6"/>
-                </a:solidFill>
-                <a:latin typeface="Calibri"/>
-              </a:rPr>
-              <a:t>One continuous ground plane end to end</a:t>
-            </a:r>
-          </a:p>
-        </p:txBody>
-      </p:sp>
-      <p:sp>
-        <p:nvSpPr>
-          <p:cNvPr id="50" name="Rectangle 49"/>
-          <p:cNvSpPr/>
-          <p:nvPr/>
-        </p:nvSpPr>
-        <p:spPr>
-          <a:xfrm>
-            <a:off x="457200" y="3291839"/>
-            <a:ext cx="11274552" cy="384048"/>
-          </a:xfrm>
-          <a:prstGeom prst="rect">
-            <a:avLst/>
-          </a:prstGeom>
-          <a:solidFill>
-            <a:srgbClr val="172331"/>
-          </a:solidFill>
-          <a:ln>
-            <a:noFill/>
-          </a:ln>
-        </p:spPr>
-        <p:txBody>
-          <a:bodyPr rtlCol="0" anchor="ctr"/>
-          <a:lstStyle/>
-          <a:p>
-            <a:pPr algn="ctr"/>
-          </a:p>
-        </p:txBody>
-      </p:sp>
-      <p:sp>
-        <p:nvSpPr>
-          <p:cNvPr id="51" name="TextBox 50"/>
-          <p:cNvSpPr txBox="1"/>
-          <p:nvPr/>
-        </p:nvSpPr>
-        <p:spPr>
-          <a:xfrm>
-            <a:off x="566928" y="3291839"/>
-            <a:ext cx="274320" cy="384048"/>
-          </a:xfrm>
-          <a:prstGeom prst="rect">
-            <a:avLst/>
-          </a:prstGeom>
-          <a:noFill/>
-        </p:spPr>
-        <p:txBody>
-          <a:bodyPr wrap="square" lIns="0" rIns="0" tIns="0" bIns="0" anchor="ctr">
-            <a:spAutoFit/>
-          </a:bodyPr>
-          <a:lstStyle/>
-          <a:p>
-            <a:pPr algn="l"/>
-            <a:r>
-              <a:rPr sz="1100" b="0" i="0">
-                <a:solidFill>
-                  <a:srgbClr val="9FB0C3"/>
-                </a:solidFill>
-                <a:latin typeface="Calibri"/>
-              </a:rPr>
-              <a:t>5</a:t>
-            </a:r>
-          </a:p>
-        </p:txBody>
-      </p:sp>
-      <p:sp>
-        <p:nvSpPr>
-          <p:cNvPr id="52" name="TextBox 51"/>
-          <p:cNvSpPr txBox="1"/>
-          <p:nvPr/>
-        </p:nvSpPr>
-        <p:spPr>
-          <a:xfrm>
-            <a:off x="978407" y="3291839"/>
-            <a:ext cx="2194560" cy="384048"/>
-          </a:xfrm>
-          <a:prstGeom prst="rect">
-            <a:avLst/>
-          </a:prstGeom>
-          <a:noFill/>
-        </p:spPr>
-        <p:txBody>
-          <a:bodyPr wrap="square" lIns="0" rIns="0" tIns="0" bIns="0" anchor="ctr">
-            <a:spAutoFit/>
-          </a:bodyPr>
-          <a:lstStyle/>
-          <a:p>
-            <a:pPr algn="l"/>
-            <a:r>
-              <a:rPr sz="1150" b="1" i="0">
-                <a:solidFill>
-                  <a:srgbClr val="EAF0F6"/>
-                </a:solidFill>
-                <a:latin typeface="Calibri"/>
-              </a:rPr>
-              <a:t>RF immunity &amp; ESD</a:t>
-            </a:r>
-          </a:p>
-        </p:txBody>
-      </p:sp>
-      <p:sp>
-        <p:nvSpPr>
-          <p:cNvPr id="53" name="Oval 52"/>
-          <p:cNvSpPr/>
-          <p:nvPr/>
-        </p:nvSpPr>
-        <p:spPr>
-          <a:xfrm>
-            <a:off x="3355848" y="3364991"/>
-            <a:ext cx="237744" cy="237744"/>
-          </a:xfrm>
-          <a:prstGeom prst="ellipse">
-            <a:avLst/>
-          </a:prstGeom>
-          <a:solidFill>
-            <a:srgbClr val="E05D5D"/>
-          </a:solidFill>
-          <a:ln>
-            <a:noFill/>
-          </a:ln>
-        </p:spPr>
-        <p:txBody>
-          <a:bodyPr rtlCol="0" anchor="ctr"/>
-          <a:lstStyle/>
-          <a:p>
-            <a:pPr algn="ctr"/>
-          </a:p>
-        </p:txBody>
-      </p:sp>
-      <p:sp>
-        <p:nvSpPr>
-          <p:cNvPr id="54" name="TextBox 53"/>
-          <p:cNvSpPr txBox="1"/>
-          <p:nvPr/>
-        </p:nvSpPr>
-        <p:spPr>
-          <a:xfrm>
-            <a:off x="3355848" y="3364991"/>
-            <a:ext cx="237744" cy="237744"/>
-          </a:xfrm>
-          <a:prstGeom prst="rect">
-            <a:avLst/>
-          </a:prstGeom>
-          <a:noFill/>
-        </p:spPr>
-        <p:txBody>
-          <a:bodyPr wrap="square" lIns="0" rIns="0" tIns="0" bIns="0" anchor="ctr">
-            <a:spAutoFit/>
-          </a:bodyPr>
-          <a:lstStyle/>
-          <a:p>
-            <a:pPr algn="ctr"/>
-            <a:r>
-              <a:rPr sz="1100" b="1" i="0">
-                <a:solidFill>
-                  <a:srgbClr val="EAF0F6"/>
-                </a:solidFill>
-                <a:latin typeface="Calibri"/>
-              </a:rPr>
-              <a:t>✗</a:t>
-            </a:r>
-          </a:p>
-        </p:txBody>
-      </p:sp>
-      <p:sp>
-        <p:nvSpPr>
-          <p:cNvPr id="55" name="TextBox 54"/>
-          <p:cNvSpPr txBox="1"/>
-          <p:nvPr/>
-        </p:nvSpPr>
-        <p:spPr>
-          <a:xfrm>
-            <a:off x="3703320" y="3291839"/>
-            <a:ext cx="3675888" cy="384048"/>
-          </a:xfrm>
-          <a:prstGeom prst="rect">
-            <a:avLst/>
-          </a:prstGeom>
-          <a:noFill/>
-        </p:spPr>
-        <p:txBody>
-          <a:bodyPr wrap="square" lIns="0" rIns="0" tIns="0" bIns="0" anchor="ctr">
-            <a:spAutoFit/>
-          </a:bodyPr>
-          <a:lstStyle/>
-          <a:p>
-            <a:pPr algn="l"/>
-            <a:r>
-              <a:rPr sz="1100" b="0" i="0">
-                <a:solidFill>
-                  <a:srgbClr val="9FB0C3"/>
-                </a:solidFill>
-                <a:latin typeface="Calibri"/>
-              </a:rPr>
-              <a:t>Harnesses pick up RF; more ESD entry points</a:t>
-            </a:r>
-          </a:p>
-        </p:txBody>
-      </p:sp>
-      <p:sp>
-        <p:nvSpPr>
-          <p:cNvPr id="56" name="Oval 55"/>
-          <p:cNvSpPr/>
-          <p:nvPr/>
-        </p:nvSpPr>
-        <p:spPr>
-          <a:xfrm>
-            <a:off x="7580375" y="3364991"/>
-            <a:ext cx="237744" cy="237744"/>
-          </a:xfrm>
-          <a:prstGeom prst="ellipse">
-            <a:avLst/>
-          </a:prstGeom>
-          <a:solidFill>
-            <a:srgbClr val="3FA46A"/>
-          </a:solidFill>
-          <a:ln>
-            <a:noFill/>
-          </a:ln>
-        </p:spPr>
-        <p:txBody>
-          <a:bodyPr rtlCol="0" anchor="ctr"/>
-          <a:lstStyle/>
-          <a:p>
-            <a:pPr algn="ctr"/>
-          </a:p>
-        </p:txBody>
-      </p:sp>
-      <p:sp>
-        <p:nvSpPr>
-          <p:cNvPr id="57" name="TextBox 56"/>
-          <p:cNvSpPr txBox="1"/>
-          <p:nvPr/>
-        </p:nvSpPr>
-        <p:spPr>
-          <a:xfrm>
-            <a:off x="7580375" y="3364991"/>
-            <a:ext cx="237744" cy="237744"/>
-          </a:xfrm>
-          <a:prstGeom prst="rect">
-            <a:avLst/>
-          </a:prstGeom>
-          <a:noFill/>
-        </p:spPr>
-        <p:txBody>
-          <a:bodyPr wrap="square" lIns="0" rIns="0" tIns="0" bIns="0" anchor="ctr">
-            <a:spAutoFit/>
-          </a:bodyPr>
-          <a:lstStyle/>
-          <a:p>
-            <a:pPr algn="ctr"/>
-            <a:r>
-              <a:rPr sz="1100" b="1" i="0">
-                <a:solidFill>
-                  <a:srgbClr val="EAF0F6"/>
-                </a:solidFill>
-                <a:latin typeface="Calibri"/>
-              </a:rPr>
-              <a:t>✓</a:t>
-            </a:r>
-          </a:p>
-        </p:txBody>
-      </p:sp>
-      <p:sp>
-        <p:nvSpPr>
-          <p:cNvPr id="58" name="TextBox 57"/>
-          <p:cNvSpPr txBox="1"/>
-          <p:nvPr/>
-        </p:nvSpPr>
-        <p:spPr>
-          <a:xfrm>
-            <a:off x="7927848" y="3291839"/>
-            <a:ext cx="3712464" cy="384048"/>
-          </a:xfrm>
-          <a:prstGeom prst="rect">
-            <a:avLst/>
-          </a:prstGeom>
-          <a:noFill/>
-        </p:spPr>
-        <p:txBody>
-          <a:bodyPr wrap="square" lIns="0" rIns="0" tIns="0" bIns="0" anchor="ctr">
-            <a:spAutoFit/>
-          </a:bodyPr>
-          <a:lstStyle/>
-          <a:p>
-            <a:pPr algn="l"/>
-            <a:r>
-              <a:rPr sz="1100" b="0" i="0">
-                <a:solidFill>
-                  <a:srgbClr val="EAF0F6"/>
-                </a:solidFill>
-                <a:latin typeface="Calibri"/>
-              </a:rPr>
-              <a:t>Fewer conductors and interfaces to protect</a:t>
-            </a:r>
-          </a:p>
-        </p:txBody>
-      </p:sp>
-      <p:sp>
-        <p:nvSpPr>
-          <p:cNvPr id="59" name="Rectangle 58"/>
-          <p:cNvSpPr/>
-          <p:nvPr/>
-        </p:nvSpPr>
-        <p:spPr>
-          <a:xfrm>
-            <a:off x="457200" y="3675887"/>
-            <a:ext cx="11274552" cy="384048"/>
-          </a:xfrm>
-          <a:prstGeom prst="rect">
-            <a:avLst/>
-          </a:prstGeom>
-          <a:solidFill>
-            <a:srgbClr val="0E1621"/>
-          </a:solidFill>
-          <a:ln>
-            <a:noFill/>
-          </a:ln>
-        </p:spPr>
-        <p:txBody>
-          <a:bodyPr rtlCol="0" anchor="ctr"/>
-          <a:lstStyle/>
-          <a:p>
-            <a:pPr algn="ctr"/>
-          </a:p>
-        </p:txBody>
-      </p:sp>
-      <p:sp>
-        <p:nvSpPr>
-          <p:cNvPr id="60" name="TextBox 59"/>
-          <p:cNvSpPr txBox="1"/>
-          <p:nvPr/>
-        </p:nvSpPr>
-        <p:spPr>
-          <a:xfrm>
-            <a:off x="566928" y="3675887"/>
-            <a:ext cx="274320" cy="384048"/>
-          </a:xfrm>
-          <a:prstGeom prst="rect">
-            <a:avLst/>
-          </a:prstGeom>
-          <a:noFill/>
-        </p:spPr>
-        <p:txBody>
-          <a:bodyPr wrap="square" lIns="0" rIns="0" tIns="0" bIns="0" anchor="ctr">
-            <a:spAutoFit/>
-          </a:bodyPr>
-          <a:lstStyle/>
-          <a:p>
-            <a:pPr algn="l"/>
-            <a:r>
-              <a:rPr sz="1100" b="0" i="0">
-                <a:solidFill>
-                  <a:srgbClr val="9FB0C3"/>
-                </a:solidFill>
-                <a:latin typeface="Calibri"/>
-              </a:rPr>
-              <a:t>6</a:t>
-            </a:r>
-          </a:p>
-        </p:txBody>
-      </p:sp>
-      <p:sp>
-        <p:nvSpPr>
-          <p:cNvPr id="61" name="TextBox 60"/>
-          <p:cNvSpPr txBox="1"/>
-          <p:nvPr/>
-        </p:nvSpPr>
-        <p:spPr>
-          <a:xfrm>
-            <a:off x="978407" y="3675887"/>
-            <a:ext cx="2194560" cy="384048"/>
-          </a:xfrm>
-          <a:prstGeom prst="rect">
-            <a:avLst/>
-          </a:prstGeom>
-          <a:noFill/>
-        </p:spPr>
-        <p:txBody>
-          <a:bodyPr wrap="square" lIns="0" rIns="0" tIns="0" bIns="0" anchor="ctr">
-            <a:spAutoFit/>
-          </a:bodyPr>
-          <a:lstStyle/>
-          <a:p>
-            <a:pPr algn="l"/>
-            <a:r>
-              <a:rPr sz="1150" b="1" i="0">
-                <a:solidFill>
-                  <a:srgbClr val="EAF0F6"/>
-                </a:solidFill>
-                <a:latin typeface="Calibri"/>
-              </a:rPr>
-              <a:t>Connector reliability</a:t>
-            </a:r>
-          </a:p>
-        </p:txBody>
-      </p:sp>
-      <p:sp>
-        <p:nvSpPr>
-          <p:cNvPr id="62" name="Oval 61"/>
-          <p:cNvSpPr/>
-          <p:nvPr/>
-        </p:nvSpPr>
-        <p:spPr>
-          <a:xfrm>
-            <a:off x="3355848" y="3749039"/>
-            <a:ext cx="237744" cy="237744"/>
-          </a:xfrm>
-          <a:prstGeom prst="ellipse">
-            <a:avLst/>
-          </a:prstGeom>
-          <a:solidFill>
-            <a:srgbClr val="E05D5D"/>
-          </a:solidFill>
-          <a:ln>
-            <a:noFill/>
-          </a:ln>
-        </p:spPr>
-        <p:txBody>
-          <a:bodyPr rtlCol="0" anchor="ctr"/>
-          <a:lstStyle/>
-          <a:p>
-            <a:pPr algn="ctr"/>
-          </a:p>
-        </p:txBody>
-      </p:sp>
-      <p:sp>
-        <p:nvSpPr>
-          <p:cNvPr id="63" name="TextBox 62"/>
-          <p:cNvSpPr txBox="1"/>
-          <p:nvPr/>
-        </p:nvSpPr>
-        <p:spPr>
-          <a:xfrm>
-            <a:off x="3355848" y="3749039"/>
-            <a:ext cx="237744" cy="237744"/>
-          </a:xfrm>
-          <a:prstGeom prst="rect">
-            <a:avLst/>
-          </a:prstGeom>
-          <a:noFill/>
-        </p:spPr>
-        <p:txBody>
-          <a:bodyPr wrap="square" lIns="0" rIns="0" tIns="0" bIns="0" anchor="ctr">
-            <a:spAutoFit/>
-          </a:bodyPr>
-          <a:lstStyle/>
-          <a:p>
-            <a:pPr algn="ctr"/>
-            <a:r>
-              <a:rPr sz="1100" b="1" i="0">
-                <a:solidFill>
-                  <a:srgbClr val="EAF0F6"/>
-                </a:solidFill>
-                <a:latin typeface="Calibri"/>
-              </a:rPr>
-              <a:t>✗</a:t>
-            </a:r>
-          </a:p>
-        </p:txBody>
-      </p:sp>
-      <p:sp>
-        <p:nvSpPr>
-          <p:cNvPr id="64" name="TextBox 63"/>
-          <p:cNvSpPr txBox="1"/>
-          <p:nvPr/>
-        </p:nvSpPr>
-        <p:spPr>
-          <a:xfrm>
-            <a:off x="3703320" y="3675887"/>
-            <a:ext cx="3675888" cy="384048"/>
-          </a:xfrm>
-          <a:prstGeom prst="rect">
-            <a:avLst/>
-          </a:prstGeom>
-          <a:noFill/>
-        </p:spPr>
-        <p:txBody>
-          <a:bodyPr wrap="square" lIns="0" rIns="0" tIns="0" bIns="0" anchor="ctr">
-            <a:spAutoFit/>
-          </a:bodyPr>
-          <a:lstStyle/>
-          <a:p>
-            <a:pPr algn="l"/>
-            <a:r>
-              <a:rPr sz="1100" b="0" i="0">
-                <a:solidFill>
-                  <a:srgbClr val="9FB0C3"/>
-                </a:solidFill>
-                <a:latin typeface="Calibri"/>
-              </a:rPr>
-              <a:t>More connectors/crimps stressed by vibration</a:t>
-            </a:r>
-          </a:p>
-        </p:txBody>
-      </p:sp>
-      <p:sp>
-        <p:nvSpPr>
-          <p:cNvPr id="65" name="Oval 64"/>
-          <p:cNvSpPr/>
-          <p:nvPr/>
-        </p:nvSpPr>
-        <p:spPr>
-          <a:xfrm>
-            <a:off x="7580375" y="3749039"/>
-            <a:ext cx="237744" cy="237744"/>
-          </a:xfrm>
-          <a:prstGeom prst="ellipse">
-            <a:avLst/>
-          </a:prstGeom>
-          <a:solidFill>
-            <a:srgbClr val="3FA46A"/>
-          </a:solidFill>
-          <a:ln>
-            <a:noFill/>
-          </a:ln>
-        </p:spPr>
-        <p:txBody>
-          <a:bodyPr rtlCol="0" anchor="ctr"/>
-          <a:lstStyle/>
-          <a:p>
-            <a:pPr algn="ctr"/>
-          </a:p>
-        </p:txBody>
-      </p:sp>
-      <p:sp>
-        <p:nvSpPr>
-          <p:cNvPr id="66" name="TextBox 65"/>
-          <p:cNvSpPr txBox="1"/>
-          <p:nvPr/>
-        </p:nvSpPr>
-        <p:spPr>
-          <a:xfrm>
-            <a:off x="7580375" y="3749039"/>
-            <a:ext cx="237744" cy="237744"/>
-          </a:xfrm>
-          <a:prstGeom prst="rect">
-            <a:avLst/>
-          </a:prstGeom>
-          <a:noFill/>
-        </p:spPr>
-        <p:txBody>
-          <a:bodyPr wrap="square" lIns="0" rIns="0" tIns="0" bIns="0" anchor="ctr">
-            <a:spAutoFit/>
-          </a:bodyPr>
-          <a:lstStyle/>
-          <a:p>
-            <a:pPr algn="ctr"/>
-            <a:r>
-              <a:rPr sz="1100" b="1" i="0">
-                <a:solidFill>
-                  <a:srgbClr val="EAF0F6"/>
-                </a:solidFill>
-                <a:latin typeface="Calibri"/>
-              </a:rPr>
-              <a:t>✓</a:t>
-            </a:r>
-          </a:p>
-        </p:txBody>
-      </p:sp>
-      <p:sp>
-        <p:nvSpPr>
-          <p:cNvPr id="67" name="TextBox 66"/>
-          <p:cNvSpPr txBox="1"/>
-          <p:nvPr/>
-        </p:nvSpPr>
-        <p:spPr>
-          <a:xfrm>
-            <a:off x="7927848" y="3675887"/>
-            <a:ext cx="3712464" cy="384048"/>
-          </a:xfrm>
-          <a:prstGeom prst="rect">
-            <a:avLst/>
-          </a:prstGeom>
-          <a:noFill/>
-        </p:spPr>
-        <p:txBody>
-          <a:bodyPr wrap="square" lIns="0" rIns="0" tIns="0" bIns="0" anchor="ctr">
-            <a:spAutoFit/>
-          </a:bodyPr>
-          <a:lstStyle/>
-          <a:p>
-            <a:pPr algn="l"/>
-            <a:r>
-              <a:rPr sz="1100" b="0" i="0">
-                <a:solidFill>
-                  <a:srgbClr val="EAF0F6"/>
-                </a:solidFill>
-                <a:latin typeface="Calibri"/>
-              </a:rPr>
-              <a:t>Fewer interfaces, fewer failure points</a:t>
-            </a:r>
-          </a:p>
-        </p:txBody>
-      </p:sp>
-      <p:sp>
-        <p:nvSpPr>
-          <p:cNvPr id="68" name="Rectangle 67"/>
-          <p:cNvSpPr/>
-          <p:nvPr/>
-        </p:nvSpPr>
-        <p:spPr>
-          <a:xfrm>
-            <a:off x="457200" y="4059935"/>
-            <a:ext cx="11274552" cy="384048"/>
-          </a:xfrm>
-          <a:prstGeom prst="rect">
-            <a:avLst/>
-          </a:prstGeom>
-          <a:solidFill>
-            <a:srgbClr val="172331"/>
-          </a:solidFill>
-          <a:ln>
-            <a:noFill/>
-          </a:ln>
-        </p:spPr>
-        <p:txBody>
-          <a:bodyPr rtlCol="0" anchor="ctr"/>
-          <a:lstStyle/>
-          <a:p>
-            <a:pPr algn="ctr"/>
-          </a:p>
-        </p:txBody>
-      </p:sp>
-      <p:sp>
-        <p:nvSpPr>
-          <p:cNvPr id="69" name="TextBox 68"/>
-          <p:cNvSpPr txBox="1"/>
-          <p:nvPr/>
-        </p:nvSpPr>
-        <p:spPr>
-          <a:xfrm>
-            <a:off x="566928" y="4059935"/>
-            <a:ext cx="274320" cy="384048"/>
-          </a:xfrm>
-          <a:prstGeom prst="rect">
-            <a:avLst/>
-          </a:prstGeom>
-          <a:noFill/>
-        </p:spPr>
-        <p:txBody>
-          <a:bodyPr wrap="square" lIns="0" rIns="0" tIns="0" bIns="0" anchor="ctr">
-            <a:spAutoFit/>
-          </a:bodyPr>
-          <a:lstStyle/>
-          <a:p>
-            <a:pPr algn="l"/>
-            <a:r>
-              <a:rPr sz="1100" b="0" i="0">
-                <a:solidFill>
-                  <a:srgbClr val="9FB0C3"/>
-                </a:solidFill>
-                <a:latin typeface="Calibri"/>
-              </a:rPr>
-              <a:t>7</a:t>
-            </a:r>
-          </a:p>
-        </p:txBody>
-      </p:sp>
-      <p:sp>
-        <p:nvSpPr>
-          <p:cNvPr id="70" name="TextBox 69"/>
-          <p:cNvSpPr txBox="1"/>
-          <p:nvPr/>
-        </p:nvSpPr>
-        <p:spPr>
-          <a:xfrm>
-            <a:off x="978407" y="4059935"/>
-            <a:ext cx="2194560" cy="384048"/>
-          </a:xfrm>
-          <a:prstGeom prst="rect">
-            <a:avLst/>
-          </a:prstGeom>
-          <a:noFill/>
-        </p:spPr>
-        <p:txBody>
-          <a:bodyPr wrap="square" lIns="0" rIns="0" tIns="0" bIns="0" anchor="ctr">
-            <a:spAutoFit/>
-          </a:bodyPr>
-          <a:lstStyle/>
-          <a:p>
-            <a:pPr algn="l"/>
-            <a:r>
-              <a:rPr sz="1150" b="1" i="0">
-                <a:solidFill>
-                  <a:srgbClr val="EAF0F6"/>
-                </a:solidFill>
-                <a:latin typeface="Calibri"/>
-              </a:rPr>
-              <a:t>BOM &amp; assembly</a:t>
-            </a:r>
-          </a:p>
-        </p:txBody>
-      </p:sp>
-      <p:sp>
-        <p:nvSpPr>
-          <p:cNvPr id="71" name="Oval 70"/>
-          <p:cNvSpPr/>
-          <p:nvPr/>
-        </p:nvSpPr>
-        <p:spPr>
-          <a:xfrm>
-            <a:off x="3355848" y="4133087"/>
-            <a:ext cx="237744" cy="237744"/>
-          </a:xfrm>
-          <a:prstGeom prst="ellipse">
-            <a:avLst/>
-          </a:prstGeom>
-          <a:solidFill>
-            <a:srgbClr val="E05D5D"/>
-          </a:solidFill>
-          <a:ln>
-            <a:noFill/>
-          </a:ln>
-        </p:spPr>
-        <p:txBody>
-          <a:bodyPr rtlCol="0" anchor="ctr"/>
-          <a:lstStyle/>
-          <a:p>
-            <a:pPr algn="ctr"/>
-          </a:p>
-        </p:txBody>
-      </p:sp>
-      <p:sp>
-        <p:nvSpPr>
-          <p:cNvPr id="72" name="TextBox 71"/>
-          <p:cNvSpPr txBox="1"/>
-          <p:nvPr/>
-        </p:nvSpPr>
-        <p:spPr>
-          <a:xfrm>
-            <a:off x="3355848" y="4133087"/>
-            <a:ext cx="237744" cy="237744"/>
-          </a:xfrm>
-          <a:prstGeom prst="rect">
-            <a:avLst/>
-          </a:prstGeom>
-          <a:noFill/>
-        </p:spPr>
-        <p:txBody>
-          <a:bodyPr wrap="square" lIns="0" rIns="0" tIns="0" bIns="0" anchor="ctr">
-            <a:spAutoFit/>
-          </a:bodyPr>
-          <a:lstStyle/>
-          <a:p>
-            <a:pPr algn="ctr"/>
-            <a:r>
-              <a:rPr sz="1100" b="1" i="0">
-                <a:solidFill>
-                  <a:srgbClr val="EAF0F6"/>
-                </a:solidFill>
-                <a:latin typeface="Calibri"/>
-              </a:rPr>
-              <a:t>✗</a:t>
-            </a:r>
-          </a:p>
-        </p:txBody>
-      </p:sp>
-      <p:sp>
-        <p:nvSpPr>
-          <p:cNvPr id="73" name="TextBox 72"/>
-          <p:cNvSpPr txBox="1"/>
-          <p:nvPr/>
-        </p:nvSpPr>
-        <p:spPr>
-          <a:xfrm>
-            <a:off x="3703320" y="4059935"/>
-            <a:ext cx="3675888" cy="384048"/>
-          </a:xfrm>
-          <a:prstGeom prst="rect">
-            <a:avLst/>
-          </a:prstGeom>
-          <a:noFill/>
-        </p:spPr>
-        <p:txBody>
-          <a:bodyPr wrap="square" lIns="0" rIns="0" tIns="0" bIns="0" anchor="ctr">
-            <a:spAutoFit/>
-          </a:bodyPr>
-          <a:lstStyle/>
-          <a:p>
-            <a:pPr algn="l"/>
-            <a:r>
-              <a:rPr sz="1100" b="0" i="0">
-                <a:solidFill>
-                  <a:srgbClr val="9FB0C3"/>
-                </a:solidFill>
-                <a:latin typeface="Calibri"/>
-              </a:rPr>
-              <a:t>Extra connectors, wires, terminals, 3 PCBs</a:t>
-            </a:r>
-          </a:p>
-        </p:txBody>
-      </p:sp>
-      <p:sp>
-        <p:nvSpPr>
-          <p:cNvPr id="74" name="Oval 73"/>
-          <p:cNvSpPr/>
-          <p:nvPr/>
-        </p:nvSpPr>
-        <p:spPr>
-          <a:xfrm>
-            <a:off x="7580375" y="4133087"/>
-            <a:ext cx="237744" cy="237744"/>
-          </a:xfrm>
-          <a:prstGeom prst="ellipse">
-            <a:avLst/>
-          </a:prstGeom>
-          <a:solidFill>
-            <a:srgbClr val="3FA46A"/>
-          </a:solidFill>
-          <a:ln>
-            <a:noFill/>
-          </a:ln>
-        </p:spPr>
-        <p:txBody>
-          <a:bodyPr rtlCol="0" anchor="ctr"/>
-          <a:lstStyle/>
-          <a:p>
-            <a:pPr algn="ctr"/>
-          </a:p>
-        </p:txBody>
-      </p:sp>
-      <p:sp>
-        <p:nvSpPr>
-          <p:cNvPr id="75" name="TextBox 74"/>
-          <p:cNvSpPr txBox="1"/>
-          <p:nvPr/>
-        </p:nvSpPr>
-        <p:spPr>
-          <a:xfrm>
-            <a:off x="7580375" y="4133087"/>
-            <a:ext cx="237744" cy="237744"/>
-          </a:xfrm>
-          <a:prstGeom prst="rect">
-            <a:avLst/>
-          </a:prstGeom>
-          <a:noFill/>
-        </p:spPr>
-        <p:txBody>
-          <a:bodyPr wrap="square" lIns="0" rIns="0" tIns="0" bIns="0" anchor="ctr">
-            <a:spAutoFit/>
-          </a:bodyPr>
-          <a:lstStyle/>
-          <a:p>
-            <a:pPr algn="ctr"/>
-            <a:r>
-              <a:rPr sz="1100" b="1" i="0">
-                <a:solidFill>
-                  <a:srgbClr val="EAF0F6"/>
-                </a:solidFill>
-                <a:latin typeface="Calibri"/>
-              </a:rPr>
-              <a:t>✓</a:t>
-            </a:r>
-          </a:p>
-        </p:txBody>
-      </p:sp>
-      <p:sp>
-        <p:nvSpPr>
-          <p:cNvPr id="76" name="TextBox 75"/>
-          <p:cNvSpPr txBox="1"/>
-          <p:nvPr/>
-        </p:nvSpPr>
-        <p:spPr>
-          <a:xfrm>
-            <a:off x="7927848" y="4059935"/>
-            <a:ext cx="3712464" cy="384048"/>
-          </a:xfrm>
-          <a:prstGeom prst="rect">
-            <a:avLst/>
-          </a:prstGeom>
-          <a:noFill/>
-        </p:spPr>
-        <p:txBody>
-          <a:bodyPr wrap="square" lIns="0" rIns="0" tIns="0" bIns="0" anchor="ctr">
-            <a:spAutoFit/>
-          </a:bodyPr>
-          <a:lstStyle/>
-          <a:p>
-            <a:pPr algn="l"/>
-            <a:r>
-              <a:rPr sz="1100" b="0" i="0">
-                <a:solidFill>
-                  <a:srgbClr val="EAF0F6"/>
-                </a:solidFill>
-                <a:latin typeface="Calibri"/>
-              </a:rPr>
-              <a:t>One part number, single assembly step</a:t>
-            </a:r>
-          </a:p>
-        </p:txBody>
-      </p:sp>
-      <p:sp>
-        <p:nvSpPr>
-          <p:cNvPr id="77" name="Rectangle 76"/>
-          <p:cNvSpPr/>
-          <p:nvPr/>
-        </p:nvSpPr>
-        <p:spPr>
-          <a:xfrm>
-            <a:off x="457200" y="4443983"/>
-            <a:ext cx="11274552" cy="384048"/>
-          </a:xfrm>
-          <a:prstGeom prst="rect">
-            <a:avLst/>
-          </a:prstGeom>
-          <a:solidFill>
-            <a:srgbClr val="0E1621"/>
-          </a:solidFill>
-          <a:ln>
-            <a:noFill/>
-          </a:ln>
-        </p:spPr>
-        <p:txBody>
-          <a:bodyPr rtlCol="0" anchor="ctr"/>
-          <a:lstStyle/>
-          <a:p>
-            <a:pPr algn="ctr"/>
-          </a:p>
-        </p:txBody>
-      </p:sp>
-      <p:sp>
-        <p:nvSpPr>
-          <p:cNvPr id="78" name="TextBox 77"/>
-          <p:cNvSpPr txBox="1"/>
-          <p:nvPr/>
-        </p:nvSpPr>
-        <p:spPr>
-          <a:xfrm>
-            <a:off x="566928" y="4443983"/>
-            <a:ext cx="274320" cy="384048"/>
-          </a:xfrm>
-          <a:prstGeom prst="rect">
-            <a:avLst/>
-          </a:prstGeom>
-          <a:noFill/>
-        </p:spPr>
-        <p:txBody>
-          <a:bodyPr wrap="square" lIns="0" rIns="0" tIns="0" bIns="0" anchor="ctr">
-            <a:spAutoFit/>
-          </a:bodyPr>
-          <a:lstStyle/>
-          <a:p>
-            <a:pPr algn="l"/>
-            <a:r>
-              <a:rPr sz="1100" b="0" i="0">
-                <a:solidFill>
-                  <a:srgbClr val="9FB0C3"/>
-                </a:solidFill>
-                <a:latin typeface="Calibri"/>
-              </a:rPr>
-              <a:t>8</a:t>
-            </a:r>
-          </a:p>
-        </p:txBody>
-      </p:sp>
-      <p:sp>
-        <p:nvSpPr>
-          <p:cNvPr id="79" name="TextBox 78"/>
-          <p:cNvSpPr txBox="1"/>
-          <p:nvPr/>
-        </p:nvSpPr>
-        <p:spPr>
-          <a:xfrm>
-            <a:off x="978407" y="4443983"/>
-            <a:ext cx="2194560" cy="384048"/>
-          </a:xfrm>
-          <a:prstGeom prst="rect">
-            <a:avLst/>
-          </a:prstGeom>
-          <a:noFill/>
-        </p:spPr>
-        <p:txBody>
-          <a:bodyPr wrap="square" lIns="0" rIns="0" tIns="0" bIns="0" anchor="ctr">
-            <a:spAutoFit/>
-          </a:bodyPr>
-          <a:lstStyle/>
-          <a:p>
-            <a:pPr algn="l"/>
-            <a:r>
-              <a:rPr sz="1150" b="1" i="0">
-                <a:solidFill>
-                  <a:srgbClr val="EAF0F6"/>
-                </a:solidFill>
-                <a:latin typeface="Calibri"/>
-              </a:rPr>
-              <a:t>Panel utilization</a:t>
-            </a:r>
-          </a:p>
-        </p:txBody>
-      </p:sp>
-      <p:sp>
-        <p:nvSpPr>
-          <p:cNvPr id="80" name="Oval 79"/>
-          <p:cNvSpPr/>
-          <p:nvPr/>
-        </p:nvSpPr>
-        <p:spPr>
-          <a:xfrm>
-            <a:off x="3355848" y="4517136"/>
-            <a:ext cx="237744" cy="237744"/>
-          </a:xfrm>
-          <a:prstGeom prst="ellipse">
-            <a:avLst/>
-          </a:prstGeom>
-          <a:solidFill>
-            <a:srgbClr val="3FA46A"/>
-          </a:solidFill>
-          <a:ln>
-            <a:noFill/>
-          </a:ln>
-        </p:spPr>
-        <p:txBody>
-          <a:bodyPr rtlCol="0" anchor="ctr"/>
-          <a:lstStyle/>
-          <a:p>
-            <a:pPr algn="ctr"/>
-          </a:p>
-        </p:txBody>
-      </p:sp>
-      <p:sp>
-        <p:nvSpPr>
-          <p:cNvPr id="81" name="TextBox 80"/>
-          <p:cNvSpPr txBox="1"/>
-          <p:nvPr/>
-        </p:nvSpPr>
-        <p:spPr>
-          <a:xfrm>
-            <a:off x="3355848" y="4517136"/>
-            <a:ext cx="237744" cy="237744"/>
-          </a:xfrm>
-          <a:prstGeom prst="rect">
-            <a:avLst/>
-          </a:prstGeom>
-          <a:noFill/>
-        </p:spPr>
-        <p:txBody>
-          <a:bodyPr wrap="square" lIns="0" rIns="0" tIns="0" bIns="0" anchor="ctr">
-            <a:spAutoFit/>
-          </a:bodyPr>
-          <a:lstStyle/>
-          <a:p>
-            <a:pPr algn="ctr"/>
-            <a:r>
-              <a:rPr sz="1100" b="1" i="0">
-                <a:solidFill>
-                  <a:srgbClr val="EAF0F6"/>
-                </a:solidFill>
-                <a:latin typeface="Calibri"/>
-              </a:rPr>
-              <a:t>✓</a:t>
-            </a:r>
-          </a:p>
-        </p:txBody>
-      </p:sp>
-      <p:sp>
-        <p:nvSpPr>
-          <p:cNvPr id="82" name="TextBox 81"/>
-          <p:cNvSpPr txBox="1"/>
-          <p:nvPr/>
-        </p:nvSpPr>
-        <p:spPr>
-          <a:xfrm>
-            <a:off x="3703320" y="4443983"/>
-            <a:ext cx="3675888" cy="384048"/>
-          </a:xfrm>
-          <a:prstGeom prst="rect">
-            <a:avLst/>
-          </a:prstGeom>
-          <a:noFill/>
-        </p:spPr>
-        <p:txBody>
-          <a:bodyPr wrap="square" lIns="0" rIns="0" tIns="0" bIns="0" anchor="ctr">
-            <a:spAutoFit/>
-          </a:bodyPr>
-          <a:lstStyle/>
-          <a:p>
-            <a:pPr algn="l"/>
-            <a:r>
-              <a:rPr sz="1100" b="0" i="0">
-                <a:solidFill>
-                  <a:srgbClr val="EAF0F6"/>
-                </a:solidFill>
-                <a:latin typeface="Calibri"/>
-              </a:rPr>
-              <a:t>Small rectangular boards nest efficiently</a:t>
-            </a:r>
-          </a:p>
-        </p:txBody>
-      </p:sp>
-      <p:sp>
-        <p:nvSpPr>
-          <p:cNvPr id="83" name="Oval 82"/>
-          <p:cNvSpPr/>
-          <p:nvPr/>
-        </p:nvSpPr>
-        <p:spPr>
-          <a:xfrm>
-            <a:off x="7580375" y="4517136"/>
-            <a:ext cx="237744" cy="237744"/>
-          </a:xfrm>
-          <a:prstGeom prst="ellipse">
-            <a:avLst/>
-          </a:prstGeom>
-          <a:solidFill>
-            <a:srgbClr val="E05D5D"/>
-          </a:solidFill>
-          <a:ln>
-            <a:noFill/>
-          </a:ln>
-        </p:spPr>
-        <p:txBody>
-          <a:bodyPr rtlCol="0" anchor="ctr"/>
-          <a:lstStyle/>
-          <a:p>
-            <a:pPr algn="ctr"/>
-          </a:p>
-        </p:txBody>
-      </p:sp>
-      <p:sp>
-        <p:nvSpPr>
-          <p:cNvPr id="84" name="TextBox 83"/>
-          <p:cNvSpPr txBox="1"/>
-          <p:nvPr/>
-        </p:nvSpPr>
-        <p:spPr>
-          <a:xfrm>
-            <a:off x="7580375" y="4517136"/>
-            <a:ext cx="237744" cy="237744"/>
-          </a:xfrm>
-          <a:prstGeom prst="rect">
-            <a:avLst/>
-          </a:prstGeom>
-          <a:noFill/>
-        </p:spPr>
-        <p:txBody>
-          <a:bodyPr wrap="square" lIns="0" rIns="0" tIns="0" bIns="0" anchor="ctr">
-            <a:spAutoFit/>
-          </a:bodyPr>
-          <a:lstStyle/>
-          <a:p>
-            <a:pPr algn="ctr"/>
-            <a:r>
-              <a:rPr sz="1100" b="1" i="0">
-                <a:solidFill>
-                  <a:srgbClr val="EAF0F6"/>
-                </a:solidFill>
-                <a:latin typeface="Calibri"/>
-              </a:rPr>
-              <a:t>✗</a:t>
-            </a:r>
-          </a:p>
-        </p:txBody>
-      </p:sp>
-      <p:sp>
-        <p:nvSpPr>
-          <p:cNvPr id="85" name="TextBox 84"/>
-          <p:cNvSpPr txBox="1"/>
-          <p:nvPr/>
-        </p:nvSpPr>
-        <p:spPr>
-          <a:xfrm>
-            <a:off x="7927848" y="4443983"/>
-            <a:ext cx="3712464" cy="384048"/>
-          </a:xfrm>
-          <a:prstGeom prst="rect">
-            <a:avLst/>
-          </a:prstGeom>
-          <a:noFill/>
-        </p:spPr>
-        <p:txBody>
-          <a:bodyPr wrap="square" lIns="0" rIns="0" tIns="0" bIns="0" anchor="ctr">
-            <a:spAutoFit/>
-          </a:bodyPr>
-          <a:lstStyle/>
-          <a:p>
-            <a:pPr algn="l"/>
-            <a:r>
-              <a:rPr sz="1100" b="0" i="0">
-                <a:solidFill>
-                  <a:srgbClr val="9FB0C3"/>
-                </a:solidFill>
-                <a:latin typeface="Calibri"/>
-              </a:rPr>
-              <a:t>C-outline leaves unused panel area</a:t>
-            </a:r>
-          </a:p>
-        </p:txBody>
-      </p:sp>
-      <p:sp>
-        <p:nvSpPr>
-          <p:cNvPr id="86" name="Rectangle 85"/>
-          <p:cNvSpPr/>
-          <p:nvPr/>
-        </p:nvSpPr>
-        <p:spPr>
-          <a:xfrm>
-            <a:off x="457200" y="4828031"/>
-            <a:ext cx="11274552" cy="384048"/>
-          </a:xfrm>
-          <a:prstGeom prst="rect">
-            <a:avLst/>
-          </a:prstGeom>
-          <a:solidFill>
-            <a:srgbClr val="172331"/>
-          </a:solidFill>
-          <a:ln>
-            <a:noFill/>
-          </a:ln>
-        </p:spPr>
-        <p:txBody>
-          <a:bodyPr rtlCol="0" anchor="ctr"/>
-          <a:lstStyle/>
-          <a:p>
-            <a:pPr algn="ctr"/>
-          </a:p>
-        </p:txBody>
-      </p:sp>
-      <p:sp>
-        <p:nvSpPr>
-          <p:cNvPr id="87" name="TextBox 86"/>
-          <p:cNvSpPr txBox="1"/>
-          <p:nvPr/>
-        </p:nvSpPr>
-        <p:spPr>
-          <a:xfrm>
-            <a:off x="566928" y="4828031"/>
-            <a:ext cx="274320" cy="384048"/>
-          </a:xfrm>
-          <a:prstGeom prst="rect">
-            <a:avLst/>
-          </a:prstGeom>
-          <a:noFill/>
-        </p:spPr>
-        <p:txBody>
-          <a:bodyPr wrap="square" lIns="0" rIns="0" tIns="0" bIns="0" anchor="ctr">
-            <a:spAutoFit/>
-          </a:bodyPr>
-          <a:lstStyle/>
-          <a:p>
-            <a:pPr algn="l"/>
-            <a:r>
-              <a:rPr sz="1100" b="0" i="0">
-                <a:solidFill>
-                  <a:srgbClr val="9FB0C3"/>
-                </a:solidFill>
-                <a:latin typeface="Calibri"/>
-              </a:rPr>
-              <a:t>9</a:t>
-            </a:r>
-          </a:p>
-        </p:txBody>
-      </p:sp>
-      <p:sp>
-        <p:nvSpPr>
-          <p:cNvPr id="88" name="TextBox 87"/>
-          <p:cNvSpPr txBox="1"/>
-          <p:nvPr/>
-        </p:nvSpPr>
-        <p:spPr>
-          <a:xfrm>
-            <a:off x="978407" y="4828031"/>
-            <a:ext cx="2194560" cy="384048"/>
-          </a:xfrm>
-          <a:prstGeom prst="rect">
-            <a:avLst/>
-          </a:prstGeom>
-          <a:noFill/>
-        </p:spPr>
-        <p:txBody>
-          <a:bodyPr wrap="square" lIns="0" rIns="0" tIns="0" bIns="0" anchor="ctr">
-            <a:spAutoFit/>
-          </a:bodyPr>
-          <a:lstStyle/>
-          <a:p>
-            <a:pPr algn="l"/>
-            <a:r>
-              <a:rPr sz="1150" b="1" i="0">
-                <a:solidFill>
-                  <a:srgbClr val="EAF0F6"/>
-                </a:solidFill>
-                <a:latin typeface="Calibri"/>
-              </a:rPr>
-              <a:t>Warpage &amp; depaneling ★</a:t>
-            </a:r>
-          </a:p>
-        </p:txBody>
-      </p:sp>
-      <p:sp>
-        <p:nvSpPr>
-          <p:cNvPr id="89" name="Oval 88"/>
-          <p:cNvSpPr/>
-          <p:nvPr/>
-        </p:nvSpPr>
-        <p:spPr>
-          <a:xfrm>
-            <a:off x="3355848" y="4901183"/>
-            <a:ext cx="237744" cy="237744"/>
-          </a:xfrm>
-          <a:prstGeom prst="ellipse">
-            <a:avLst/>
-          </a:prstGeom>
-          <a:solidFill>
-            <a:srgbClr val="3FA46A"/>
-          </a:solidFill>
-          <a:ln>
-            <a:noFill/>
-          </a:ln>
-        </p:spPr>
-        <p:txBody>
-          <a:bodyPr rtlCol="0" anchor="ctr"/>
-          <a:lstStyle/>
-          <a:p>
-            <a:pPr algn="ctr"/>
-          </a:p>
-        </p:txBody>
-      </p:sp>
-      <p:sp>
-        <p:nvSpPr>
-          <p:cNvPr id="90" name="TextBox 89"/>
-          <p:cNvSpPr txBox="1"/>
-          <p:nvPr/>
-        </p:nvSpPr>
-        <p:spPr>
-          <a:xfrm>
-            <a:off x="3355848" y="4901183"/>
-            <a:ext cx="237744" cy="237744"/>
-          </a:xfrm>
-          <a:prstGeom prst="rect">
-            <a:avLst/>
-          </a:prstGeom>
-          <a:noFill/>
-        </p:spPr>
-        <p:txBody>
-          <a:bodyPr wrap="square" lIns="0" rIns="0" tIns="0" bIns="0" anchor="ctr">
-            <a:spAutoFit/>
-          </a:bodyPr>
-          <a:lstStyle/>
-          <a:p>
-            <a:pPr algn="ctr"/>
-            <a:r>
-              <a:rPr sz="1100" b="1" i="0">
-                <a:solidFill>
-                  <a:srgbClr val="EAF0F6"/>
-                </a:solidFill>
-                <a:latin typeface="Calibri"/>
-              </a:rPr>
-              <a:t>✓</a:t>
-            </a:r>
-          </a:p>
-        </p:txBody>
-      </p:sp>
-      <p:sp>
-        <p:nvSpPr>
-          <p:cNvPr id="91" name="TextBox 90"/>
-          <p:cNvSpPr txBox="1"/>
-          <p:nvPr/>
-        </p:nvSpPr>
-        <p:spPr>
-          <a:xfrm>
-            <a:off x="3703320" y="4828031"/>
-            <a:ext cx="3675888" cy="384048"/>
-          </a:xfrm>
-          <a:prstGeom prst="rect">
-            <a:avLst/>
-          </a:prstGeom>
-          <a:noFill/>
-        </p:spPr>
-        <p:txBody>
-          <a:bodyPr wrap="square" lIns="0" rIns="0" tIns="0" bIns="0" anchor="ctr">
-            <a:spAutoFit/>
-          </a:bodyPr>
-          <a:lstStyle/>
-          <a:p>
-            <a:pPr algn="l"/>
-            <a:r>
-              <a:rPr sz="1100" b="0" i="0">
-                <a:solidFill>
-                  <a:srgbClr val="EAF0F6"/>
-                </a:solidFill>
-                <a:latin typeface="Calibri"/>
-              </a:rPr>
-              <a:t>Short boards stay flat; low joint stress</a:t>
-            </a:r>
-          </a:p>
-        </p:txBody>
-      </p:sp>
-      <p:sp>
-        <p:nvSpPr>
-          <p:cNvPr id="92" name="Oval 91"/>
-          <p:cNvSpPr/>
-          <p:nvPr/>
-        </p:nvSpPr>
-        <p:spPr>
-          <a:xfrm>
-            <a:off x="7580375" y="4901183"/>
-            <a:ext cx="237744" cy="237744"/>
-          </a:xfrm>
-          <a:prstGeom prst="ellipse">
-            <a:avLst/>
-          </a:prstGeom>
-          <a:solidFill>
-            <a:srgbClr val="E05D5D"/>
-          </a:solidFill>
-          <a:ln>
-            <a:noFill/>
-          </a:ln>
-        </p:spPr>
-        <p:txBody>
-          <a:bodyPr rtlCol="0" anchor="ctr"/>
-          <a:lstStyle/>
-          <a:p>
-            <a:pPr algn="ctr"/>
-          </a:p>
-        </p:txBody>
-      </p:sp>
-      <p:sp>
-        <p:nvSpPr>
-          <p:cNvPr id="93" name="TextBox 92"/>
-          <p:cNvSpPr txBox="1"/>
-          <p:nvPr/>
-        </p:nvSpPr>
-        <p:spPr>
-          <a:xfrm>
-            <a:off x="7580375" y="4901183"/>
-            <a:ext cx="237744" cy="237744"/>
-          </a:xfrm>
-          <a:prstGeom prst="rect">
-            <a:avLst/>
-          </a:prstGeom>
-          <a:noFill/>
-        </p:spPr>
-        <p:txBody>
-          <a:bodyPr wrap="square" lIns="0" rIns="0" tIns="0" bIns="0" anchor="ctr">
-            <a:spAutoFit/>
-          </a:bodyPr>
-          <a:lstStyle/>
-          <a:p>
-            <a:pPr algn="ctr"/>
-            <a:r>
-              <a:rPr sz="1100" b="1" i="0">
-                <a:solidFill>
-                  <a:srgbClr val="EAF0F6"/>
-                </a:solidFill>
-                <a:latin typeface="Calibri"/>
-              </a:rPr>
-              <a:t>✗</a:t>
-            </a:r>
-          </a:p>
-        </p:txBody>
-      </p:sp>
-      <p:sp>
-        <p:nvSpPr>
-          <p:cNvPr id="94" name="TextBox 93"/>
-          <p:cNvSpPr txBox="1"/>
-          <p:nvPr/>
-        </p:nvSpPr>
-        <p:spPr>
-          <a:xfrm>
-            <a:off x="7927848" y="4828031"/>
-            <a:ext cx="3712464" cy="384048"/>
-          </a:xfrm>
-          <a:prstGeom prst="rect">
-            <a:avLst/>
-          </a:prstGeom>
-          <a:noFill/>
-        </p:spPr>
-        <p:txBody>
-          <a:bodyPr wrap="square" lIns="0" rIns="0" tIns="0" bIns="0" anchor="ctr">
-            <a:spAutoFit/>
-          </a:bodyPr>
-          <a:lstStyle/>
-          <a:p>
-            <a:pPr algn="l"/>
-            <a:r>
-              <a:rPr sz="1100" b="0" i="0">
-                <a:solidFill>
-                  <a:srgbClr val="9FB0C3"/>
-                </a:solidFill>
-                <a:latin typeface="Calibri"/>
-              </a:rPr>
-              <a:t>Long C-shape can warp, stressing LED joints</a:t>
-            </a:r>
-          </a:p>
-        </p:txBody>
-      </p:sp>
-      <p:sp>
-        <p:nvSpPr>
-          <p:cNvPr id="95" name="Rectangle 94"/>
-          <p:cNvSpPr/>
-          <p:nvPr/>
-        </p:nvSpPr>
-        <p:spPr>
-          <a:xfrm>
-            <a:off x="457200" y="5212079"/>
-            <a:ext cx="11274552" cy="384048"/>
-          </a:xfrm>
-          <a:prstGeom prst="rect">
-            <a:avLst/>
-          </a:prstGeom>
-          <a:solidFill>
-            <a:srgbClr val="0E1621"/>
-          </a:solidFill>
-          <a:ln>
-            <a:noFill/>
-          </a:ln>
-        </p:spPr>
-        <p:txBody>
-          <a:bodyPr rtlCol="0" anchor="ctr"/>
-          <a:lstStyle/>
-          <a:p>
-            <a:pPr algn="ctr"/>
-          </a:p>
-        </p:txBody>
-      </p:sp>
-      <p:sp>
-        <p:nvSpPr>
-          <p:cNvPr id="96" name="TextBox 95"/>
-          <p:cNvSpPr txBox="1"/>
-          <p:nvPr/>
-        </p:nvSpPr>
-        <p:spPr>
-          <a:xfrm>
-            <a:off x="566928" y="5212079"/>
-            <a:ext cx="274320" cy="384048"/>
-          </a:xfrm>
-          <a:prstGeom prst="rect">
-            <a:avLst/>
-          </a:prstGeom>
-          <a:noFill/>
-        </p:spPr>
-        <p:txBody>
-          <a:bodyPr wrap="square" lIns="0" rIns="0" tIns="0" bIns="0" anchor="ctr">
-            <a:spAutoFit/>
-          </a:bodyPr>
-          <a:lstStyle/>
-          <a:p>
-            <a:pPr algn="l"/>
-            <a:r>
-              <a:rPr sz="1100" b="0" i="0">
-                <a:solidFill>
-                  <a:srgbClr val="9FB0C3"/>
-                </a:solidFill>
-                <a:latin typeface="Calibri"/>
-              </a:rPr>
-              <a:t>10</a:t>
-            </a:r>
-          </a:p>
-        </p:txBody>
-      </p:sp>
-      <p:sp>
-        <p:nvSpPr>
-          <p:cNvPr id="97" name="TextBox 96"/>
-          <p:cNvSpPr txBox="1"/>
-          <p:nvPr/>
-        </p:nvSpPr>
-        <p:spPr>
-          <a:xfrm>
-            <a:off x="978407" y="5212079"/>
-            <a:ext cx="2194560" cy="384048"/>
-          </a:xfrm>
-          <a:prstGeom prst="rect">
-            <a:avLst/>
-          </a:prstGeom>
-          <a:noFill/>
-        </p:spPr>
-        <p:txBody>
-          <a:bodyPr wrap="square" lIns="0" rIns="0" tIns="0" bIns="0" anchor="ctr">
-            <a:spAutoFit/>
-          </a:bodyPr>
-          <a:lstStyle/>
-          <a:p>
-            <a:pPr algn="l"/>
-            <a:r>
-              <a:rPr sz="1150" b="1" i="0">
-                <a:solidFill>
-                  <a:srgbClr val="EAF0F6"/>
-                </a:solidFill>
-                <a:latin typeface="Calibri"/>
-              </a:rPr>
-              <a:t>Mechanical fit &amp; service</a:t>
-            </a:r>
-          </a:p>
-        </p:txBody>
-      </p:sp>
-      <p:sp>
-        <p:nvSpPr>
-          <p:cNvPr id="98" name="Oval 97"/>
-          <p:cNvSpPr/>
-          <p:nvPr/>
-        </p:nvSpPr>
-        <p:spPr>
-          <a:xfrm>
-            <a:off x="3355848" y="5285231"/>
-            <a:ext cx="237744" cy="237744"/>
-          </a:xfrm>
-          <a:prstGeom prst="ellipse">
-            <a:avLst/>
-          </a:prstGeom>
-          <a:solidFill>
-            <a:srgbClr val="3FA46A"/>
-          </a:solidFill>
-          <a:ln>
-            <a:noFill/>
-          </a:ln>
-        </p:spPr>
-        <p:txBody>
-          <a:bodyPr rtlCol="0" anchor="ctr"/>
-          <a:lstStyle/>
-          <a:p>
-            <a:pPr algn="ctr"/>
-          </a:p>
-        </p:txBody>
-      </p:sp>
-      <p:sp>
-        <p:nvSpPr>
-          <p:cNvPr id="99" name="TextBox 98"/>
-          <p:cNvSpPr txBox="1"/>
-          <p:nvPr/>
-        </p:nvSpPr>
-        <p:spPr>
-          <a:xfrm>
-            <a:off x="3355848" y="5285231"/>
-            <a:ext cx="237744" cy="237744"/>
-          </a:xfrm>
-          <a:prstGeom prst="rect">
-            <a:avLst/>
-          </a:prstGeom>
-          <a:noFill/>
-        </p:spPr>
-        <p:txBody>
-          <a:bodyPr wrap="square" lIns="0" rIns="0" tIns="0" bIns="0" anchor="ctr">
-            <a:spAutoFit/>
-          </a:bodyPr>
-          <a:lstStyle/>
-          <a:p>
-            <a:pPr algn="ctr"/>
-            <a:r>
-              <a:rPr sz="1100" b="1" i="0">
-                <a:solidFill>
-                  <a:srgbClr val="EAF0F6"/>
-                </a:solidFill>
-                <a:latin typeface="Calibri"/>
-              </a:rPr>
-              <a:t>✓</a:t>
-            </a:r>
-          </a:p>
-        </p:txBody>
-      </p:sp>
-      <p:sp>
-        <p:nvSpPr>
-          <p:cNvPr id="100" name="TextBox 99"/>
-          <p:cNvSpPr txBox="1"/>
-          <p:nvPr/>
-        </p:nvSpPr>
-        <p:spPr>
-          <a:xfrm>
-            <a:off x="3703320" y="5212079"/>
-            <a:ext cx="3675888" cy="384048"/>
-          </a:xfrm>
-          <a:prstGeom prst="rect">
-            <a:avLst/>
-          </a:prstGeom>
-          <a:noFill/>
-        </p:spPr>
-        <p:txBody>
-          <a:bodyPr wrap="square" lIns="0" rIns="0" tIns="0" bIns="0" anchor="ctr">
-            <a:spAutoFit/>
-          </a:bodyPr>
-          <a:lstStyle/>
-          <a:p>
-            <a:pPr algn="l"/>
-            <a:r>
-              <a:rPr sz="1100" b="0" i="0">
-                <a:solidFill>
-                  <a:srgbClr val="EAF0F6"/>
-                </a:solidFill>
-                <a:latin typeface="Calibri"/>
-              </a:rPr>
-              <a:t>Boards placed and replaced independently</a:t>
-            </a:r>
-          </a:p>
-        </p:txBody>
-      </p:sp>
-      <p:sp>
-        <p:nvSpPr>
-          <p:cNvPr id="101" name="Oval 100"/>
-          <p:cNvSpPr/>
-          <p:nvPr/>
-        </p:nvSpPr>
-        <p:spPr>
-          <a:xfrm>
-            <a:off x="7580375" y="5285231"/>
-            <a:ext cx="237744" cy="237744"/>
-          </a:xfrm>
-          <a:prstGeom prst="ellipse">
-            <a:avLst/>
-          </a:prstGeom>
-          <a:solidFill>
-            <a:srgbClr val="E05D5D"/>
-          </a:solidFill>
-          <a:ln>
-            <a:noFill/>
-          </a:ln>
-        </p:spPr>
-        <p:txBody>
-          <a:bodyPr rtlCol="0" anchor="ctr"/>
-          <a:lstStyle/>
-          <a:p>
-            <a:pPr algn="ctr"/>
-          </a:p>
-        </p:txBody>
-      </p:sp>
-      <p:sp>
-        <p:nvSpPr>
-          <p:cNvPr id="102" name="TextBox 101"/>
-          <p:cNvSpPr txBox="1"/>
-          <p:nvPr/>
-        </p:nvSpPr>
-        <p:spPr>
-          <a:xfrm>
-            <a:off x="7580375" y="5285231"/>
-            <a:ext cx="237744" cy="237744"/>
-          </a:xfrm>
-          <a:prstGeom prst="rect">
-            <a:avLst/>
-          </a:prstGeom>
-          <a:noFill/>
-        </p:spPr>
-        <p:txBody>
-          <a:bodyPr wrap="square" lIns="0" rIns="0" tIns="0" bIns="0" anchor="ctr">
-            <a:spAutoFit/>
-          </a:bodyPr>
-          <a:lstStyle/>
-          <a:p>
-            <a:pPr algn="ctr"/>
-            <a:r>
-              <a:rPr sz="1100" b="1" i="0">
-                <a:solidFill>
-                  <a:srgbClr val="EAF0F6"/>
-                </a:solidFill>
-                <a:latin typeface="Calibri"/>
-              </a:rPr>
-              <a:t>✗</a:t>
-            </a:r>
-          </a:p>
-        </p:txBody>
-      </p:sp>
-      <p:sp>
-        <p:nvSpPr>
-          <p:cNvPr id="103" name="TextBox 102"/>
-          <p:cNvSpPr txBox="1"/>
-          <p:nvPr/>
-        </p:nvSpPr>
-        <p:spPr>
-          <a:xfrm>
-            <a:off x="7927848" y="5212079"/>
-            <a:ext cx="3712464" cy="384048"/>
-          </a:xfrm>
-          <a:prstGeom prst="rect">
-            <a:avLst/>
-          </a:prstGeom>
-          <a:noFill/>
-        </p:spPr>
-        <p:txBody>
-          <a:bodyPr wrap="square" lIns="0" rIns="0" tIns="0" bIns="0" anchor="ctr">
-            <a:spAutoFit/>
-          </a:bodyPr>
-          <a:lstStyle/>
-          <a:p>
-            <a:pPr algn="l"/>
-            <a:r>
-              <a:rPr sz="1100" b="0" i="0">
-                <a:solidFill>
-                  <a:srgbClr val="9FB0C3"/>
-                </a:solidFill>
-                <a:latin typeface="Calibri"/>
-              </a:rPr>
-              <a:t>Whole C must meet the housing tolerance</a:t>
-            </a:r>
-          </a:p>
-        </p:txBody>
-      </p:sp>
-      <p:sp>
-        <p:nvSpPr>
-          <p:cNvPr id="104" name="Rounded Rectangle 103"/>
-          <p:cNvSpPr/>
-          <p:nvPr/>
-        </p:nvSpPr>
-        <p:spPr>
-          <a:xfrm>
-            <a:off x="457200" y="5760720"/>
-            <a:ext cx="11274552" cy="731519"/>
-          </a:xfrm>
-          <a:prstGeom prst="roundRect">
-            <a:avLst>
-              <a:gd name="adj" fmla="val 12000"/>
-            </a:avLst>
-          </a:prstGeom>
-          <a:solidFill>
-            <a:srgbClr val="1D2B3B"/>
-          </a:solidFill>
-          <a:ln w="15875">
-            <a:solidFill>
-              <a:srgbClr val="3FA46A"/>
-            </a:solidFill>
-          </a:ln>
-        </p:spPr>
-        <p:txBody>
-          <a:bodyPr rtlCol="0" anchor="ctr"/>
-          <a:lstStyle/>
-          <a:p>
-            <a:pPr algn="ctr"/>
-          </a:p>
-        </p:txBody>
-      </p:sp>
-      <p:sp>
-        <p:nvSpPr>
-          <p:cNvPr id="105" name="TextBox 104"/>
-          <p:cNvSpPr txBox="1"/>
-          <p:nvPr/>
-        </p:nvSpPr>
-        <p:spPr>
-          <a:xfrm>
-            <a:off x="685800" y="5760720"/>
-            <a:ext cx="3108960" cy="731519"/>
-          </a:xfrm>
-          <a:prstGeom prst="rect">
-            <a:avLst/>
-          </a:prstGeom>
-          <a:noFill/>
-        </p:spPr>
-        <p:txBody>
-          <a:bodyPr wrap="square" lIns="0" rIns="0" tIns="0" bIns="0" anchor="ctr">
-            <a:spAutoFit/>
-          </a:bodyPr>
-          <a:lstStyle/>
-          <a:p>
-            <a:pPr algn="l"/>
-            <a:r>
-              <a:rPr sz="1100" b="0" i="0">
-                <a:solidFill>
-                  <a:srgbClr val="9FB0C3"/>
-                </a:solidFill>
-                <a:latin typeface="Calibri"/>
-              </a:rPr>
-              <a:t>Best overall</a:t>
-            </a:r>
-          </a:p>
-          <a:p>
-            <a:pPr algn="l"/>
-            <a:r>
-              <a:rPr sz="1700" b="1" i="0">
-                <a:solidFill>
-                  <a:srgbClr val="FFD34D"/>
-                </a:solidFill>
-                <a:latin typeface="Calibri"/>
-              </a:rPr>
-              <a:t>Single C-Shape PCB</a:t>
-            </a:r>
-          </a:p>
-        </p:txBody>
-      </p:sp>
-      <p:sp>
-        <p:nvSpPr>
-          <p:cNvPr id="106" name="TextBox 105"/>
-          <p:cNvSpPr txBox="1"/>
-          <p:nvPr/>
-        </p:nvSpPr>
-        <p:spPr>
-          <a:xfrm>
-            <a:off x="3840480" y="5760720"/>
-            <a:ext cx="7680960" cy="731519"/>
-          </a:xfrm>
-          <a:prstGeom prst="rect">
-            <a:avLst/>
-          </a:prstGeom>
-          <a:noFill/>
-        </p:spPr>
-        <p:txBody>
-          <a:bodyPr wrap="square" lIns="0" rIns="0" tIns="0" bIns="0" anchor="ctr">
-            <a:spAutoFit/>
-          </a:bodyPr>
-          <a:lstStyle/>
-          <a:p>
-            <a:pPr algn="l"/>
-            <a:r>
-              <a:rPr sz="1100" b="0" i="0">
-                <a:solidFill>
-                  <a:srgbClr val="EAF0F6"/>
-                </a:solidFill>
-                <a:latin typeface="Calibri"/>
-              </a:rPr>
-              <a:t>Wins 7 of 10, including every EMC criterion: removing the inter-board harness removes the main emission, immunity and reliability risk. Pick the 3-PCB split only when panel cost or housing tolerance dominates, and then use flex jumpers with common-mode filtering at each interface.</a:t>
+              <a:t> (7 of 10 parameters, including all EMC parameters)</a:t>
             </a:r>
           </a:p>
         </p:txBody>

</xml_diff>